<commit_message>
Add mobile-responsive UI with live market price integration
- Created gramsetu-mobile.html with mobile-first design
- Added bottom navigation with Photo and Clear buttons for easy thumb access
- Implemented 3x2 agent card grid for mobile devices
- Integrated live market price data from data.gov.in API
- Added supervisor_simple_with_prices wrapper for price queries
- Updated Lambda handler to use supervisor_simple_with_prices
- Deployed both desktop and mobile UIs to S3/CloudFront
- All features tested and working on AWS
</commit_message>
<xml_diff>
--- a/Prototype Development Submission _ AWS AI for Bharat Hackathon.pptx
+++ b/Prototype Development Submission _ AWS AI for Bharat Hackathon.pptx
@@ -1,51 +1,51 @@
 
 <file path=ppt/presentation.xml><?xml version="1.0" encoding="utf-8"?>
-<p:presentation xmlns:a="http://schemas.openxmlformats.org/drawingml/2006/main" xmlns:r="http://schemas.openxmlformats.org/officeDocument/2006/relationships" xmlns:mc="http://schemas.openxmlformats.org/markup-compatibility/2006" xmlns:mv="urn:schemas-microsoft-com:mac:vml" xmlns:p="http://schemas.openxmlformats.org/presentationml/2006/main" xmlns:c="http://schemas.openxmlformats.org/drawingml/2006/chart" xmlns:dgm="http://schemas.openxmlformats.org/drawingml/2006/diagram" xmlns:o="urn:schemas-microsoft-com:office:office" xmlns:v="urn:schemas-microsoft-com:vml" xmlns:pvml="urn:schemas-microsoft-com:office:powerpoint" xmlns:com="http://schemas.openxmlformats.org/drawingml/2006/compatibility" xmlns:p14="http://schemas.microsoft.com/office/powerpoint/2010/main" xmlns:p15="http://schemas.microsoft.com/office/powerpoint/2012/main" xmlns:ahyp="http://schemas.microsoft.com/office/drawing/2018/hyperlinkcolor" autoCompressPictures="0" embedTrueTypeFonts="1" strictFirstAndLastChars="0" saveSubsetFonts="1">
+<p:presentation xmlns:a="http://schemas.openxmlformats.org/drawingml/2006/main" xmlns:r="http://schemas.openxmlformats.org/officeDocument/2006/relationships" xmlns:p="http://schemas.openxmlformats.org/presentationml/2006/main" strictFirstAndLastChars="0" embedTrueTypeFonts="1" saveSubsetFonts="1" autoCompressPictures="0">
   <p:sldMasterIdLst>
-    <p:sldMasterId id="2147483659" r:id="rId4"/>
+    <p:sldMasterId id="2147483659" r:id="rId1"/>
   </p:sldMasterIdLst>
   <p:notesMasterIdLst>
-    <p:notesMasterId r:id="rId5"/>
+    <p:notesMasterId r:id="rId16"/>
   </p:notesMasterIdLst>
   <p:sldIdLst>
-    <p:sldId id="256" r:id="rId6"/>
-    <p:sldId id="257" r:id="rId7"/>
-    <p:sldId id="258" r:id="rId8"/>
-    <p:sldId id="259" r:id="rId9"/>
-    <p:sldId id="260" r:id="rId10"/>
-    <p:sldId id="261" r:id="rId11"/>
-    <p:sldId id="262" r:id="rId12"/>
-    <p:sldId id="263" r:id="rId13"/>
-    <p:sldId id="264" r:id="rId14"/>
-    <p:sldId id="265" r:id="rId15"/>
-    <p:sldId id="266" r:id="rId16"/>
-    <p:sldId id="267" r:id="rId17"/>
-    <p:sldId id="268" r:id="rId18"/>
-    <p:sldId id="269" r:id="rId19"/>
+    <p:sldId id="256" r:id="rId2"/>
+    <p:sldId id="257" r:id="rId3"/>
+    <p:sldId id="258" r:id="rId4"/>
+    <p:sldId id="259" r:id="rId5"/>
+    <p:sldId id="260" r:id="rId6"/>
+    <p:sldId id="261" r:id="rId7"/>
+    <p:sldId id="262" r:id="rId8"/>
+    <p:sldId id="263" r:id="rId9"/>
+    <p:sldId id="264" r:id="rId10"/>
+    <p:sldId id="265" r:id="rId11"/>
+    <p:sldId id="266" r:id="rId12"/>
+    <p:sldId id="267" r:id="rId13"/>
+    <p:sldId id="268" r:id="rId14"/>
+    <p:sldId id="269" r:id="rId15"/>
   </p:sldIdLst>
-  <p:sldSz cy="5143500" cx="9144000"/>
+  <p:sldSz cx="9144000" cy="5143500" type="screen16x9"/>
   <p:notesSz cx="6858000" cy="9144000"/>
   <p:embeddedFontLst>
     <p:embeddedFont>
-      <p:font typeface="Manrope SemiBold"/>
-      <p:regular r:id="rId20"/>
-      <p:bold r:id="rId21"/>
+      <p:font typeface="Manrope" panose="020B0604020202020204" charset="0"/>
+      <p:regular r:id="rId17"/>
+      <p:bold r:id="rId18"/>
     </p:embeddedFont>
     <p:embeddedFont>
-      <p:font typeface="Poppins"/>
-      <p:regular r:id="rId22"/>
-      <p:bold r:id="rId23"/>
-      <p:italic r:id="rId24"/>
-      <p:boldItalic r:id="rId25"/>
+      <p:font typeface="Manrope SemiBold" panose="020B0604020202020204" charset="0"/>
+      <p:regular r:id="rId19"/>
+      <p:bold r:id="rId20"/>
     </p:embeddedFont>
     <p:embeddedFont>
-      <p:font typeface="Manrope"/>
-      <p:regular r:id="rId26"/>
-      <p:bold r:id="rId27"/>
+      <p:font typeface="Poppins" panose="020B0502040204020203" pitchFamily="2" charset="0"/>
+      <p:regular r:id="rId21"/>
+      <p:bold r:id="rId22"/>
+      <p:italic r:id="rId23"/>
+      <p:boldItalic r:id="rId24"/>
     </p:embeddedFont>
   </p:embeddedFontLst>
   <p:defaultTextStyle>
-    <a:defPPr lvl="0" marR="0" rtl="0" algn="l">
+    <a:defPPr marR="0" lvl="0" algn="l" rtl="0">
       <a:lnSpc>
         <a:spcPct val="100000"/>
       </a:lnSpc>
@@ -56,7 +56,7 @@
         <a:spcPts val="0"/>
       </a:spcAft>
     </a:defPPr>
-    <a:lvl1pPr lvl="0" marR="0" rtl="0" algn="l">
+    <a:lvl1pPr marR="0" lvl="0" algn="l" rtl="0">
       <a:lnSpc>
         <a:spcPct val="100000"/>
       </a:lnSpc>
@@ -70,7 +70,7 @@
         <a:srgbClr val="000000"/>
       </a:buClr>
       <a:buFont typeface="Arial"/>
-      <a:defRPr b="0" i="0" sz="1400" u="none" cap="none" strike="noStrike">
+      <a:defRPr sz="1400" b="0" i="0" u="none" strike="noStrike" cap="none">
         <a:solidFill>
           <a:srgbClr val="000000"/>
         </a:solidFill>
@@ -80,7 +80,7 @@
         <a:sym typeface="Arial"/>
       </a:defRPr>
     </a:lvl1pPr>
-    <a:lvl2pPr lvl="1" marR="0" rtl="0" algn="l">
+    <a:lvl2pPr marR="0" lvl="1" algn="l" rtl="0">
       <a:lnSpc>
         <a:spcPct val="100000"/>
       </a:lnSpc>
@@ -94,7 +94,7 @@
         <a:srgbClr val="000000"/>
       </a:buClr>
       <a:buFont typeface="Arial"/>
-      <a:defRPr b="0" i="0" sz="1400" u="none" cap="none" strike="noStrike">
+      <a:defRPr sz="1400" b="0" i="0" u="none" strike="noStrike" cap="none">
         <a:solidFill>
           <a:srgbClr val="000000"/>
         </a:solidFill>
@@ -104,7 +104,7 @@
         <a:sym typeface="Arial"/>
       </a:defRPr>
     </a:lvl2pPr>
-    <a:lvl3pPr lvl="2" marR="0" rtl="0" algn="l">
+    <a:lvl3pPr marR="0" lvl="2" algn="l" rtl="0">
       <a:lnSpc>
         <a:spcPct val="100000"/>
       </a:lnSpc>
@@ -118,7 +118,7 @@
         <a:srgbClr val="000000"/>
       </a:buClr>
       <a:buFont typeface="Arial"/>
-      <a:defRPr b="0" i="0" sz="1400" u="none" cap="none" strike="noStrike">
+      <a:defRPr sz="1400" b="0" i="0" u="none" strike="noStrike" cap="none">
         <a:solidFill>
           <a:srgbClr val="000000"/>
         </a:solidFill>
@@ -128,7 +128,7 @@
         <a:sym typeface="Arial"/>
       </a:defRPr>
     </a:lvl3pPr>
-    <a:lvl4pPr lvl="3" marR="0" rtl="0" algn="l">
+    <a:lvl4pPr marR="0" lvl="3" algn="l" rtl="0">
       <a:lnSpc>
         <a:spcPct val="100000"/>
       </a:lnSpc>
@@ -142,7 +142,7 @@
         <a:srgbClr val="000000"/>
       </a:buClr>
       <a:buFont typeface="Arial"/>
-      <a:defRPr b="0" i="0" sz="1400" u="none" cap="none" strike="noStrike">
+      <a:defRPr sz="1400" b="0" i="0" u="none" strike="noStrike" cap="none">
         <a:solidFill>
           <a:srgbClr val="000000"/>
         </a:solidFill>
@@ -152,7 +152,7 @@
         <a:sym typeface="Arial"/>
       </a:defRPr>
     </a:lvl4pPr>
-    <a:lvl5pPr lvl="4" marR="0" rtl="0" algn="l">
+    <a:lvl5pPr marR="0" lvl="4" algn="l" rtl="0">
       <a:lnSpc>
         <a:spcPct val="100000"/>
       </a:lnSpc>
@@ -166,7 +166,7 @@
         <a:srgbClr val="000000"/>
       </a:buClr>
       <a:buFont typeface="Arial"/>
-      <a:defRPr b="0" i="0" sz="1400" u="none" cap="none" strike="noStrike">
+      <a:defRPr sz="1400" b="0" i="0" u="none" strike="noStrike" cap="none">
         <a:solidFill>
           <a:srgbClr val="000000"/>
         </a:solidFill>
@@ -176,7 +176,7 @@
         <a:sym typeface="Arial"/>
       </a:defRPr>
     </a:lvl5pPr>
-    <a:lvl6pPr lvl="5" marR="0" rtl="0" algn="l">
+    <a:lvl6pPr marR="0" lvl="5" algn="l" rtl="0">
       <a:lnSpc>
         <a:spcPct val="100000"/>
       </a:lnSpc>
@@ -190,7 +190,7 @@
         <a:srgbClr val="000000"/>
       </a:buClr>
       <a:buFont typeface="Arial"/>
-      <a:defRPr b="0" i="0" sz="1400" u="none" cap="none" strike="noStrike">
+      <a:defRPr sz="1400" b="0" i="0" u="none" strike="noStrike" cap="none">
         <a:solidFill>
           <a:srgbClr val="000000"/>
         </a:solidFill>
@@ -200,7 +200,7 @@
         <a:sym typeface="Arial"/>
       </a:defRPr>
     </a:lvl6pPr>
-    <a:lvl7pPr lvl="6" marR="0" rtl="0" algn="l">
+    <a:lvl7pPr marR="0" lvl="6" algn="l" rtl="0">
       <a:lnSpc>
         <a:spcPct val="100000"/>
       </a:lnSpc>
@@ -214,7 +214,7 @@
         <a:srgbClr val="000000"/>
       </a:buClr>
       <a:buFont typeface="Arial"/>
-      <a:defRPr b="0" i="0" sz="1400" u="none" cap="none" strike="noStrike">
+      <a:defRPr sz="1400" b="0" i="0" u="none" strike="noStrike" cap="none">
         <a:solidFill>
           <a:srgbClr val="000000"/>
         </a:solidFill>
@@ -224,7 +224,7 @@
         <a:sym typeface="Arial"/>
       </a:defRPr>
     </a:lvl7pPr>
-    <a:lvl8pPr lvl="7" marR="0" rtl="0" algn="l">
+    <a:lvl8pPr marR="0" lvl="7" algn="l" rtl="0">
       <a:lnSpc>
         <a:spcPct val="100000"/>
       </a:lnSpc>
@@ -238,7 +238,7 @@
         <a:srgbClr val="000000"/>
       </a:buClr>
       <a:buFont typeface="Arial"/>
-      <a:defRPr b="0" i="0" sz="1400" u="none" cap="none" strike="noStrike">
+      <a:defRPr sz="1400" b="0" i="0" u="none" strike="noStrike" cap="none">
         <a:solidFill>
           <a:srgbClr val="000000"/>
         </a:solidFill>
@@ -248,7 +248,7 @@
         <a:sym typeface="Arial"/>
       </a:defRPr>
     </a:lvl8pPr>
-    <a:lvl9pPr lvl="8" marR="0" rtl="0" algn="l">
+    <a:lvl9pPr marR="0" lvl="8" algn="l" rtl="0">
       <a:lnSpc>
         <a:spcPct val="100000"/>
       </a:lnSpc>
@@ -262,7 +262,7 @@
         <a:srgbClr val="000000"/>
       </a:buClr>
       <a:buFont typeface="Arial"/>
-      <a:defRPr b="0" i="0" sz="1400" u="none" cap="none" strike="noStrike">
+      <a:defRPr sz="1400" b="0" i="0" u="none" strike="noStrike" cap="none">
         <a:solidFill>
           <a:srgbClr val="000000"/>
         </a:solidFill>
@@ -275,7 +275,7 @@
   </p:defaultTextStyle>
   <p:extLst>
     <p:ext uri="{EFAFB233-063F-42B5-8137-9DF3F51BA10A}">
-      <p15:sldGuideLst>
+      <p15:sldGuideLst xmlns:p15="http://schemas.microsoft.com/office/powerpoint/2012/main">
         <p15:guide id="1" orient="horz" pos="1620">
           <p15:clr>
             <a:srgbClr val="747775"/>
@@ -293,11 +293,16 @@
 </file>
 
 <file path=ppt/notesMasters/notesMaster1.xml><?xml version="1.0" encoding="utf-8"?>
-<p:notesMaster xmlns:a="http://schemas.openxmlformats.org/drawingml/2006/main" xmlns:r="http://schemas.openxmlformats.org/officeDocument/2006/relationships" xmlns:mc="http://schemas.openxmlformats.org/markup-compatibility/2006" xmlns:mv="urn:schemas-microsoft-com:mac:vml" xmlns:p="http://schemas.openxmlformats.org/presentationml/2006/main" xmlns:c="http://schemas.openxmlformats.org/drawingml/2006/chart" xmlns:dgm="http://schemas.openxmlformats.org/drawingml/2006/diagram" xmlns:o="urn:schemas-microsoft-com:office:office" xmlns:v="urn:schemas-microsoft-com:vml" xmlns:pvml="urn:schemas-microsoft-com:office:powerpoint" xmlns:com="http://schemas.openxmlformats.org/drawingml/2006/compatibility" xmlns:p14="http://schemas.microsoft.com/office/powerpoint/2010/main" xmlns:p15="http://schemas.microsoft.com/office/powerpoint/2012/main" xmlns:ahyp="http://schemas.microsoft.com/office/drawing/2018/hyperlinkcolor">
+<p:notesMaster xmlns:a="http://schemas.openxmlformats.org/drawingml/2006/main" xmlns:r="http://schemas.openxmlformats.org/officeDocument/2006/relationships" xmlns:p="http://schemas.openxmlformats.org/presentationml/2006/main">
   <p:cSld>
+    <p:bg>
+      <p:bgRef idx="1001">
+        <a:schemeClr val="bg1"/>
+      </p:bgRef>
+    </p:bg>
     <p:spTree>
       <p:nvGrpSpPr>
-        <p:cNvPr id="2" name="Shape 2"/>
+        <p:cNvPr id="1" name="Shape 2"/>
         <p:cNvGrpSpPr/>
         <p:nvPr/>
       </p:nvGrpSpPr>
@@ -312,9 +317,11 @@
       <p:sp>
         <p:nvSpPr>
           <p:cNvPr id="3" name="Google Shape;3;n"/>
-          <p:cNvSpPr/>
+          <p:cNvSpPr>
+            <a:spLocks noGrp="1" noRot="1" noChangeAspect="1"/>
+          </p:cNvSpPr>
           <p:nvPr>
-            <p:ph idx="2" type="sldImg"/>
+            <p:ph type="sldImg" idx="2"/>
           </p:nvPr>
         </p:nvSpPr>
         <p:spPr>
@@ -323,9 +330,13 @@
             <a:ext cx="6096075" cy="3429000"/>
           </a:xfrm>
           <a:custGeom>
-            <a:rect b="b" l="l" r="r" t="t"/>
+            <a:avLst/>
+            <a:gdLst/>
+            <a:ahLst/>
+            <a:cxnLst/>
+            <a:rect l="l" t="t" r="r" b="b"/>
             <a:pathLst>
-              <a:path extrusionOk="0" h="120000" w="120000">
+              <a:path w="120000" h="120000" extrusionOk="0">
                 <a:moveTo>
                   <a:pt x="0" y="0"/>
                 </a:moveTo>
@@ -343,23 +354,25 @@
             </a:pathLst>
           </a:custGeom>
           <a:noFill/>
-          <a:ln cap="flat" cmpd="sng" w="9525">
+          <a:ln w="9525" cap="flat" cmpd="sng">
             <a:solidFill>
               <a:srgbClr val="000000"/>
             </a:solidFill>
             <a:prstDash val="solid"/>
             <a:round/>
-            <a:headEnd len="sm" w="sm" type="none"/>
-            <a:tailEnd len="sm" w="sm" type="none"/>
+            <a:headEnd type="none" w="sm" len="sm"/>
+            <a:tailEnd type="none" w="sm" len="sm"/>
           </a:ln>
         </p:spPr>
       </p:sp>
       <p:sp>
         <p:nvSpPr>
           <p:cNvPr id="4" name="Google Shape;4;n"/>
-          <p:cNvSpPr txBox="1"/>
+          <p:cNvSpPr txBox="1">
+            <a:spLocks noGrp="1"/>
+          </p:cNvSpPr>
           <p:nvPr>
-            <p:ph idx="1" type="body"/>
+            <p:ph type="body" idx="1"/>
           </p:nvPr>
         </p:nvSpPr>
         <p:spPr>
@@ -376,11 +389,11 @@
           </a:ln>
         </p:spPr>
         <p:txBody>
-          <a:bodyPr anchorCtr="0" anchor="t" bIns="91425" lIns="91425" spcFirstLastPara="1" rIns="91425" wrap="square" tIns="91425">
+          <a:bodyPr spcFirstLastPara="1" wrap="square" lIns="91425" tIns="91425" rIns="91425" bIns="91425" anchor="t" anchorCtr="0">
             <a:noAutofit/>
           </a:bodyPr>
           <a:lstStyle>
-            <a:lvl1pPr indent="-298450" lvl="0" marL="457200">
+            <a:lvl1pPr marL="457200" lvl="0" indent="-298450">
               <a:spcBef>
                 <a:spcPts val="0"/>
               </a:spcBef>
@@ -391,7 +404,7 @@
               <a:buChar char="●"/>
               <a:defRPr sz="1100"/>
             </a:lvl1pPr>
-            <a:lvl2pPr indent="-298450" lvl="1" marL="914400">
+            <a:lvl2pPr marL="914400" lvl="1" indent="-298450">
               <a:spcBef>
                 <a:spcPts val="0"/>
               </a:spcBef>
@@ -402,7 +415,7 @@
               <a:buChar char="○"/>
               <a:defRPr sz="1100"/>
             </a:lvl2pPr>
-            <a:lvl3pPr indent="-298450" lvl="2" marL="1371600">
+            <a:lvl3pPr marL="1371600" lvl="2" indent="-298450">
               <a:spcBef>
                 <a:spcPts val="0"/>
               </a:spcBef>
@@ -413,7 +426,7 @@
               <a:buChar char="■"/>
               <a:defRPr sz="1100"/>
             </a:lvl3pPr>
-            <a:lvl4pPr indent="-298450" lvl="3" marL="1828800">
+            <a:lvl4pPr marL="1828800" lvl="3" indent="-298450">
               <a:spcBef>
                 <a:spcPts val="0"/>
               </a:spcBef>
@@ -424,7 +437,7 @@
               <a:buChar char="●"/>
               <a:defRPr sz="1100"/>
             </a:lvl4pPr>
-            <a:lvl5pPr indent="-298450" lvl="4" marL="2286000">
+            <a:lvl5pPr marL="2286000" lvl="4" indent="-298450">
               <a:spcBef>
                 <a:spcPts val="0"/>
               </a:spcBef>
@@ -435,7 +448,7 @@
               <a:buChar char="○"/>
               <a:defRPr sz="1100"/>
             </a:lvl5pPr>
-            <a:lvl6pPr indent="-298450" lvl="5" marL="2743200">
+            <a:lvl6pPr marL="2743200" lvl="5" indent="-298450">
               <a:spcBef>
                 <a:spcPts val="0"/>
               </a:spcBef>
@@ -446,7 +459,7 @@
               <a:buChar char="■"/>
               <a:defRPr sz="1100"/>
             </a:lvl6pPr>
-            <a:lvl7pPr indent="-298450" lvl="6" marL="3200400">
+            <a:lvl7pPr marL="3200400" lvl="6" indent="-298450">
               <a:spcBef>
                 <a:spcPts val="0"/>
               </a:spcBef>
@@ -457,7 +470,7 @@
               <a:buChar char="●"/>
               <a:defRPr sz="1100"/>
             </a:lvl7pPr>
-            <a:lvl8pPr indent="-298450" lvl="7" marL="3657600">
+            <a:lvl8pPr marL="3657600" lvl="7" indent="-298450">
               <a:spcBef>
                 <a:spcPts val="0"/>
               </a:spcBef>
@@ -468,7 +481,7 @@
               <a:buChar char="○"/>
               <a:defRPr sz="1100"/>
             </a:lvl8pPr>
-            <a:lvl9pPr indent="-298450" lvl="8" marL="4114800">
+            <a:lvl9pPr marL="4114800" lvl="8" indent="-298450">
               <a:spcBef>
                 <a:spcPts val="0"/>
               </a:spcBef>
@@ -480,14 +493,16 @@
               <a:defRPr sz="1100"/>
             </a:lvl9pPr>
           </a:lstStyle>
-          <a:p/>
+          <a:p>
+            <a:endParaRPr/>
+          </a:p>
         </p:txBody>
       </p:sp>
     </p:spTree>
   </p:cSld>
-  <p:clrMap accent1="accent1" accent2="accent2" accent3="accent3" accent4="accent4" accent5="accent5" accent6="accent6" bg1="lt1" bg2="dk2" tx1="dk1" tx2="lt2" folHlink="folHlink" hlink="hlink"/>
+  <p:clrMap bg1="lt1" tx1="dk1" bg2="dk2" tx2="lt2" accent1="accent1" accent2="accent2" accent3="accent3" accent4="accent4" accent5="accent5" accent6="accent6" hlink="hlink" folHlink="folHlink"/>
   <p:notesStyle>
-    <a:defPPr lvl="0" marR="0" rtl="0" algn="l">
+    <a:defPPr marR="0" lvl="0" algn="l" rtl="0">
       <a:lnSpc>
         <a:spcPct val="100000"/>
       </a:lnSpc>
@@ -498,7 +513,7 @@
         <a:spcPts val="0"/>
       </a:spcAft>
     </a:defPPr>
-    <a:lvl1pPr lvl="0" marR="0" rtl="0" algn="l">
+    <a:lvl1pPr marR="0" lvl="0" algn="l" rtl="0">
       <a:lnSpc>
         <a:spcPct val="100000"/>
       </a:lnSpc>
@@ -512,7 +527,7 @@
         <a:srgbClr val="000000"/>
       </a:buClr>
       <a:buFont typeface="Arial"/>
-      <a:defRPr b="0" i="0" sz="1400" u="none" cap="none" strike="noStrike">
+      <a:defRPr sz="1400" b="0" i="0" u="none" strike="noStrike" cap="none">
         <a:solidFill>
           <a:srgbClr val="000000"/>
         </a:solidFill>
@@ -522,7 +537,7 @@
         <a:sym typeface="Arial"/>
       </a:defRPr>
     </a:lvl1pPr>
-    <a:lvl2pPr lvl="1" marR="0" rtl="0" algn="l">
+    <a:lvl2pPr marR="0" lvl="1" algn="l" rtl="0">
       <a:lnSpc>
         <a:spcPct val="100000"/>
       </a:lnSpc>
@@ -536,7 +551,7 @@
         <a:srgbClr val="000000"/>
       </a:buClr>
       <a:buFont typeface="Arial"/>
-      <a:defRPr b="0" i="0" sz="1400" u="none" cap="none" strike="noStrike">
+      <a:defRPr sz="1400" b="0" i="0" u="none" strike="noStrike" cap="none">
         <a:solidFill>
           <a:srgbClr val="000000"/>
         </a:solidFill>
@@ -546,7 +561,7 @@
         <a:sym typeface="Arial"/>
       </a:defRPr>
     </a:lvl2pPr>
-    <a:lvl3pPr lvl="2" marR="0" rtl="0" algn="l">
+    <a:lvl3pPr marR="0" lvl="2" algn="l" rtl="0">
       <a:lnSpc>
         <a:spcPct val="100000"/>
       </a:lnSpc>
@@ -560,7 +575,7 @@
         <a:srgbClr val="000000"/>
       </a:buClr>
       <a:buFont typeface="Arial"/>
-      <a:defRPr b="0" i="0" sz="1400" u="none" cap="none" strike="noStrike">
+      <a:defRPr sz="1400" b="0" i="0" u="none" strike="noStrike" cap="none">
         <a:solidFill>
           <a:srgbClr val="000000"/>
         </a:solidFill>
@@ -570,7 +585,7 @@
         <a:sym typeface="Arial"/>
       </a:defRPr>
     </a:lvl3pPr>
-    <a:lvl4pPr lvl="3" marR="0" rtl="0" algn="l">
+    <a:lvl4pPr marR="0" lvl="3" algn="l" rtl="0">
       <a:lnSpc>
         <a:spcPct val="100000"/>
       </a:lnSpc>
@@ -584,7 +599,7 @@
         <a:srgbClr val="000000"/>
       </a:buClr>
       <a:buFont typeface="Arial"/>
-      <a:defRPr b="0" i="0" sz="1400" u="none" cap="none" strike="noStrike">
+      <a:defRPr sz="1400" b="0" i="0" u="none" strike="noStrike" cap="none">
         <a:solidFill>
           <a:srgbClr val="000000"/>
         </a:solidFill>
@@ -594,7 +609,7 @@
         <a:sym typeface="Arial"/>
       </a:defRPr>
     </a:lvl4pPr>
-    <a:lvl5pPr lvl="4" marR="0" rtl="0" algn="l">
+    <a:lvl5pPr marR="0" lvl="4" algn="l" rtl="0">
       <a:lnSpc>
         <a:spcPct val="100000"/>
       </a:lnSpc>
@@ -608,7 +623,7 @@
         <a:srgbClr val="000000"/>
       </a:buClr>
       <a:buFont typeface="Arial"/>
-      <a:defRPr b="0" i="0" sz="1400" u="none" cap="none" strike="noStrike">
+      <a:defRPr sz="1400" b="0" i="0" u="none" strike="noStrike" cap="none">
         <a:solidFill>
           <a:srgbClr val="000000"/>
         </a:solidFill>
@@ -618,7 +633,7 @@
         <a:sym typeface="Arial"/>
       </a:defRPr>
     </a:lvl5pPr>
-    <a:lvl6pPr lvl="5" marR="0" rtl="0" algn="l">
+    <a:lvl6pPr marR="0" lvl="5" algn="l" rtl="0">
       <a:lnSpc>
         <a:spcPct val="100000"/>
       </a:lnSpc>
@@ -632,7 +647,7 @@
         <a:srgbClr val="000000"/>
       </a:buClr>
       <a:buFont typeface="Arial"/>
-      <a:defRPr b="0" i="0" sz="1400" u="none" cap="none" strike="noStrike">
+      <a:defRPr sz="1400" b="0" i="0" u="none" strike="noStrike" cap="none">
         <a:solidFill>
           <a:srgbClr val="000000"/>
         </a:solidFill>
@@ -642,7 +657,7 @@
         <a:sym typeface="Arial"/>
       </a:defRPr>
     </a:lvl6pPr>
-    <a:lvl7pPr lvl="6" marR="0" rtl="0" algn="l">
+    <a:lvl7pPr marR="0" lvl="6" algn="l" rtl="0">
       <a:lnSpc>
         <a:spcPct val="100000"/>
       </a:lnSpc>
@@ -656,7 +671,7 @@
         <a:srgbClr val="000000"/>
       </a:buClr>
       <a:buFont typeface="Arial"/>
-      <a:defRPr b="0" i="0" sz="1400" u="none" cap="none" strike="noStrike">
+      <a:defRPr sz="1400" b="0" i="0" u="none" strike="noStrike" cap="none">
         <a:solidFill>
           <a:srgbClr val="000000"/>
         </a:solidFill>
@@ -666,7 +681,7 @@
         <a:sym typeface="Arial"/>
       </a:defRPr>
     </a:lvl7pPr>
-    <a:lvl8pPr lvl="7" marR="0" rtl="0" algn="l">
+    <a:lvl8pPr marR="0" lvl="7" algn="l" rtl="0">
       <a:lnSpc>
         <a:spcPct val="100000"/>
       </a:lnSpc>
@@ -680,7 +695,7 @@
         <a:srgbClr val="000000"/>
       </a:buClr>
       <a:buFont typeface="Arial"/>
-      <a:defRPr b="0" i="0" sz="1400" u="none" cap="none" strike="noStrike">
+      <a:defRPr sz="1400" b="0" i="0" u="none" strike="noStrike" cap="none">
         <a:solidFill>
           <a:srgbClr val="000000"/>
         </a:solidFill>
@@ -690,7 +705,7 @@
         <a:sym typeface="Arial"/>
       </a:defRPr>
     </a:lvl8pPr>
-    <a:lvl9pPr lvl="8" marR="0" rtl="0" algn="l">
+    <a:lvl9pPr marR="0" lvl="8" algn="l" rtl="0">
       <a:lnSpc>
         <a:spcPct val="100000"/>
       </a:lnSpc>
@@ -704,7 +719,7 @@
         <a:srgbClr val="000000"/>
       </a:buClr>
       <a:buFont typeface="Arial"/>
-      <a:defRPr b="0" i="0" sz="1400" u="none" cap="none" strike="noStrike">
+      <a:defRPr sz="1400" b="0" i="0" u="none" strike="noStrike" cap="none">
         <a:solidFill>
           <a:srgbClr val="000000"/>
         </a:solidFill>
@@ -719,11 +734,11 @@
 </file>
 
 <file path=ppt/notesSlides/notesSlide1.xml><?xml version="1.0" encoding="utf-8"?>
-<p:notes xmlns:a="http://schemas.openxmlformats.org/drawingml/2006/main" xmlns:r="http://schemas.openxmlformats.org/officeDocument/2006/relationships" xmlns:mc="http://schemas.openxmlformats.org/markup-compatibility/2006" xmlns:mv="urn:schemas-microsoft-com:mac:vml" xmlns:p="http://schemas.openxmlformats.org/presentationml/2006/main" xmlns:c="http://schemas.openxmlformats.org/drawingml/2006/chart" xmlns:dgm="http://schemas.openxmlformats.org/drawingml/2006/diagram" xmlns:o="urn:schemas-microsoft-com:office:office" xmlns:v="urn:schemas-microsoft-com:vml" xmlns:pvml="urn:schemas-microsoft-com:office:powerpoint" xmlns:com="http://schemas.openxmlformats.org/drawingml/2006/compatibility" xmlns:p14="http://schemas.microsoft.com/office/powerpoint/2010/main" xmlns:p15="http://schemas.microsoft.com/office/powerpoint/2012/main" xmlns:ahyp="http://schemas.microsoft.com/office/drawing/2018/hyperlinkcolor" showMasterPhAnim="0" showMasterSp="0">
+<p:notes xmlns:a="http://schemas.openxmlformats.org/drawingml/2006/main" xmlns:r="http://schemas.openxmlformats.org/officeDocument/2006/relationships" xmlns:p="http://schemas.openxmlformats.org/presentationml/2006/main" showMasterSp="0" showMasterPhAnim="0">
   <p:cSld>
     <p:spTree>
       <p:nvGrpSpPr>
-        <p:cNvPr id="50" name="Shape 50"/>
+        <p:cNvPr id="1" name="Shape 50"/>
         <p:cNvGrpSpPr/>
         <p:nvPr/>
       </p:nvGrpSpPr>
@@ -738,20 +753,26 @@
       <p:sp>
         <p:nvSpPr>
           <p:cNvPr id="51" name="Google Shape;51;p:notes"/>
-          <p:cNvSpPr/>
+          <p:cNvSpPr>
+            <a:spLocks noGrp="1" noRot="1" noChangeAspect="1"/>
+          </p:cNvSpPr>
           <p:nvPr>
-            <p:ph idx="2" type="sldImg"/>
+            <p:ph type="sldImg" idx="2"/>
           </p:nvPr>
         </p:nvSpPr>
         <p:spPr>
           <a:xfrm>
-            <a:off x="381300" y="685800"/>
-            <a:ext cx="6096075" cy="3429000"/>
+            <a:off x="381000" y="685800"/>
+            <a:ext cx="6096000" cy="3429000"/>
           </a:xfrm>
           <a:custGeom>
-            <a:rect b="b" l="l" r="r" t="t"/>
+            <a:avLst/>
+            <a:gdLst/>
+            <a:ahLst/>
+            <a:cxnLst/>
+            <a:rect l="l" t="t" r="r" b="b"/>
             <a:pathLst>
-              <a:path extrusionOk="0" h="120000" w="120000">
+              <a:path w="120000" h="120000" extrusionOk="0">
                 <a:moveTo>
                   <a:pt x="0" y="0"/>
                 </a:moveTo>
@@ -773,9 +794,11 @@
       <p:sp>
         <p:nvSpPr>
           <p:cNvPr id="52" name="Google Shape;52;p:notes"/>
-          <p:cNvSpPr txBox="1"/>
+          <p:cNvSpPr txBox="1">
+            <a:spLocks noGrp="1"/>
+          </p:cNvSpPr>
           <p:nvPr>
-            <p:ph idx="1" type="body"/>
+            <p:ph type="body" idx="1"/>
           </p:nvPr>
         </p:nvSpPr>
         <p:spPr>
@@ -788,12 +811,12 @@
           </a:prstGeom>
         </p:spPr>
         <p:txBody>
-          <a:bodyPr anchorCtr="0" anchor="t" bIns="91425" lIns="91425" spcFirstLastPara="1" rIns="91425" wrap="square" tIns="91425">
+          <a:bodyPr spcFirstLastPara="1" wrap="square" lIns="91425" tIns="91425" rIns="91425" bIns="91425" anchor="t" anchorCtr="0">
             <a:noAutofit/>
           </a:bodyPr>
           <a:lstStyle/>
           <a:p>
-            <a:pPr indent="0" lvl="0" marL="0" rtl="0" algn="l">
+            <a:pPr marL="0" lvl="0" indent="0" algn="l" rtl="0">
               <a:spcBef>
                 <a:spcPts val="0"/>
               </a:spcBef>
@@ -802,9 +825,6 @@
               </a:spcAft>
               <a:buNone/>
             </a:pPr>
-            <a:r>
-              <a:t/>
-            </a:r>
             <a:endParaRPr/>
           </a:p>
         </p:txBody>
@@ -818,11 +838,11 @@
 </file>
 
 <file path=ppt/notesSlides/notesSlide10.xml><?xml version="1.0" encoding="utf-8"?>
-<p:notes xmlns:a="http://schemas.openxmlformats.org/drawingml/2006/main" xmlns:r="http://schemas.openxmlformats.org/officeDocument/2006/relationships" xmlns:mc="http://schemas.openxmlformats.org/markup-compatibility/2006" xmlns:mv="urn:schemas-microsoft-com:mac:vml" xmlns:p="http://schemas.openxmlformats.org/presentationml/2006/main" xmlns:c="http://schemas.openxmlformats.org/drawingml/2006/chart" xmlns:dgm="http://schemas.openxmlformats.org/drawingml/2006/diagram" xmlns:o="urn:schemas-microsoft-com:office:office" xmlns:v="urn:schemas-microsoft-com:vml" xmlns:pvml="urn:schemas-microsoft-com:office:powerpoint" xmlns:com="http://schemas.openxmlformats.org/drawingml/2006/compatibility" xmlns:p14="http://schemas.microsoft.com/office/powerpoint/2010/main" xmlns:p15="http://schemas.microsoft.com/office/powerpoint/2012/main" xmlns:ahyp="http://schemas.microsoft.com/office/drawing/2018/hyperlinkcolor" showMasterPhAnim="0" showMasterSp="0">
+<p:notes xmlns:a="http://schemas.openxmlformats.org/drawingml/2006/main" xmlns:r="http://schemas.openxmlformats.org/officeDocument/2006/relationships" xmlns:p="http://schemas.openxmlformats.org/presentationml/2006/main" showMasterSp="0" showMasterPhAnim="0">
   <p:cSld>
     <p:spTree>
       <p:nvGrpSpPr>
-        <p:cNvPr id="106" name="Shape 106"/>
+        <p:cNvPr id="1" name="Shape 106"/>
         <p:cNvGrpSpPr/>
         <p:nvPr/>
       </p:nvGrpSpPr>
@@ -837,9 +857,11 @@
       <p:sp>
         <p:nvSpPr>
           <p:cNvPr id="107" name="Google Shape;107;g3cb91012bb2_0_0:notes"/>
-          <p:cNvSpPr/>
+          <p:cNvSpPr>
+            <a:spLocks noGrp="1" noRot="1" noChangeAspect="1"/>
+          </p:cNvSpPr>
           <p:nvPr>
-            <p:ph idx="2" type="sldImg"/>
+            <p:ph type="sldImg" idx="2"/>
           </p:nvPr>
         </p:nvSpPr>
         <p:spPr>
@@ -848,9 +870,13 @@
             <a:ext cx="6096000" cy="3429000"/>
           </a:xfrm>
           <a:custGeom>
-            <a:rect b="b" l="l" r="r" t="t"/>
+            <a:avLst/>
+            <a:gdLst/>
+            <a:ahLst/>
+            <a:cxnLst/>
+            <a:rect l="l" t="t" r="r" b="b"/>
             <a:pathLst>
-              <a:path extrusionOk="0" h="120000" w="120000">
+              <a:path w="120000" h="120000" extrusionOk="0">
                 <a:moveTo>
                   <a:pt x="0" y="0"/>
                 </a:moveTo>
@@ -872,9 +898,11 @@
       <p:sp>
         <p:nvSpPr>
           <p:cNvPr id="108" name="Google Shape;108;g3cb91012bb2_0_0:notes"/>
-          <p:cNvSpPr txBox="1"/>
+          <p:cNvSpPr txBox="1">
+            <a:spLocks noGrp="1"/>
+          </p:cNvSpPr>
           <p:nvPr>
-            <p:ph idx="1" type="body"/>
+            <p:ph type="body" idx="1"/>
           </p:nvPr>
         </p:nvSpPr>
         <p:spPr>
@@ -887,12 +915,12 @@
           </a:prstGeom>
         </p:spPr>
         <p:txBody>
-          <a:bodyPr anchorCtr="0" anchor="t" bIns="91425" lIns="91425" spcFirstLastPara="1" rIns="91425" wrap="square" tIns="91425">
+          <a:bodyPr spcFirstLastPara="1" wrap="square" lIns="91425" tIns="91425" rIns="91425" bIns="91425" anchor="t" anchorCtr="0">
             <a:noAutofit/>
           </a:bodyPr>
           <a:lstStyle/>
           <a:p>
-            <a:pPr indent="0" lvl="0" marL="0" rtl="0" algn="l">
+            <a:pPr marL="0" lvl="0" indent="0" algn="l" rtl="0">
               <a:spcBef>
                 <a:spcPts val="0"/>
               </a:spcBef>
@@ -901,9 +929,6 @@
               </a:spcAft>
               <a:buNone/>
             </a:pPr>
-            <a:r>
-              <a:t/>
-            </a:r>
             <a:endParaRPr/>
           </a:p>
         </p:txBody>
@@ -917,11 +942,11 @@
 </file>
 
 <file path=ppt/notesSlides/notesSlide11.xml><?xml version="1.0" encoding="utf-8"?>
-<p:notes xmlns:a="http://schemas.openxmlformats.org/drawingml/2006/main" xmlns:r="http://schemas.openxmlformats.org/officeDocument/2006/relationships" xmlns:mc="http://schemas.openxmlformats.org/markup-compatibility/2006" xmlns:mv="urn:schemas-microsoft-com:mac:vml" xmlns:p="http://schemas.openxmlformats.org/presentationml/2006/main" xmlns:c="http://schemas.openxmlformats.org/drawingml/2006/chart" xmlns:dgm="http://schemas.openxmlformats.org/drawingml/2006/diagram" xmlns:o="urn:schemas-microsoft-com:office:office" xmlns:v="urn:schemas-microsoft-com:vml" xmlns:pvml="urn:schemas-microsoft-com:office:powerpoint" xmlns:com="http://schemas.openxmlformats.org/drawingml/2006/compatibility" xmlns:p14="http://schemas.microsoft.com/office/powerpoint/2010/main" xmlns:p15="http://schemas.microsoft.com/office/powerpoint/2012/main" xmlns:ahyp="http://schemas.microsoft.com/office/drawing/2018/hyperlinkcolor" showMasterPhAnim="0" showMasterSp="0">
+<p:notes xmlns:a="http://schemas.openxmlformats.org/drawingml/2006/main" xmlns:r="http://schemas.openxmlformats.org/officeDocument/2006/relationships" xmlns:p="http://schemas.openxmlformats.org/presentationml/2006/main" showMasterSp="0" showMasterPhAnim="0">
   <p:cSld>
     <p:spTree>
       <p:nvGrpSpPr>
-        <p:cNvPr id="112" name="Shape 112"/>
+        <p:cNvPr id="1" name="Shape 112"/>
         <p:cNvGrpSpPr/>
         <p:nvPr/>
       </p:nvGrpSpPr>
@@ -936,9 +961,11 @@
       <p:sp>
         <p:nvSpPr>
           <p:cNvPr id="113" name="Google Shape;113;g3cb91012bb2_0_5:notes"/>
-          <p:cNvSpPr/>
+          <p:cNvSpPr>
+            <a:spLocks noGrp="1" noRot="1" noChangeAspect="1"/>
+          </p:cNvSpPr>
           <p:nvPr>
-            <p:ph idx="2" type="sldImg"/>
+            <p:ph type="sldImg" idx="2"/>
           </p:nvPr>
         </p:nvSpPr>
         <p:spPr>
@@ -947,9 +974,13 @@
             <a:ext cx="6096000" cy="3429000"/>
           </a:xfrm>
           <a:custGeom>
-            <a:rect b="b" l="l" r="r" t="t"/>
+            <a:avLst/>
+            <a:gdLst/>
+            <a:ahLst/>
+            <a:cxnLst/>
+            <a:rect l="l" t="t" r="r" b="b"/>
             <a:pathLst>
-              <a:path extrusionOk="0" h="120000" w="120000">
+              <a:path w="120000" h="120000" extrusionOk="0">
                 <a:moveTo>
                   <a:pt x="0" y="0"/>
                 </a:moveTo>
@@ -971,9 +1002,11 @@
       <p:sp>
         <p:nvSpPr>
           <p:cNvPr id="114" name="Google Shape;114;g3cb91012bb2_0_5:notes"/>
-          <p:cNvSpPr txBox="1"/>
+          <p:cNvSpPr txBox="1">
+            <a:spLocks noGrp="1"/>
+          </p:cNvSpPr>
           <p:nvPr>
-            <p:ph idx="1" type="body"/>
+            <p:ph type="body" idx="1"/>
           </p:nvPr>
         </p:nvSpPr>
         <p:spPr>
@@ -986,12 +1019,12 @@
           </a:prstGeom>
         </p:spPr>
         <p:txBody>
-          <a:bodyPr anchorCtr="0" anchor="t" bIns="91425" lIns="91425" spcFirstLastPara="1" rIns="91425" wrap="square" tIns="91425">
+          <a:bodyPr spcFirstLastPara="1" wrap="square" lIns="91425" tIns="91425" rIns="91425" bIns="91425" anchor="t" anchorCtr="0">
             <a:noAutofit/>
           </a:bodyPr>
           <a:lstStyle/>
           <a:p>
-            <a:pPr indent="0" lvl="0" marL="0" rtl="0" algn="l">
+            <a:pPr marL="0" lvl="0" indent="0" algn="l" rtl="0">
               <a:spcBef>
                 <a:spcPts val="0"/>
               </a:spcBef>
@@ -1000,9 +1033,6 @@
               </a:spcAft>
               <a:buNone/>
             </a:pPr>
-            <a:r>
-              <a:t/>
-            </a:r>
             <a:endParaRPr/>
           </a:p>
         </p:txBody>
@@ -1016,11 +1046,11 @@
 </file>
 
 <file path=ppt/notesSlides/notesSlide12.xml><?xml version="1.0" encoding="utf-8"?>
-<p:notes xmlns:a="http://schemas.openxmlformats.org/drawingml/2006/main" xmlns:r="http://schemas.openxmlformats.org/officeDocument/2006/relationships" xmlns:mc="http://schemas.openxmlformats.org/markup-compatibility/2006" xmlns:mv="urn:schemas-microsoft-com:mac:vml" xmlns:p="http://schemas.openxmlformats.org/presentationml/2006/main" xmlns:c="http://schemas.openxmlformats.org/drawingml/2006/chart" xmlns:dgm="http://schemas.openxmlformats.org/drawingml/2006/diagram" xmlns:o="urn:schemas-microsoft-com:office:office" xmlns:v="urn:schemas-microsoft-com:vml" xmlns:pvml="urn:schemas-microsoft-com:office:powerpoint" xmlns:com="http://schemas.openxmlformats.org/drawingml/2006/compatibility" xmlns:p14="http://schemas.microsoft.com/office/powerpoint/2010/main" xmlns:p15="http://schemas.microsoft.com/office/powerpoint/2012/main" xmlns:ahyp="http://schemas.microsoft.com/office/drawing/2018/hyperlinkcolor" showMasterPhAnim="0" showMasterSp="0">
+<p:notes xmlns:a="http://schemas.openxmlformats.org/drawingml/2006/main" xmlns:r="http://schemas.openxmlformats.org/officeDocument/2006/relationships" xmlns:p="http://schemas.openxmlformats.org/presentationml/2006/main" showMasterSp="0" showMasterPhAnim="0">
   <p:cSld>
     <p:spTree>
       <p:nvGrpSpPr>
-        <p:cNvPr id="118" name="Shape 118"/>
+        <p:cNvPr id="1" name="Shape 118"/>
         <p:cNvGrpSpPr/>
         <p:nvPr/>
       </p:nvGrpSpPr>
@@ -1035,9 +1065,11 @@
       <p:sp>
         <p:nvSpPr>
           <p:cNvPr id="119" name="Google Shape;119;g3cb91012bb2_0_10:notes"/>
-          <p:cNvSpPr/>
+          <p:cNvSpPr>
+            <a:spLocks noGrp="1" noRot="1" noChangeAspect="1"/>
+          </p:cNvSpPr>
           <p:nvPr>
-            <p:ph idx="2" type="sldImg"/>
+            <p:ph type="sldImg" idx="2"/>
           </p:nvPr>
         </p:nvSpPr>
         <p:spPr>
@@ -1046,9 +1078,13 @@
             <a:ext cx="6096000" cy="3429000"/>
           </a:xfrm>
           <a:custGeom>
-            <a:rect b="b" l="l" r="r" t="t"/>
+            <a:avLst/>
+            <a:gdLst/>
+            <a:ahLst/>
+            <a:cxnLst/>
+            <a:rect l="l" t="t" r="r" b="b"/>
             <a:pathLst>
-              <a:path extrusionOk="0" h="120000" w="120000">
+              <a:path w="120000" h="120000" extrusionOk="0">
                 <a:moveTo>
                   <a:pt x="0" y="0"/>
                 </a:moveTo>
@@ -1070,9 +1106,11 @@
       <p:sp>
         <p:nvSpPr>
           <p:cNvPr id="120" name="Google Shape;120;g3cb91012bb2_0_10:notes"/>
-          <p:cNvSpPr txBox="1"/>
+          <p:cNvSpPr txBox="1">
+            <a:spLocks noGrp="1"/>
+          </p:cNvSpPr>
           <p:nvPr>
-            <p:ph idx="1" type="body"/>
+            <p:ph type="body" idx="1"/>
           </p:nvPr>
         </p:nvSpPr>
         <p:spPr>
@@ -1085,12 +1123,12 @@
           </a:prstGeom>
         </p:spPr>
         <p:txBody>
-          <a:bodyPr anchorCtr="0" anchor="t" bIns="91425" lIns="91425" spcFirstLastPara="1" rIns="91425" wrap="square" tIns="91425">
+          <a:bodyPr spcFirstLastPara="1" wrap="square" lIns="91425" tIns="91425" rIns="91425" bIns="91425" anchor="t" anchorCtr="0">
             <a:noAutofit/>
           </a:bodyPr>
           <a:lstStyle/>
           <a:p>
-            <a:pPr indent="0" lvl="0" marL="0" rtl="0" algn="l">
+            <a:pPr marL="0" lvl="0" indent="0" algn="l" rtl="0">
               <a:spcBef>
                 <a:spcPts val="0"/>
               </a:spcBef>
@@ -1099,9 +1137,6 @@
               </a:spcAft>
               <a:buNone/>
             </a:pPr>
-            <a:r>
-              <a:t/>
-            </a:r>
             <a:endParaRPr/>
           </a:p>
         </p:txBody>
@@ -1115,11 +1150,11 @@
 </file>
 
 <file path=ppt/notesSlides/notesSlide13.xml><?xml version="1.0" encoding="utf-8"?>
-<p:notes xmlns:a="http://schemas.openxmlformats.org/drawingml/2006/main" xmlns:r="http://schemas.openxmlformats.org/officeDocument/2006/relationships" xmlns:mc="http://schemas.openxmlformats.org/markup-compatibility/2006" xmlns:mv="urn:schemas-microsoft-com:mac:vml" xmlns:p="http://schemas.openxmlformats.org/presentationml/2006/main" xmlns:c="http://schemas.openxmlformats.org/drawingml/2006/chart" xmlns:dgm="http://schemas.openxmlformats.org/drawingml/2006/diagram" xmlns:o="urn:schemas-microsoft-com:office:office" xmlns:v="urn:schemas-microsoft-com:vml" xmlns:pvml="urn:schemas-microsoft-com:office:powerpoint" xmlns:com="http://schemas.openxmlformats.org/drawingml/2006/compatibility" xmlns:p14="http://schemas.microsoft.com/office/powerpoint/2010/main" xmlns:p15="http://schemas.microsoft.com/office/powerpoint/2012/main" xmlns:ahyp="http://schemas.microsoft.com/office/drawing/2018/hyperlinkcolor" showMasterPhAnim="0" showMasterSp="0">
+<p:notes xmlns:a="http://schemas.openxmlformats.org/drawingml/2006/main" xmlns:r="http://schemas.openxmlformats.org/officeDocument/2006/relationships" xmlns:p="http://schemas.openxmlformats.org/presentationml/2006/main" showMasterSp="0" showMasterPhAnim="0">
   <p:cSld>
     <p:spTree>
       <p:nvGrpSpPr>
-        <p:cNvPr id="124" name="Shape 124"/>
+        <p:cNvPr id="1" name="Shape 124"/>
         <p:cNvGrpSpPr/>
         <p:nvPr/>
       </p:nvGrpSpPr>
@@ -1134,20 +1169,26 @@
       <p:sp>
         <p:nvSpPr>
           <p:cNvPr id="125" name="Google Shape;125;g3cb91012bb2_0_15:notes"/>
-          <p:cNvSpPr/>
+          <p:cNvSpPr>
+            <a:spLocks noGrp="1" noRot="1" noChangeAspect="1"/>
+          </p:cNvSpPr>
           <p:nvPr>
-            <p:ph idx="2" type="sldImg"/>
+            <p:ph type="sldImg" idx="2"/>
           </p:nvPr>
         </p:nvSpPr>
         <p:spPr>
           <a:xfrm>
-            <a:off x="381300" y="685800"/>
+            <a:off x="381000" y="685800"/>
             <a:ext cx="6096000" cy="3429000"/>
           </a:xfrm>
           <a:custGeom>
-            <a:rect b="b" l="l" r="r" t="t"/>
+            <a:avLst/>
+            <a:gdLst/>
+            <a:ahLst/>
+            <a:cxnLst/>
+            <a:rect l="l" t="t" r="r" b="b"/>
             <a:pathLst>
-              <a:path extrusionOk="0" h="120000" w="120000">
+              <a:path w="120000" h="120000" extrusionOk="0">
                 <a:moveTo>
                   <a:pt x="0" y="0"/>
                 </a:moveTo>
@@ -1169,9 +1210,11 @@
       <p:sp>
         <p:nvSpPr>
           <p:cNvPr id="126" name="Google Shape;126;g3cb91012bb2_0_15:notes"/>
-          <p:cNvSpPr txBox="1"/>
+          <p:cNvSpPr txBox="1">
+            <a:spLocks noGrp="1"/>
+          </p:cNvSpPr>
           <p:nvPr>
-            <p:ph idx="1" type="body"/>
+            <p:ph type="body" idx="1"/>
           </p:nvPr>
         </p:nvSpPr>
         <p:spPr>
@@ -1184,12 +1227,12 @@
           </a:prstGeom>
         </p:spPr>
         <p:txBody>
-          <a:bodyPr anchorCtr="0" anchor="t" bIns="91425" lIns="91425" spcFirstLastPara="1" rIns="91425" wrap="square" tIns="91425">
+          <a:bodyPr spcFirstLastPara="1" wrap="square" lIns="91425" tIns="91425" rIns="91425" bIns="91425" anchor="t" anchorCtr="0">
             <a:noAutofit/>
           </a:bodyPr>
           <a:lstStyle/>
           <a:p>
-            <a:pPr indent="0" lvl="0" marL="0" rtl="0" algn="l">
+            <a:pPr marL="0" lvl="0" indent="0" algn="l" rtl="0">
               <a:spcBef>
                 <a:spcPts val="0"/>
               </a:spcBef>
@@ -1198,9 +1241,6 @@
               </a:spcAft>
               <a:buNone/>
             </a:pPr>
-            <a:r>
-              <a:t/>
-            </a:r>
             <a:endParaRPr/>
           </a:p>
         </p:txBody>
@@ -1214,11 +1254,11 @@
 </file>
 
 <file path=ppt/notesSlides/notesSlide14.xml><?xml version="1.0" encoding="utf-8"?>
-<p:notes xmlns:a="http://schemas.openxmlformats.org/drawingml/2006/main" xmlns:r="http://schemas.openxmlformats.org/officeDocument/2006/relationships" xmlns:mc="http://schemas.openxmlformats.org/markup-compatibility/2006" xmlns:mv="urn:schemas-microsoft-com:mac:vml" xmlns:p="http://schemas.openxmlformats.org/presentationml/2006/main" xmlns:c="http://schemas.openxmlformats.org/drawingml/2006/chart" xmlns:dgm="http://schemas.openxmlformats.org/drawingml/2006/diagram" xmlns:o="urn:schemas-microsoft-com:office:office" xmlns:v="urn:schemas-microsoft-com:vml" xmlns:pvml="urn:schemas-microsoft-com:office:powerpoint" xmlns:com="http://schemas.openxmlformats.org/drawingml/2006/compatibility" xmlns:p14="http://schemas.microsoft.com/office/powerpoint/2010/main" xmlns:p15="http://schemas.microsoft.com/office/powerpoint/2012/main" xmlns:ahyp="http://schemas.microsoft.com/office/drawing/2018/hyperlinkcolor" showMasterPhAnim="0" showMasterSp="0">
+<p:notes xmlns:a="http://schemas.openxmlformats.org/drawingml/2006/main" xmlns:r="http://schemas.openxmlformats.org/officeDocument/2006/relationships" xmlns:p="http://schemas.openxmlformats.org/presentationml/2006/main" showMasterSp="0" showMasterPhAnim="0">
   <p:cSld>
     <p:spTree>
       <p:nvGrpSpPr>
-        <p:cNvPr id="131" name="Shape 131"/>
+        <p:cNvPr id="1" name="Shape 131"/>
         <p:cNvGrpSpPr/>
         <p:nvPr/>
       </p:nvGrpSpPr>
@@ -1233,9 +1273,11 @@
       <p:sp>
         <p:nvSpPr>
           <p:cNvPr id="132" name="Google Shape;132;g3b6c7e62156_0_5:notes"/>
-          <p:cNvSpPr/>
+          <p:cNvSpPr>
+            <a:spLocks noGrp="1" noRot="1" noChangeAspect="1"/>
+          </p:cNvSpPr>
           <p:nvPr>
-            <p:ph idx="2" type="sldImg"/>
+            <p:ph type="sldImg" idx="2"/>
           </p:nvPr>
         </p:nvSpPr>
         <p:spPr>
@@ -1244,9 +1286,13 @@
             <a:ext cx="6096000" cy="3429000"/>
           </a:xfrm>
           <a:custGeom>
-            <a:rect b="b" l="l" r="r" t="t"/>
+            <a:avLst/>
+            <a:gdLst/>
+            <a:ahLst/>
+            <a:cxnLst/>
+            <a:rect l="l" t="t" r="r" b="b"/>
             <a:pathLst>
-              <a:path extrusionOk="0" h="120000" w="120000">
+              <a:path w="120000" h="120000" extrusionOk="0">
                 <a:moveTo>
                   <a:pt x="0" y="0"/>
                 </a:moveTo>
@@ -1268,9 +1314,11 @@
       <p:sp>
         <p:nvSpPr>
           <p:cNvPr id="133" name="Google Shape;133;g3b6c7e62156_0_5:notes"/>
-          <p:cNvSpPr txBox="1"/>
+          <p:cNvSpPr txBox="1">
+            <a:spLocks noGrp="1"/>
+          </p:cNvSpPr>
           <p:nvPr>
-            <p:ph idx="1" type="body"/>
+            <p:ph type="body" idx="1"/>
           </p:nvPr>
         </p:nvSpPr>
         <p:spPr>
@@ -1283,12 +1331,12 @@
           </a:prstGeom>
         </p:spPr>
         <p:txBody>
-          <a:bodyPr anchorCtr="0" anchor="t" bIns="91425" lIns="91425" spcFirstLastPara="1" rIns="91425" wrap="square" tIns="91425">
+          <a:bodyPr spcFirstLastPara="1" wrap="square" lIns="91425" tIns="91425" rIns="91425" bIns="91425" anchor="t" anchorCtr="0">
             <a:noAutofit/>
           </a:bodyPr>
           <a:lstStyle/>
           <a:p>
-            <a:pPr indent="0" lvl="0" marL="0" rtl="0" algn="l">
+            <a:pPr marL="0" lvl="0" indent="0" algn="l" rtl="0">
               <a:spcBef>
                 <a:spcPts val="0"/>
               </a:spcBef>
@@ -1297,9 +1345,6 @@
               </a:spcAft>
               <a:buNone/>
             </a:pPr>
-            <a:r>
-              <a:t/>
-            </a:r>
             <a:endParaRPr/>
           </a:p>
         </p:txBody>
@@ -1313,11 +1358,11 @@
 </file>
 
 <file path=ppt/notesSlides/notesSlide2.xml><?xml version="1.0" encoding="utf-8"?>
-<p:notes xmlns:a="http://schemas.openxmlformats.org/drawingml/2006/main" xmlns:r="http://schemas.openxmlformats.org/officeDocument/2006/relationships" xmlns:mc="http://schemas.openxmlformats.org/markup-compatibility/2006" xmlns:mv="urn:schemas-microsoft-com:mac:vml" xmlns:p="http://schemas.openxmlformats.org/presentationml/2006/main" xmlns:c="http://schemas.openxmlformats.org/drawingml/2006/chart" xmlns:dgm="http://schemas.openxmlformats.org/drawingml/2006/diagram" xmlns:o="urn:schemas-microsoft-com:office:office" xmlns:v="urn:schemas-microsoft-com:vml" xmlns:pvml="urn:schemas-microsoft-com:office:powerpoint" xmlns:com="http://schemas.openxmlformats.org/drawingml/2006/compatibility" xmlns:p14="http://schemas.microsoft.com/office/powerpoint/2010/main" xmlns:p15="http://schemas.microsoft.com/office/powerpoint/2012/main" xmlns:ahyp="http://schemas.microsoft.com/office/drawing/2018/hyperlinkcolor" showMasterPhAnim="0" showMasterSp="0">
+<p:notes xmlns:a="http://schemas.openxmlformats.org/drawingml/2006/main" xmlns:r="http://schemas.openxmlformats.org/officeDocument/2006/relationships" xmlns:p="http://schemas.openxmlformats.org/presentationml/2006/main" showMasterSp="0" showMasterPhAnim="0">
   <p:cSld>
     <p:spTree>
       <p:nvGrpSpPr>
-        <p:cNvPr id="58" name="Shape 58"/>
+        <p:cNvPr id="1" name="Shape 58"/>
         <p:cNvGrpSpPr/>
         <p:nvPr/>
       </p:nvGrpSpPr>
@@ -1332,20 +1377,26 @@
       <p:sp>
         <p:nvSpPr>
           <p:cNvPr id="59" name="Google Shape;59;g3b6c7e62156_0_1:notes"/>
-          <p:cNvSpPr/>
+          <p:cNvSpPr>
+            <a:spLocks noGrp="1" noRot="1" noChangeAspect="1"/>
+          </p:cNvSpPr>
           <p:nvPr>
-            <p:ph idx="2" type="sldImg"/>
+            <p:ph type="sldImg" idx="2"/>
           </p:nvPr>
         </p:nvSpPr>
         <p:spPr>
           <a:xfrm>
-            <a:off x="381300" y="685800"/>
+            <a:off x="381000" y="685800"/>
             <a:ext cx="6096000" cy="3429000"/>
           </a:xfrm>
           <a:custGeom>
-            <a:rect b="b" l="l" r="r" t="t"/>
+            <a:avLst/>
+            <a:gdLst/>
+            <a:ahLst/>
+            <a:cxnLst/>
+            <a:rect l="l" t="t" r="r" b="b"/>
             <a:pathLst>
-              <a:path extrusionOk="0" h="120000" w="120000">
+              <a:path w="120000" h="120000" extrusionOk="0">
                 <a:moveTo>
                   <a:pt x="0" y="0"/>
                 </a:moveTo>
@@ -1367,9 +1418,11 @@
       <p:sp>
         <p:nvSpPr>
           <p:cNvPr id="60" name="Google Shape;60;g3b6c7e62156_0_1:notes"/>
-          <p:cNvSpPr txBox="1"/>
+          <p:cNvSpPr txBox="1">
+            <a:spLocks noGrp="1"/>
+          </p:cNvSpPr>
           <p:nvPr>
-            <p:ph idx="1" type="body"/>
+            <p:ph type="body" idx="1"/>
           </p:nvPr>
         </p:nvSpPr>
         <p:spPr>
@@ -1382,12 +1435,12 @@
           </a:prstGeom>
         </p:spPr>
         <p:txBody>
-          <a:bodyPr anchorCtr="0" anchor="t" bIns="91425" lIns="91425" spcFirstLastPara="1" rIns="91425" wrap="square" tIns="91425">
+          <a:bodyPr spcFirstLastPara="1" wrap="square" lIns="91425" tIns="91425" rIns="91425" bIns="91425" anchor="t" anchorCtr="0">
             <a:noAutofit/>
           </a:bodyPr>
           <a:lstStyle/>
           <a:p>
-            <a:pPr indent="0" lvl="0" marL="0" rtl="0" algn="l">
+            <a:pPr marL="0" lvl="0" indent="0" algn="l" rtl="0">
               <a:spcBef>
                 <a:spcPts val="0"/>
               </a:spcBef>
@@ -1396,9 +1449,6 @@
               </a:spcAft>
               <a:buNone/>
             </a:pPr>
-            <a:r>
-              <a:t/>
-            </a:r>
             <a:endParaRPr/>
           </a:p>
         </p:txBody>
@@ -1412,11 +1462,11 @@
 </file>
 
 <file path=ppt/notesSlides/notesSlide3.xml><?xml version="1.0" encoding="utf-8"?>
-<p:notes xmlns:a="http://schemas.openxmlformats.org/drawingml/2006/main" xmlns:r="http://schemas.openxmlformats.org/officeDocument/2006/relationships" xmlns:mc="http://schemas.openxmlformats.org/markup-compatibility/2006" xmlns:mv="urn:schemas-microsoft-com:mac:vml" xmlns:p="http://schemas.openxmlformats.org/presentationml/2006/main" xmlns:c="http://schemas.openxmlformats.org/drawingml/2006/chart" xmlns:dgm="http://schemas.openxmlformats.org/drawingml/2006/diagram" xmlns:o="urn:schemas-microsoft-com:office:office" xmlns:v="urn:schemas-microsoft-com:vml" xmlns:pvml="urn:schemas-microsoft-com:office:powerpoint" xmlns:com="http://schemas.openxmlformats.org/drawingml/2006/compatibility" xmlns:p14="http://schemas.microsoft.com/office/powerpoint/2010/main" xmlns:p15="http://schemas.microsoft.com/office/powerpoint/2012/main" xmlns:ahyp="http://schemas.microsoft.com/office/drawing/2018/hyperlinkcolor" showMasterPhAnim="0" showMasterSp="0">
+<p:notes xmlns:a="http://schemas.openxmlformats.org/drawingml/2006/main" xmlns:r="http://schemas.openxmlformats.org/officeDocument/2006/relationships" xmlns:p="http://schemas.openxmlformats.org/presentationml/2006/main" showMasterSp="0" showMasterPhAnim="0">
   <p:cSld>
     <p:spTree>
       <p:nvGrpSpPr>
-        <p:cNvPr id="64" name="Shape 64"/>
+        <p:cNvPr id="1" name="Shape 64"/>
         <p:cNvGrpSpPr/>
         <p:nvPr/>
       </p:nvGrpSpPr>
@@ -1431,9 +1481,11 @@
       <p:sp>
         <p:nvSpPr>
           <p:cNvPr id="65" name="Google Shape;65;g3b6c7e62156_0_13:notes"/>
-          <p:cNvSpPr/>
+          <p:cNvSpPr>
+            <a:spLocks noGrp="1" noRot="1" noChangeAspect="1"/>
+          </p:cNvSpPr>
           <p:nvPr>
-            <p:ph idx="2" type="sldImg"/>
+            <p:ph type="sldImg" idx="2"/>
           </p:nvPr>
         </p:nvSpPr>
         <p:spPr>
@@ -1442,9 +1494,13 @@
             <a:ext cx="6096000" cy="3429000"/>
           </a:xfrm>
           <a:custGeom>
-            <a:rect b="b" l="l" r="r" t="t"/>
+            <a:avLst/>
+            <a:gdLst/>
+            <a:ahLst/>
+            <a:cxnLst/>
+            <a:rect l="l" t="t" r="r" b="b"/>
             <a:pathLst>
-              <a:path extrusionOk="0" h="120000" w="120000">
+              <a:path w="120000" h="120000" extrusionOk="0">
                 <a:moveTo>
                   <a:pt x="0" y="0"/>
                 </a:moveTo>
@@ -1466,9 +1522,11 @@
       <p:sp>
         <p:nvSpPr>
           <p:cNvPr id="66" name="Google Shape;66;g3b6c7e62156_0_13:notes"/>
-          <p:cNvSpPr txBox="1"/>
+          <p:cNvSpPr txBox="1">
+            <a:spLocks noGrp="1"/>
+          </p:cNvSpPr>
           <p:nvPr>
-            <p:ph idx="1" type="body"/>
+            <p:ph type="body" idx="1"/>
           </p:nvPr>
         </p:nvSpPr>
         <p:spPr>
@@ -1481,12 +1539,12 @@
           </a:prstGeom>
         </p:spPr>
         <p:txBody>
-          <a:bodyPr anchorCtr="0" anchor="t" bIns="91425" lIns="91425" spcFirstLastPara="1" rIns="91425" wrap="square" tIns="91425">
+          <a:bodyPr spcFirstLastPara="1" wrap="square" lIns="91425" tIns="91425" rIns="91425" bIns="91425" anchor="t" anchorCtr="0">
             <a:noAutofit/>
           </a:bodyPr>
           <a:lstStyle/>
           <a:p>
-            <a:pPr indent="0" lvl="0" marL="0" rtl="0" algn="l">
+            <a:pPr marL="0" lvl="0" indent="0" algn="l" rtl="0">
               <a:spcBef>
                 <a:spcPts val="0"/>
               </a:spcBef>
@@ -1495,9 +1553,6 @@
               </a:spcAft>
               <a:buNone/>
             </a:pPr>
-            <a:r>
-              <a:t/>
-            </a:r>
             <a:endParaRPr/>
           </a:p>
         </p:txBody>
@@ -1511,11 +1566,11 @@
 </file>
 
 <file path=ppt/notesSlides/notesSlide4.xml><?xml version="1.0" encoding="utf-8"?>
-<p:notes xmlns:a="http://schemas.openxmlformats.org/drawingml/2006/main" xmlns:r="http://schemas.openxmlformats.org/officeDocument/2006/relationships" xmlns:mc="http://schemas.openxmlformats.org/markup-compatibility/2006" xmlns:mv="urn:schemas-microsoft-com:mac:vml" xmlns:p="http://schemas.openxmlformats.org/presentationml/2006/main" xmlns:c="http://schemas.openxmlformats.org/drawingml/2006/chart" xmlns:dgm="http://schemas.openxmlformats.org/drawingml/2006/diagram" xmlns:o="urn:schemas-microsoft-com:office:office" xmlns:v="urn:schemas-microsoft-com:vml" xmlns:pvml="urn:schemas-microsoft-com:office:powerpoint" xmlns:com="http://schemas.openxmlformats.org/drawingml/2006/compatibility" xmlns:p14="http://schemas.microsoft.com/office/powerpoint/2010/main" xmlns:p15="http://schemas.microsoft.com/office/powerpoint/2012/main" xmlns:ahyp="http://schemas.microsoft.com/office/drawing/2018/hyperlinkcolor" showMasterPhAnim="0" showMasterSp="0">
+<p:notes xmlns:a="http://schemas.openxmlformats.org/drawingml/2006/main" xmlns:r="http://schemas.openxmlformats.org/officeDocument/2006/relationships" xmlns:p="http://schemas.openxmlformats.org/presentationml/2006/main" showMasterSp="0" showMasterPhAnim="0">
   <p:cSld>
     <p:spTree>
       <p:nvGrpSpPr>
-        <p:cNvPr id="70" name="Shape 70"/>
+        <p:cNvPr id="1" name="Shape 70"/>
         <p:cNvGrpSpPr/>
         <p:nvPr/>
       </p:nvGrpSpPr>
@@ -1530,9 +1585,11 @@
       <p:sp>
         <p:nvSpPr>
           <p:cNvPr id="71" name="Google Shape;71;g3b6c7e62156_0_18:notes"/>
-          <p:cNvSpPr/>
+          <p:cNvSpPr>
+            <a:spLocks noGrp="1" noRot="1" noChangeAspect="1"/>
+          </p:cNvSpPr>
           <p:nvPr>
-            <p:ph idx="2" type="sldImg"/>
+            <p:ph type="sldImg" idx="2"/>
           </p:nvPr>
         </p:nvSpPr>
         <p:spPr>
@@ -1541,9 +1598,13 @@
             <a:ext cx="6096000" cy="3429000"/>
           </a:xfrm>
           <a:custGeom>
-            <a:rect b="b" l="l" r="r" t="t"/>
+            <a:avLst/>
+            <a:gdLst/>
+            <a:ahLst/>
+            <a:cxnLst/>
+            <a:rect l="l" t="t" r="r" b="b"/>
             <a:pathLst>
-              <a:path extrusionOk="0" h="120000" w="120000">
+              <a:path w="120000" h="120000" extrusionOk="0">
                 <a:moveTo>
                   <a:pt x="0" y="0"/>
                 </a:moveTo>
@@ -1565,9 +1626,11 @@
       <p:sp>
         <p:nvSpPr>
           <p:cNvPr id="72" name="Google Shape;72;g3b6c7e62156_0_18:notes"/>
-          <p:cNvSpPr txBox="1"/>
+          <p:cNvSpPr txBox="1">
+            <a:spLocks noGrp="1"/>
+          </p:cNvSpPr>
           <p:nvPr>
-            <p:ph idx="1" type="body"/>
+            <p:ph type="body" idx="1"/>
           </p:nvPr>
         </p:nvSpPr>
         <p:spPr>
@@ -1580,12 +1643,12 @@
           </a:prstGeom>
         </p:spPr>
         <p:txBody>
-          <a:bodyPr anchorCtr="0" anchor="t" bIns="91425" lIns="91425" spcFirstLastPara="1" rIns="91425" wrap="square" tIns="91425">
+          <a:bodyPr spcFirstLastPara="1" wrap="square" lIns="91425" tIns="91425" rIns="91425" bIns="91425" anchor="t" anchorCtr="0">
             <a:noAutofit/>
           </a:bodyPr>
           <a:lstStyle/>
           <a:p>
-            <a:pPr indent="0" lvl="0" marL="0" rtl="0" algn="l">
+            <a:pPr marL="0" lvl="0" indent="0" algn="l" rtl="0">
               <a:spcBef>
                 <a:spcPts val="0"/>
               </a:spcBef>
@@ -1594,9 +1657,6 @@
               </a:spcAft>
               <a:buNone/>
             </a:pPr>
-            <a:r>
-              <a:t/>
-            </a:r>
             <a:endParaRPr/>
           </a:p>
         </p:txBody>
@@ -1610,11 +1670,11 @@
 </file>
 
 <file path=ppt/notesSlides/notesSlide5.xml><?xml version="1.0" encoding="utf-8"?>
-<p:notes xmlns:a="http://schemas.openxmlformats.org/drawingml/2006/main" xmlns:r="http://schemas.openxmlformats.org/officeDocument/2006/relationships" xmlns:mc="http://schemas.openxmlformats.org/markup-compatibility/2006" xmlns:mv="urn:schemas-microsoft-com:mac:vml" xmlns:p="http://schemas.openxmlformats.org/presentationml/2006/main" xmlns:c="http://schemas.openxmlformats.org/drawingml/2006/chart" xmlns:dgm="http://schemas.openxmlformats.org/drawingml/2006/diagram" xmlns:o="urn:schemas-microsoft-com:office:office" xmlns:v="urn:schemas-microsoft-com:vml" xmlns:pvml="urn:schemas-microsoft-com:office:powerpoint" xmlns:com="http://schemas.openxmlformats.org/drawingml/2006/compatibility" xmlns:p14="http://schemas.microsoft.com/office/powerpoint/2010/main" xmlns:p15="http://schemas.microsoft.com/office/powerpoint/2012/main" xmlns:ahyp="http://schemas.microsoft.com/office/drawing/2018/hyperlinkcolor" showMasterPhAnim="0" showMasterSp="0">
+<p:notes xmlns:a="http://schemas.openxmlformats.org/drawingml/2006/main" xmlns:r="http://schemas.openxmlformats.org/officeDocument/2006/relationships" xmlns:p="http://schemas.openxmlformats.org/presentationml/2006/main" showMasterSp="0" showMasterPhAnim="0">
   <p:cSld>
     <p:spTree>
       <p:nvGrpSpPr>
-        <p:cNvPr id="76" name="Shape 76"/>
+        <p:cNvPr id="1" name="Shape 76"/>
         <p:cNvGrpSpPr/>
         <p:nvPr/>
       </p:nvGrpSpPr>
@@ -1629,9 +1689,11 @@
       <p:sp>
         <p:nvSpPr>
           <p:cNvPr id="77" name="Google Shape;77;g3b6c7e62156_0_23:notes"/>
-          <p:cNvSpPr/>
+          <p:cNvSpPr>
+            <a:spLocks noGrp="1" noRot="1" noChangeAspect="1"/>
+          </p:cNvSpPr>
           <p:nvPr>
-            <p:ph idx="2" type="sldImg"/>
+            <p:ph type="sldImg" idx="2"/>
           </p:nvPr>
         </p:nvSpPr>
         <p:spPr>
@@ -1640,9 +1702,13 @@
             <a:ext cx="6096000" cy="3429000"/>
           </a:xfrm>
           <a:custGeom>
-            <a:rect b="b" l="l" r="r" t="t"/>
+            <a:avLst/>
+            <a:gdLst/>
+            <a:ahLst/>
+            <a:cxnLst/>
+            <a:rect l="l" t="t" r="r" b="b"/>
             <a:pathLst>
-              <a:path extrusionOk="0" h="120000" w="120000">
+              <a:path w="120000" h="120000" extrusionOk="0">
                 <a:moveTo>
                   <a:pt x="0" y="0"/>
                 </a:moveTo>
@@ -1664,9 +1730,11 @@
       <p:sp>
         <p:nvSpPr>
           <p:cNvPr id="78" name="Google Shape;78;g3b6c7e62156_0_23:notes"/>
-          <p:cNvSpPr txBox="1"/>
+          <p:cNvSpPr txBox="1">
+            <a:spLocks noGrp="1"/>
+          </p:cNvSpPr>
           <p:nvPr>
-            <p:ph idx="1" type="body"/>
+            <p:ph type="body" idx="1"/>
           </p:nvPr>
         </p:nvSpPr>
         <p:spPr>
@@ -1679,12 +1747,12 @@
           </a:prstGeom>
         </p:spPr>
         <p:txBody>
-          <a:bodyPr anchorCtr="0" anchor="t" bIns="91425" lIns="91425" spcFirstLastPara="1" rIns="91425" wrap="square" tIns="91425">
+          <a:bodyPr spcFirstLastPara="1" wrap="square" lIns="91425" tIns="91425" rIns="91425" bIns="91425" anchor="t" anchorCtr="0">
             <a:noAutofit/>
           </a:bodyPr>
           <a:lstStyle/>
           <a:p>
-            <a:pPr indent="0" lvl="0" marL="0" rtl="0" algn="l">
+            <a:pPr marL="0" lvl="0" indent="0" algn="l" rtl="0">
               <a:spcBef>
                 <a:spcPts val="0"/>
               </a:spcBef>
@@ -1693,9 +1761,6 @@
               </a:spcAft>
               <a:buNone/>
             </a:pPr>
-            <a:r>
-              <a:t/>
-            </a:r>
             <a:endParaRPr/>
           </a:p>
         </p:txBody>
@@ -1709,11 +1774,11 @@
 </file>
 
 <file path=ppt/notesSlides/notesSlide6.xml><?xml version="1.0" encoding="utf-8"?>
-<p:notes xmlns:a="http://schemas.openxmlformats.org/drawingml/2006/main" xmlns:r="http://schemas.openxmlformats.org/officeDocument/2006/relationships" xmlns:mc="http://schemas.openxmlformats.org/markup-compatibility/2006" xmlns:mv="urn:schemas-microsoft-com:mac:vml" xmlns:p="http://schemas.openxmlformats.org/presentationml/2006/main" xmlns:c="http://schemas.openxmlformats.org/drawingml/2006/chart" xmlns:dgm="http://schemas.openxmlformats.org/drawingml/2006/diagram" xmlns:o="urn:schemas-microsoft-com:office:office" xmlns:v="urn:schemas-microsoft-com:vml" xmlns:pvml="urn:schemas-microsoft-com:office:powerpoint" xmlns:com="http://schemas.openxmlformats.org/drawingml/2006/compatibility" xmlns:p14="http://schemas.microsoft.com/office/powerpoint/2010/main" xmlns:p15="http://schemas.microsoft.com/office/powerpoint/2012/main" xmlns:ahyp="http://schemas.microsoft.com/office/drawing/2018/hyperlinkcolor" showMasterPhAnim="0" showMasterSp="0">
+<p:notes xmlns:a="http://schemas.openxmlformats.org/drawingml/2006/main" xmlns:r="http://schemas.openxmlformats.org/officeDocument/2006/relationships" xmlns:p="http://schemas.openxmlformats.org/presentationml/2006/main" showMasterSp="0" showMasterPhAnim="0">
   <p:cSld>
     <p:spTree>
       <p:nvGrpSpPr>
-        <p:cNvPr id="82" name="Shape 82"/>
+        <p:cNvPr id="1" name="Shape 82"/>
         <p:cNvGrpSpPr/>
         <p:nvPr/>
       </p:nvGrpSpPr>
@@ -1728,9 +1793,11 @@
       <p:sp>
         <p:nvSpPr>
           <p:cNvPr id="83" name="Google Shape;83;g3b6c7e62156_0_28:notes"/>
-          <p:cNvSpPr/>
+          <p:cNvSpPr>
+            <a:spLocks noGrp="1" noRot="1" noChangeAspect="1"/>
+          </p:cNvSpPr>
           <p:nvPr>
-            <p:ph idx="2" type="sldImg"/>
+            <p:ph type="sldImg" idx="2"/>
           </p:nvPr>
         </p:nvSpPr>
         <p:spPr>
@@ -1739,9 +1806,13 @@
             <a:ext cx="6096000" cy="3429000"/>
           </a:xfrm>
           <a:custGeom>
-            <a:rect b="b" l="l" r="r" t="t"/>
+            <a:avLst/>
+            <a:gdLst/>
+            <a:ahLst/>
+            <a:cxnLst/>
+            <a:rect l="l" t="t" r="r" b="b"/>
             <a:pathLst>
-              <a:path extrusionOk="0" h="120000" w="120000">
+              <a:path w="120000" h="120000" extrusionOk="0">
                 <a:moveTo>
                   <a:pt x="0" y="0"/>
                 </a:moveTo>
@@ -1763,9 +1834,11 @@
       <p:sp>
         <p:nvSpPr>
           <p:cNvPr id="84" name="Google Shape;84;g3b6c7e62156_0_28:notes"/>
-          <p:cNvSpPr txBox="1"/>
+          <p:cNvSpPr txBox="1">
+            <a:spLocks noGrp="1"/>
+          </p:cNvSpPr>
           <p:nvPr>
-            <p:ph idx="1" type="body"/>
+            <p:ph type="body" idx="1"/>
           </p:nvPr>
         </p:nvSpPr>
         <p:spPr>
@@ -1778,12 +1851,12 @@
           </a:prstGeom>
         </p:spPr>
         <p:txBody>
-          <a:bodyPr anchorCtr="0" anchor="t" bIns="91425" lIns="91425" spcFirstLastPara="1" rIns="91425" wrap="square" tIns="91425">
+          <a:bodyPr spcFirstLastPara="1" wrap="square" lIns="91425" tIns="91425" rIns="91425" bIns="91425" anchor="t" anchorCtr="0">
             <a:noAutofit/>
           </a:bodyPr>
           <a:lstStyle/>
           <a:p>
-            <a:pPr indent="0" lvl="0" marL="0" rtl="0" algn="l">
+            <a:pPr marL="0" lvl="0" indent="0" algn="l" rtl="0">
               <a:spcBef>
                 <a:spcPts val="0"/>
               </a:spcBef>
@@ -1792,9 +1865,6 @@
               </a:spcAft>
               <a:buNone/>
             </a:pPr>
-            <a:r>
-              <a:t/>
-            </a:r>
             <a:endParaRPr/>
           </a:p>
         </p:txBody>
@@ -1808,11 +1878,11 @@
 </file>
 
 <file path=ppt/notesSlides/notesSlide7.xml><?xml version="1.0" encoding="utf-8"?>
-<p:notes xmlns:a="http://schemas.openxmlformats.org/drawingml/2006/main" xmlns:r="http://schemas.openxmlformats.org/officeDocument/2006/relationships" xmlns:mc="http://schemas.openxmlformats.org/markup-compatibility/2006" xmlns:mv="urn:schemas-microsoft-com:mac:vml" xmlns:p="http://schemas.openxmlformats.org/presentationml/2006/main" xmlns:c="http://schemas.openxmlformats.org/drawingml/2006/chart" xmlns:dgm="http://schemas.openxmlformats.org/drawingml/2006/diagram" xmlns:o="urn:schemas-microsoft-com:office:office" xmlns:v="urn:schemas-microsoft-com:vml" xmlns:pvml="urn:schemas-microsoft-com:office:powerpoint" xmlns:com="http://schemas.openxmlformats.org/drawingml/2006/compatibility" xmlns:p14="http://schemas.microsoft.com/office/powerpoint/2010/main" xmlns:p15="http://schemas.microsoft.com/office/powerpoint/2012/main" xmlns:ahyp="http://schemas.microsoft.com/office/drawing/2018/hyperlinkcolor" showMasterPhAnim="0" showMasterSp="0">
+<p:notes xmlns:a="http://schemas.openxmlformats.org/drawingml/2006/main" xmlns:r="http://schemas.openxmlformats.org/officeDocument/2006/relationships" xmlns:p="http://schemas.openxmlformats.org/presentationml/2006/main" showMasterSp="0" showMasterPhAnim="0">
   <p:cSld>
     <p:spTree>
       <p:nvGrpSpPr>
-        <p:cNvPr id="88" name="Shape 88"/>
+        <p:cNvPr id="1" name="Shape 88"/>
         <p:cNvGrpSpPr/>
         <p:nvPr/>
       </p:nvGrpSpPr>
@@ -1827,9 +1897,11 @@
       <p:sp>
         <p:nvSpPr>
           <p:cNvPr id="89" name="Google Shape;89;g3b6c7e62156_0_33:notes"/>
-          <p:cNvSpPr/>
+          <p:cNvSpPr>
+            <a:spLocks noGrp="1" noRot="1" noChangeAspect="1"/>
+          </p:cNvSpPr>
           <p:nvPr>
-            <p:ph idx="2" type="sldImg"/>
+            <p:ph type="sldImg" idx="2"/>
           </p:nvPr>
         </p:nvSpPr>
         <p:spPr>
@@ -1838,9 +1910,13 @@
             <a:ext cx="6096000" cy="3429000"/>
           </a:xfrm>
           <a:custGeom>
-            <a:rect b="b" l="l" r="r" t="t"/>
+            <a:avLst/>
+            <a:gdLst/>
+            <a:ahLst/>
+            <a:cxnLst/>
+            <a:rect l="l" t="t" r="r" b="b"/>
             <a:pathLst>
-              <a:path extrusionOk="0" h="120000" w="120000">
+              <a:path w="120000" h="120000" extrusionOk="0">
                 <a:moveTo>
                   <a:pt x="0" y="0"/>
                 </a:moveTo>
@@ -1862,9 +1938,11 @@
       <p:sp>
         <p:nvSpPr>
           <p:cNvPr id="90" name="Google Shape;90;g3b6c7e62156_0_33:notes"/>
-          <p:cNvSpPr txBox="1"/>
+          <p:cNvSpPr txBox="1">
+            <a:spLocks noGrp="1"/>
+          </p:cNvSpPr>
           <p:nvPr>
-            <p:ph idx="1" type="body"/>
+            <p:ph type="body" idx="1"/>
           </p:nvPr>
         </p:nvSpPr>
         <p:spPr>
@@ -1877,12 +1955,12 @@
           </a:prstGeom>
         </p:spPr>
         <p:txBody>
-          <a:bodyPr anchorCtr="0" anchor="t" bIns="91425" lIns="91425" spcFirstLastPara="1" rIns="91425" wrap="square" tIns="91425">
+          <a:bodyPr spcFirstLastPara="1" wrap="square" lIns="91425" tIns="91425" rIns="91425" bIns="91425" anchor="t" anchorCtr="0">
             <a:noAutofit/>
           </a:bodyPr>
           <a:lstStyle/>
           <a:p>
-            <a:pPr indent="0" lvl="0" marL="0" rtl="0" algn="l">
+            <a:pPr marL="0" lvl="0" indent="0" algn="l" rtl="0">
               <a:spcBef>
                 <a:spcPts val="0"/>
               </a:spcBef>
@@ -1891,9 +1969,6 @@
               </a:spcAft>
               <a:buNone/>
             </a:pPr>
-            <a:r>
-              <a:t/>
-            </a:r>
             <a:endParaRPr/>
           </a:p>
         </p:txBody>
@@ -1907,11 +1982,11 @@
 </file>
 
 <file path=ppt/notesSlides/notesSlide8.xml><?xml version="1.0" encoding="utf-8"?>
-<p:notes xmlns:a="http://schemas.openxmlformats.org/drawingml/2006/main" xmlns:r="http://schemas.openxmlformats.org/officeDocument/2006/relationships" xmlns:mc="http://schemas.openxmlformats.org/markup-compatibility/2006" xmlns:mv="urn:schemas-microsoft-com:mac:vml" xmlns:p="http://schemas.openxmlformats.org/presentationml/2006/main" xmlns:c="http://schemas.openxmlformats.org/drawingml/2006/chart" xmlns:dgm="http://schemas.openxmlformats.org/drawingml/2006/diagram" xmlns:o="urn:schemas-microsoft-com:office:office" xmlns:v="urn:schemas-microsoft-com:vml" xmlns:pvml="urn:schemas-microsoft-com:office:powerpoint" xmlns:com="http://schemas.openxmlformats.org/drawingml/2006/compatibility" xmlns:p14="http://schemas.microsoft.com/office/powerpoint/2010/main" xmlns:p15="http://schemas.microsoft.com/office/powerpoint/2012/main" xmlns:ahyp="http://schemas.microsoft.com/office/drawing/2018/hyperlinkcolor" showMasterPhAnim="0" showMasterSp="0">
+<p:notes xmlns:a="http://schemas.openxmlformats.org/drawingml/2006/main" xmlns:r="http://schemas.openxmlformats.org/officeDocument/2006/relationships" xmlns:p="http://schemas.openxmlformats.org/presentationml/2006/main" showMasterSp="0" showMasterPhAnim="0">
   <p:cSld>
     <p:spTree>
       <p:nvGrpSpPr>
-        <p:cNvPr id="94" name="Shape 94"/>
+        <p:cNvPr id="1" name="Shape 94"/>
         <p:cNvGrpSpPr/>
         <p:nvPr/>
       </p:nvGrpSpPr>
@@ -1926,9 +2001,11 @@
       <p:sp>
         <p:nvSpPr>
           <p:cNvPr id="95" name="Google Shape;95;g3b6c7e62156_0_38:notes"/>
-          <p:cNvSpPr/>
+          <p:cNvSpPr>
+            <a:spLocks noGrp="1" noRot="1" noChangeAspect="1"/>
+          </p:cNvSpPr>
           <p:nvPr>
-            <p:ph idx="2" type="sldImg"/>
+            <p:ph type="sldImg" idx="2"/>
           </p:nvPr>
         </p:nvSpPr>
         <p:spPr>
@@ -1937,9 +2014,13 @@
             <a:ext cx="6096000" cy="3429000"/>
           </a:xfrm>
           <a:custGeom>
-            <a:rect b="b" l="l" r="r" t="t"/>
+            <a:avLst/>
+            <a:gdLst/>
+            <a:ahLst/>
+            <a:cxnLst/>
+            <a:rect l="l" t="t" r="r" b="b"/>
             <a:pathLst>
-              <a:path extrusionOk="0" h="120000" w="120000">
+              <a:path w="120000" h="120000" extrusionOk="0">
                 <a:moveTo>
                   <a:pt x="0" y="0"/>
                 </a:moveTo>
@@ -1961,9 +2042,11 @@
       <p:sp>
         <p:nvSpPr>
           <p:cNvPr id="96" name="Google Shape;96;g3b6c7e62156_0_38:notes"/>
-          <p:cNvSpPr txBox="1"/>
+          <p:cNvSpPr txBox="1">
+            <a:spLocks noGrp="1"/>
+          </p:cNvSpPr>
           <p:nvPr>
-            <p:ph idx="1" type="body"/>
+            <p:ph type="body" idx="1"/>
           </p:nvPr>
         </p:nvSpPr>
         <p:spPr>
@@ -1976,12 +2059,12 @@
           </a:prstGeom>
         </p:spPr>
         <p:txBody>
-          <a:bodyPr anchorCtr="0" anchor="t" bIns="91425" lIns="91425" spcFirstLastPara="1" rIns="91425" wrap="square" tIns="91425">
+          <a:bodyPr spcFirstLastPara="1" wrap="square" lIns="91425" tIns="91425" rIns="91425" bIns="91425" anchor="t" anchorCtr="0">
             <a:noAutofit/>
           </a:bodyPr>
           <a:lstStyle/>
           <a:p>
-            <a:pPr indent="0" lvl="0" marL="0" rtl="0" algn="l">
+            <a:pPr marL="0" lvl="0" indent="0" algn="l" rtl="0">
               <a:spcBef>
                 <a:spcPts val="0"/>
               </a:spcBef>
@@ -1990,9 +2073,6 @@
               </a:spcAft>
               <a:buNone/>
             </a:pPr>
-            <a:r>
-              <a:t/>
-            </a:r>
             <a:endParaRPr/>
           </a:p>
         </p:txBody>
@@ -2006,11 +2086,11 @@
 </file>
 
 <file path=ppt/notesSlides/notesSlide9.xml><?xml version="1.0" encoding="utf-8"?>
-<p:notes xmlns:a="http://schemas.openxmlformats.org/drawingml/2006/main" xmlns:r="http://schemas.openxmlformats.org/officeDocument/2006/relationships" xmlns:mc="http://schemas.openxmlformats.org/markup-compatibility/2006" xmlns:mv="urn:schemas-microsoft-com:mac:vml" xmlns:p="http://schemas.openxmlformats.org/presentationml/2006/main" xmlns:c="http://schemas.openxmlformats.org/drawingml/2006/chart" xmlns:dgm="http://schemas.openxmlformats.org/drawingml/2006/diagram" xmlns:o="urn:schemas-microsoft-com:office:office" xmlns:v="urn:schemas-microsoft-com:vml" xmlns:pvml="urn:schemas-microsoft-com:office:powerpoint" xmlns:com="http://schemas.openxmlformats.org/drawingml/2006/compatibility" xmlns:p14="http://schemas.microsoft.com/office/powerpoint/2010/main" xmlns:p15="http://schemas.microsoft.com/office/powerpoint/2012/main" xmlns:ahyp="http://schemas.microsoft.com/office/drawing/2018/hyperlinkcolor" showMasterPhAnim="0" showMasterSp="0">
+<p:notes xmlns:a="http://schemas.openxmlformats.org/drawingml/2006/main" xmlns:r="http://schemas.openxmlformats.org/officeDocument/2006/relationships" xmlns:p="http://schemas.openxmlformats.org/presentationml/2006/main" showMasterSp="0" showMasterPhAnim="0">
   <p:cSld>
     <p:spTree>
       <p:nvGrpSpPr>
-        <p:cNvPr id="100" name="Shape 100"/>
+        <p:cNvPr id="1" name="Shape 100"/>
         <p:cNvGrpSpPr/>
         <p:nvPr/>
       </p:nvGrpSpPr>
@@ -2025,9 +2105,11 @@
       <p:sp>
         <p:nvSpPr>
           <p:cNvPr id="101" name="Google Shape;101;g3b6c7e62156_0_43:notes"/>
-          <p:cNvSpPr/>
+          <p:cNvSpPr>
+            <a:spLocks noGrp="1" noRot="1" noChangeAspect="1"/>
+          </p:cNvSpPr>
           <p:nvPr>
-            <p:ph idx="2" type="sldImg"/>
+            <p:ph type="sldImg" idx="2"/>
           </p:nvPr>
         </p:nvSpPr>
         <p:spPr>
@@ -2036,9 +2118,13 @@
             <a:ext cx="6096000" cy="3429000"/>
           </a:xfrm>
           <a:custGeom>
-            <a:rect b="b" l="l" r="r" t="t"/>
+            <a:avLst/>
+            <a:gdLst/>
+            <a:ahLst/>
+            <a:cxnLst/>
+            <a:rect l="l" t="t" r="r" b="b"/>
             <a:pathLst>
-              <a:path extrusionOk="0" h="120000" w="120000">
+              <a:path w="120000" h="120000" extrusionOk="0">
                 <a:moveTo>
                   <a:pt x="0" y="0"/>
                 </a:moveTo>
@@ -2060,9 +2146,11 @@
       <p:sp>
         <p:nvSpPr>
           <p:cNvPr id="102" name="Google Shape;102;g3b6c7e62156_0_43:notes"/>
-          <p:cNvSpPr txBox="1"/>
+          <p:cNvSpPr txBox="1">
+            <a:spLocks noGrp="1"/>
+          </p:cNvSpPr>
           <p:nvPr>
-            <p:ph idx="1" type="body"/>
+            <p:ph type="body" idx="1"/>
           </p:nvPr>
         </p:nvSpPr>
         <p:spPr>
@@ -2075,12 +2163,12 @@
           </a:prstGeom>
         </p:spPr>
         <p:txBody>
-          <a:bodyPr anchorCtr="0" anchor="t" bIns="91425" lIns="91425" spcFirstLastPara="1" rIns="91425" wrap="square" tIns="91425">
+          <a:bodyPr spcFirstLastPara="1" wrap="square" lIns="91425" tIns="91425" rIns="91425" bIns="91425" anchor="t" anchorCtr="0">
             <a:noAutofit/>
           </a:bodyPr>
           <a:lstStyle/>
           <a:p>
-            <a:pPr indent="0" lvl="0" marL="0" rtl="0" algn="l">
+            <a:pPr marL="0" lvl="0" indent="0" algn="l" rtl="0">
               <a:spcBef>
                 <a:spcPts val="0"/>
               </a:spcBef>
@@ -2089,9 +2177,6 @@
               </a:spcAft>
               <a:buNone/>
             </a:pPr>
-            <a:r>
-              <a:t/>
-            </a:r>
             <a:endParaRPr/>
           </a:p>
         </p:txBody>
@@ -2105,11 +2190,11 @@
 </file>
 
 <file path=ppt/slideLayouts/slideLayout1.xml><?xml version="1.0" encoding="utf-8"?>
-<p:sldLayout xmlns:a="http://schemas.openxmlformats.org/drawingml/2006/main" xmlns:r="http://schemas.openxmlformats.org/officeDocument/2006/relationships" xmlns:mc="http://schemas.openxmlformats.org/markup-compatibility/2006" xmlns:mv="urn:schemas-microsoft-com:mac:vml" xmlns:p="http://schemas.openxmlformats.org/presentationml/2006/main" xmlns:c="http://schemas.openxmlformats.org/drawingml/2006/chart" xmlns:dgm="http://schemas.openxmlformats.org/drawingml/2006/diagram" xmlns:o="urn:schemas-microsoft-com:office:office" xmlns:v="urn:schemas-microsoft-com:vml" xmlns:pvml="urn:schemas-microsoft-com:office:powerpoint" xmlns:com="http://schemas.openxmlformats.org/drawingml/2006/compatibility" xmlns:p14="http://schemas.microsoft.com/office/powerpoint/2010/main" xmlns:p15="http://schemas.microsoft.com/office/powerpoint/2012/main" xmlns:ahyp="http://schemas.microsoft.com/office/drawing/2018/hyperlinkcolor" matchingName="Title slide" type="title">
+<p:sldLayout xmlns:a="http://schemas.openxmlformats.org/drawingml/2006/main" xmlns:r="http://schemas.openxmlformats.org/officeDocument/2006/relationships" xmlns:p="http://schemas.openxmlformats.org/presentationml/2006/main" matchingName="Title slide" type="title">
   <p:cSld name="TITLE">
     <p:spTree>
       <p:nvGrpSpPr>
-        <p:cNvPr id="9" name="Shape 9"/>
+        <p:cNvPr id="1" name="Shape 9"/>
         <p:cNvGrpSpPr/>
         <p:nvPr/>
       </p:nvGrpSpPr>
@@ -2124,7 +2209,9 @@
       <p:sp>
         <p:nvSpPr>
           <p:cNvPr id="10" name="Google Shape;10;p2"/>
-          <p:cNvSpPr txBox="1"/>
+          <p:cNvSpPr txBox="1">
+            <a:spLocks noGrp="1"/>
+          </p:cNvSpPr>
           <p:nvPr>
             <p:ph type="ctrTitle"/>
           </p:nvPr>
@@ -2139,7 +2226,7 @@
           </a:prstGeom>
         </p:spPr>
         <p:txBody>
-          <a:bodyPr anchorCtr="0" anchor="b" bIns="91425" lIns="91425" spcFirstLastPara="1" rIns="91425" wrap="square" tIns="91425">
+          <a:bodyPr spcFirstLastPara="1" wrap="square" lIns="91425" tIns="91425" rIns="91425" bIns="91425" anchor="b" anchorCtr="0">
             <a:normAutofit/>
           </a:bodyPr>
           <a:lstStyle>
@@ -2243,15 +2330,19 @@
               <a:defRPr sz="5200"/>
             </a:lvl9pPr>
           </a:lstStyle>
-          <a:p/>
+          <a:p>
+            <a:endParaRPr/>
+          </a:p>
         </p:txBody>
       </p:sp>
       <p:sp>
         <p:nvSpPr>
           <p:cNvPr id="11" name="Google Shape;11;p2"/>
-          <p:cNvSpPr txBox="1"/>
+          <p:cNvSpPr txBox="1">
+            <a:spLocks noGrp="1"/>
+          </p:cNvSpPr>
           <p:nvPr>
-            <p:ph idx="1" type="subTitle"/>
+            <p:ph type="subTitle" idx="1"/>
           </p:nvPr>
         </p:nvSpPr>
         <p:spPr>
@@ -2264,7 +2355,7 @@
           </a:prstGeom>
         </p:spPr>
         <p:txBody>
-          <a:bodyPr anchorCtr="0" anchor="t" bIns="91425" lIns="91425" spcFirstLastPara="1" rIns="91425" wrap="square" tIns="91425">
+          <a:bodyPr spcFirstLastPara="1" wrap="square" lIns="91425" tIns="91425" rIns="91425" bIns="91425" anchor="t" anchorCtr="0">
             <a:normAutofit/>
           </a:bodyPr>
           <a:lstStyle>
@@ -2395,15 +2486,19 @@
               <a:defRPr sz="2800"/>
             </a:lvl9pPr>
           </a:lstStyle>
-          <a:p/>
+          <a:p>
+            <a:endParaRPr/>
+          </a:p>
         </p:txBody>
       </p:sp>
       <p:sp>
         <p:nvSpPr>
           <p:cNvPr id="12" name="Google Shape;12;p2"/>
-          <p:cNvSpPr txBox="1"/>
+          <p:cNvSpPr txBox="1">
+            <a:spLocks noGrp="1"/>
+          </p:cNvSpPr>
           <p:nvPr>
-            <p:ph idx="12" type="sldNum"/>
+            <p:ph type="sldNum" idx="12"/>
           </p:nvPr>
         </p:nvSpPr>
         <p:spPr>
@@ -2416,7 +2511,7 @@
           </a:prstGeom>
         </p:spPr>
         <p:txBody>
-          <a:bodyPr anchorCtr="0" anchor="ctr" bIns="91425" lIns="91425" spcFirstLastPara="1" rIns="91425" wrap="square" tIns="91425">
+          <a:bodyPr spcFirstLastPara="1" wrap="square" lIns="91425" tIns="91425" rIns="91425" bIns="91425" anchor="ctr" anchorCtr="0">
             <a:normAutofit/>
           </a:bodyPr>
           <a:lstStyle>
@@ -2458,7 +2553,7 @@
             </a:lvl9pPr>
           </a:lstStyle>
           <a:p>
-            <a:pPr indent="0" lvl="0" marL="0" rtl="0" algn="r">
+            <a:pPr marL="0" lvl="0" indent="0" algn="r" rtl="0">
               <a:spcBef>
                 <a:spcPts val="0"/>
               </a:spcBef>
@@ -2484,11 +2579,11 @@
 </file>
 
 <file path=ppt/slideLayouts/slideLayout10.xml><?xml version="1.0" encoding="utf-8"?>
-<p:sldLayout xmlns:a="http://schemas.openxmlformats.org/drawingml/2006/main" xmlns:r="http://schemas.openxmlformats.org/officeDocument/2006/relationships" xmlns:mc="http://schemas.openxmlformats.org/markup-compatibility/2006" xmlns:mv="urn:schemas-microsoft-com:mac:vml" xmlns:p="http://schemas.openxmlformats.org/presentationml/2006/main" xmlns:c="http://schemas.openxmlformats.org/drawingml/2006/chart" xmlns:dgm="http://schemas.openxmlformats.org/drawingml/2006/diagram" xmlns:o="urn:schemas-microsoft-com:office:office" xmlns:v="urn:schemas-microsoft-com:vml" xmlns:pvml="urn:schemas-microsoft-com:office:powerpoint" xmlns:com="http://schemas.openxmlformats.org/drawingml/2006/compatibility" xmlns:p14="http://schemas.microsoft.com/office/powerpoint/2010/main" xmlns:p15="http://schemas.microsoft.com/office/powerpoint/2012/main" xmlns:ahyp="http://schemas.microsoft.com/office/drawing/2018/hyperlinkcolor" matchingName="Big number">
+<p:sldLayout xmlns:a="http://schemas.openxmlformats.org/drawingml/2006/main" xmlns:r="http://schemas.openxmlformats.org/officeDocument/2006/relationships" xmlns:p="http://schemas.openxmlformats.org/presentationml/2006/main" matchingName="Big number">
   <p:cSld name="BIG_NUMBER">
     <p:spTree>
       <p:nvGrpSpPr>
-        <p:cNvPr id="44" name="Shape 44"/>
+        <p:cNvPr id="1" name="Shape 44"/>
         <p:cNvGrpSpPr/>
         <p:nvPr/>
       </p:nvGrpSpPr>
@@ -2503,9 +2598,11 @@
       <p:sp>
         <p:nvSpPr>
           <p:cNvPr id="45" name="Google Shape;45;p11"/>
-          <p:cNvSpPr txBox="1"/>
+          <p:cNvSpPr txBox="1">
+            <a:spLocks noGrp="1"/>
+          </p:cNvSpPr>
           <p:nvPr>
-            <p:ph hasCustomPrompt="1" type="title"/>
+            <p:ph type="title" hasCustomPrompt="1"/>
           </p:nvPr>
         </p:nvSpPr>
         <p:spPr>
@@ -2518,7 +2615,7 @@
           </a:prstGeom>
         </p:spPr>
         <p:txBody>
-          <a:bodyPr anchorCtr="0" anchor="b" bIns="91425" lIns="91425" spcFirstLastPara="1" rIns="91425" wrap="square" tIns="91425">
+          <a:bodyPr spcFirstLastPara="1" wrap="square" lIns="91425" tIns="91425" rIns="91425" bIns="91425" anchor="b" anchorCtr="0">
             <a:normAutofit/>
           </a:bodyPr>
           <a:lstStyle>
@@ -2632,9 +2729,11 @@
       <p:sp>
         <p:nvSpPr>
           <p:cNvPr id="46" name="Google Shape;46;p11"/>
-          <p:cNvSpPr txBox="1"/>
+          <p:cNvSpPr txBox="1">
+            <a:spLocks noGrp="1"/>
+          </p:cNvSpPr>
           <p:nvPr>
-            <p:ph idx="1" type="body"/>
+            <p:ph type="body" idx="1"/>
           </p:nvPr>
         </p:nvSpPr>
         <p:spPr>
@@ -2647,11 +2746,11 @@
           </a:prstGeom>
         </p:spPr>
         <p:txBody>
-          <a:bodyPr anchorCtr="0" anchor="t" bIns="91425" lIns="91425" spcFirstLastPara="1" rIns="91425" wrap="square" tIns="91425">
+          <a:bodyPr spcFirstLastPara="1" wrap="square" lIns="91425" tIns="91425" rIns="91425" bIns="91425" anchor="t" anchorCtr="0">
             <a:normAutofit/>
           </a:bodyPr>
           <a:lstStyle>
-            <a:lvl1pPr indent="-342900" lvl="0" marL="457200" algn="ctr">
+            <a:lvl1pPr marL="457200" lvl="0" indent="-342900" algn="ctr">
               <a:spcBef>
                 <a:spcPts val="0"/>
               </a:spcBef>
@@ -2662,7 +2761,7 @@
               <a:buChar char="●"/>
               <a:defRPr/>
             </a:lvl1pPr>
-            <a:lvl2pPr indent="-317500" lvl="1" marL="914400" algn="ctr">
+            <a:lvl2pPr marL="914400" lvl="1" indent="-317500" algn="ctr">
               <a:spcBef>
                 <a:spcPts val="0"/>
               </a:spcBef>
@@ -2673,7 +2772,7 @@
               <a:buChar char="○"/>
               <a:defRPr/>
             </a:lvl2pPr>
-            <a:lvl3pPr indent="-317500" lvl="2" marL="1371600" algn="ctr">
+            <a:lvl3pPr marL="1371600" lvl="2" indent="-317500" algn="ctr">
               <a:spcBef>
                 <a:spcPts val="0"/>
               </a:spcBef>
@@ -2684,7 +2783,7 @@
               <a:buChar char="■"/>
               <a:defRPr/>
             </a:lvl3pPr>
-            <a:lvl4pPr indent="-317500" lvl="3" marL="1828800" algn="ctr">
+            <a:lvl4pPr marL="1828800" lvl="3" indent="-317500" algn="ctr">
               <a:spcBef>
                 <a:spcPts val="0"/>
               </a:spcBef>
@@ -2695,7 +2794,7 @@
               <a:buChar char="●"/>
               <a:defRPr/>
             </a:lvl4pPr>
-            <a:lvl5pPr indent="-317500" lvl="4" marL="2286000" algn="ctr">
+            <a:lvl5pPr marL="2286000" lvl="4" indent="-317500" algn="ctr">
               <a:spcBef>
                 <a:spcPts val="0"/>
               </a:spcBef>
@@ -2706,7 +2805,7 @@
               <a:buChar char="○"/>
               <a:defRPr/>
             </a:lvl5pPr>
-            <a:lvl6pPr indent="-317500" lvl="5" marL="2743200" algn="ctr">
+            <a:lvl6pPr marL="2743200" lvl="5" indent="-317500" algn="ctr">
               <a:spcBef>
                 <a:spcPts val="0"/>
               </a:spcBef>
@@ -2717,7 +2816,7 @@
               <a:buChar char="■"/>
               <a:defRPr/>
             </a:lvl6pPr>
-            <a:lvl7pPr indent="-317500" lvl="6" marL="3200400" algn="ctr">
+            <a:lvl7pPr marL="3200400" lvl="6" indent="-317500" algn="ctr">
               <a:spcBef>
                 <a:spcPts val="0"/>
               </a:spcBef>
@@ -2728,7 +2827,7 @@
               <a:buChar char="●"/>
               <a:defRPr/>
             </a:lvl7pPr>
-            <a:lvl8pPr indent="-317500" lvl="7" marL="3657600" algn="ctr">
+            <a:lvl8pPr marL="3657600" lvl="7" indent="-317500" algn="ctr">
               <a:spcBef>
                 <a:spcPts val="0"/>
               </a:spcBef>
@@ -2739,7 +2838,7 @@
               <a:buChar char="○"/>
               <a:defRPr/>
             </a:lvl8pPr>
-            <a:lvl9pPr indent="-317500" lvl="8" marL="4114800" algn="ctr">
+            <a:lvl9pPr marL="4114800" lvl="8" indent="-317500" algn="ctr">
               <a:spcBef>
                 <a:spcPts val="0"/>
               </a:spcBef>
@@ -2751,15 +2850,19 @@
               <a:defRPr/>
             </a:lvl9pPr>
           </a:lstStyle>
-          <a:p/>
+          <a:p>
+            <a:endParaRPr/>
+          </a:p>
         </p:txBody>
       </p:sp>
       <p:sp>
         <p:nvSpPr>
           <p:cNvPr id="47" name="Google Shape;47;p11"/>
-          <p:cNvSpPr txBox="1"/>
+          <p:cNvSpPr txBox="1">
+            <a:spLocks noGrp="1"/>
+          </p:cNvSpPr>
           <p:nvPr>
-            <p:ph idx="12" type="sldNum"/>
+            <p:ph type="sldNum" idx="12"/>
           </p:nvPr>
         </p:nvSpPr>
         <p:spPr>
@@ -2772,7 +2875,7 @@
           </a:prstGeom>
         </p:spPr>
         <p:txBody>
-          <a:bodyPr anchorCtr="0" anchor="ctr" bIns="91425" lIns="91425" spcFirstLastPara="1" rIns="91425" wrap="square" tIns="91425">
+          <a:bodyPr spcFirstLastPara="1" wrap="square" lIns="91425" tIns="91425" rIns="91425" bIns="91425" anchor="ctr" anchorCtr="0">
             <a:normAutofit/>
           </a:bodyPr>
           <a:lstStyle>
@@ -2814,7 +2917,7 @@
             </a:lvl9pPr>
           </a:lstStyle>
           <a:p>
-            <a:pPr indent="0" lvl="0" marL="0" rtl="0" algn="r">
+            <a:pPr marL="0" lvl="0" indent="0" algn="r" rtl="0">
               <a:spcBef>
                 <a:spcPts val="0"/>
               </a:spcBef>
@@ -2840,11 +2943,11 @@
 </file>
 
 <file path=ppt/slideLayouts/slideLayout11.xml><?xml version="1.0" encoding="utf-8"?>
-<p:sldLayout xmlns:a="http://schemas.openxmlformats.org/drawingml/2006/main" xmlns:r="http://schemas.openxmlformats.org/officeDocument/2006/relationships" xmlns:mc="http://schemas.openxmlformats.org/markup-compatibility/2006" xmlns:mv="urn:schemas-microsoft-com:mac:vml" xmlns:p="http://schemas.openxmlformats.org/presentationml/2006/main" xmlns:c="http://schemas.openxmlformats.org/drawingml/2006/chart" xmlns:dgm="http://schemas.openxmlformats.org/drawingml/2006/diagram" xmlns:o="urn:schemas-microsoft-com:office:office" xmlns:v="urn:schemas-microsoft-com:vml" xmlns:pvml="urn:schemas-microsoft-com:office:powerpoint" xmlns:com="http://schemas.openxmlformats.org/drawingml/2006/compatibility" xmlns:p14="http://schemas.microsoft.com/office/powerpoint/2010/main" xmlns:p15="http://schemas.microsoft.com/office/powerpoint/2012/main" xmlns:ahyp="http://schemas.microsoft.com/office/drawing/2018/hyperlinkcolor" matchingName="Blank" type="blank">
+<p:sldLayout xmlns:a="http://schemas.openxmlformats.org/drawingml/2006/main" xmlns:r="http://schemas.openxmlformats.org/officeDocument/2006/relationships" xmlns:p="http://schemas.openxmlformats.org/presentationml/2006/main" matchingName="Blank" type="blank">
   <p:cSld name="BLANK">
     <p:spTree>
       <p:nvGrpSpPr>
-        <p:cNvPr id="48" name="Shape 48"/>
+        <p:cNvPr id="1" name="Shape 48"/>
         <p:cNvGrpSpPr/>
         <p:nvPr/>
       </p:nvGrpSpPr>
@@ -2859,9 +2962,11 @@
       <p:sp>
         <p:nvSpPr>
           <p:cNvPr id="49" name="Google Shape;49;p12"/>
-          <p:cNvSpPr txBox="1"/>
+          <p:cNvSpPr txBox="1">
+            <a:spLocks noGrp="1"/>
+          </p:cNvSpPr>
           <p:nvPr>
-            <p:ph idx="12" type="sldNum"/>
+            <p:ph type="sldNum" idx="12"/>
           </p:nvPr>
         </p:nvSpPr>
         <p:spPr>
@@ -2874,7 +2979,7 @@
           </a:prstGeom>
         </p:spPr>
         <p:txBody>
-          <a:bodyPr anchorCtr="0" anchor="ctr" bIns="91425" lIns="91425" spcFirstLastPara="1" rIns="91425" wrap="square" tIns="91425">
+          <a:bodyPr spcFirstLastPara="1" wrap="square" lIns="91425" tIns="91425" rIns="91425" bIns="91425" anchor="ctr" anchorCtr="0">
             <a:normAutofit/>
           </a:bodyPr>
           <a:lstStyle>
@@ -2916,7 +3021,7 @@
             </a:lvl9pPr>
           </a:lstStyle>
           <a:p>
-            <a:pPr indent="0" lvl="0" marL="0" rtl="0" algn="r">
+            <a:pPr marL="0" lvl="0" indent="0" algn="r" rtl="0">
               <a:spcBef>
                 <a:spcPts val="0"/>
               </a:spcBef>
@@ -2942,11 +3047,11 @@
 </file>
 
 <file path=ppt/slideLayouts/slideLayout2.xml><?xml version="1.0" encoding="utf-8"?>
-<p:sldLayout xmlns:a="http://schemas.openxmlformats.org/drawingml/2006/main" xmlns:r="http://schemas.openxmlformats.org/officeDocument/2006/relationships" xmlns:mc="http://schemas.openxmlformats.org/markup-compatibility/2006" xmlns:mv="urn:schemas-microsoft-com:mac:vml" xmlns:p="http://schemas.openxmlformats.org/presentationml/2006/main" xmlns:c="http://schemas.openxmlformats.org/drawingml/2006/chart" xmlns:dgm="http://schemas.openxmlformats.org/drawingml/2006/diagram" xmlns:o="urn:schemas-microsoft-com:office:office" xmlns:v="urn:schemas-microsoft-com:vml" xmlns:pvml="urn:schemas-microsoft-com:office:powerpoint" xmlns:com="http://schemas.openxmlformats.org/drawingml/2006/compatibility" xmlns:p14="http://schemas.microsoft.com/office/powerpoint/2010/main" xmlns:p15="http://schemas.microsoft.com/office/powerpoint/2012/main" xmlns:ahyp="http://schemas.microsoft.com/office/drawing/2018/hyperlinkcolor" matchingName="Section header" type="secHead">
+<p:sldLayout xmlns:a="http://schemas.openxmlformats.org/drawingml/2006/main" xmlns:r="http://schemas.openxmlformats.org/officeDocument/2006/relationships" xmlns:p="http://schemas.openxmlformats.org/presentationml/2006/main" matchingName="Section header" type="secHead">
   <p:cSld name="SECTION_HEADER">
     <p:spTree>
       <p:nvGrpSpPr>
-        <p:cNvPr id="13" name="Shape 13"/>
+        <p:cNvPr id="1" name="Shape 13"/>
         <p:cNvGrpSpPr/>
         <p:nvPr/>
       </p:nvGrpSpPr>
@@ -2961,7 +3066,9 @@
       <p:sp>
         <p:nvSpPr>
           <p:cNvPr id="14" name="Google Shape;14;p3"/>
-          <p:cNvSpPr txBox="1"/>
+          <p:cNvSpPr txBox="1">
+            <a:spLocks noGrp="1"/>
+          </p:cNvSpPr>
           <p:nvPr>
             <p:ph type="title"/>
           </p:nvPr>
@@ -2976,7 +3083,7 @@
           </a:prstGeom>
         </p:spPr>
         <p:txBody>
-          <a:bodyPr anchorCtr="0" anchor="ctr" bIns="91425" lIns="91425" spcFirstLastPara="1" rIns="91425" wrap="square" tIns="91425">
+          <a:bodyPr spcFirstLastPara="1" wrap="square" lIns="91425" tIns="91425" rIns="91425" bIns="91425" anchor="ctr" anchorCtr="0">
             <a:normAutofit/>
           </a:bodyPr>
           <a:lstStyle>
@@ -3080,15 +3187,19 @@
               <a:defRPr sz="3600"/>
             </a:lvl9pPr>
           </a:lstStyle>
-          <a:p/>
+          <a:p>
+            <a:endParaRPr/>
+          </a:p>
         </p:txBody>
       </p:sp>
       <p:sp>
         <p:nvSpPr>
           <p:cNvPr id="15" name="Google Shape;15;p3"/>
-          <p:cNvSpPr txBox="1"/>
+          <p:cNvSpPr txBox="1">
+            <a:spLocks noGrp="1"/>
+          </p:cNvSpPr>
           <p:nvPr>
-            <p:ph idx="12" type="sldNum"/>
+            <p:ph type="sldNum" idx="12"/>
           </p:nvPr>
         </p:nvSpPr>
         <p:spPr>
@@ -3101,7 +3212,7 @@
           </a:prstGeom>
         </p:spPr>
         <p:txBody>
-          <a:bodyPr anchorCtr="0" anchor="ctr" bIns="91425" lIns="91425" spcFirstLastPara="1" rIns="91425" wrap="square" tIns="91425">
+          <a:bodyPr spcFirstLastPara="1" wrap="square" lIns="91425" tIns="91425" rIns="91425" bIns="91425" anchor="ctr" anchorCtr="0">
             <a:normAutofit/>
           </a:bodyPr>
           <a:lstStyle>
@@ -3143,7 +3254,7 @@
             </a:lvl9pPr>
           </a:lstStyle>
           <a:p>
-            <a:pPr indent="0" lvl="0" marL="0" rtl="0" algn="r">
+            <a:pPr marL="0" lvl="0" indent="0" algn="r" rtl="0">
               <a:spcBef>
                 <a:spcPts val="0"/>
               </a:spcBef>
@@ -3169,11 +3280,11 @@
 </file>
 
 <file path=ppt/slideLayouts/slideLayout3.xml><?xml version="1.0" encoding="utf-8"?>
-<p:sldLayout xmlns:a="http://schemas.openxmlformats.org/drawingml/2006/main" xmlns:r="http://schemas.openxmlformats.org/officeDocument/2006/relationships" xmlns:mc="http://schemas.openxmlformats.org/markup-compatibility/2006" xmlns:mv="urn:schemas-microsoft-com:mac:vml" xmlns:p="http://schemas.openxmlformats.org/presentationml/2006/main" xmlns:c="http://schemas.openxmlformats.org/drawingml/2006/chart" xmlns:dgm="http://schemas.openxmlformats.org/drawingml/2006/diagram" xmlns:o="urn:schemas-microsoft-com:office:office" xmlns:v="urn:schemas-microsoft-com:vml" xmlns:pvml="urn:schemas-microsoft-com:office:powerpoint" xmlns:com="http://schemas.openxmlformats.org/drawingml/2006/compatibility" xmlns:p14="http://schemas.microsoft.com/office/powerpoint/2010/main" xmlns:p15="http://schemas.microsoft.com/office/powerpoint/2012/main" xmlns:ahyp="http://schemas.microsoft.com/office/drawing/2018/hyperlinkcolor" matchingName="Title and body" type="tx">
+<p:sldLayout xmlns:a="http://schemas.openxmlformats.org/drawingml/2006/main" xmlns:r="http://schemas.openxmlformats.org/officeDocument/2006/relationships" xmlns:p="http://schemas.openxmlformats.org/presentationml/2006/main" matchingName="Title and body" type="tx">
   <p:cSld name="TITLE_AND_BODY">
     <p:spTree>
       <p:nvGrpSpPr>
-        <p:cNvPr id="16" name="Shape 16"/>
+        <p:cNvPr id="1" name="Shape 16"/>
         <p:cNvGrpSpPr/>
         <p:nvPr/>
       </p:nvGrpSpPr>
@@ -3188,7 +3299,9 @@
       <p:sp>
         <p:nvSpPr>
           <p:cNvPr id="17" name="Google Shape;17;p4"/>
-          <p:cNvSpPr txBox="1"/>
+          <p:cNvSpPr txBox="1">
+            <a:spLocks noGrp="1"/>
+          </p:cNvSpPr>
           <p:nvPr>
             <p:ph type="title"/>
           </p:nvPr>
@@ -3203,7 +3316,7 @@
           </a:prstGeom>
         </p:spPr>
         <p:txBody>
-          <a:bodyPr anchorCtr="0" anchor="t" bIns="91425" lIns="91425" spcFirstLastPara="1" rIns="91425" wrap="square" tIns="91425">
+          <a:bodyPr spcFirstLastPara="1" wrap="square" lIns="91425" tIns="91425" rIns="91425" bIns="91425" anchor="t" anchorCtr="0">
             <a:normAutofit/>
           </a:bodyPr>
           <a:lstStyle>
@@ -3307,15 +3420,19 @@
               <a:defRPr/>
             </a:lvl9pPr>
           </a:lstStyle>
-          <a:p/>
+          <a:p>
+            <a:endParaRPr/>
+          </a:p>
         </p:txBody>
       </p:sp>
       <p:sp>
         <p:nvSpPr>
           <p:cNvPr id="18" name="Google Shape;18;p4"/>
-          <p:cNvSpPr txBox="1"/>
+          <p:cNvSpPr txBox="1">
+            <a:spLocks noGrp="1"/>
+          </p:cNvSpPr>
           <p:nvPr>
-            <p:ph idx="1" type="body"/>
+            <p:ph type="body" idx="1"/>
           </p:nvPr>
         </p:nvSpPr>
         <p:spPr>
@@ -3328,11 +3445,11 @@
           </a:prstGeom>
         </p:spPr>
         <p:txBody>
-          <a:bodyPr anchorCtr="0" anchor="t" bIns="91425" lIns="91425" spcFirstLastPara="1" rIns="91425" wrap="square" tIns="91425">
+          <a:bodyPr spcFirstLastPara="1" wrap="square" lIns="91425" tIns="91425" rIns="91425" bIns="91425" anchor="t" anchorCtr="0">
             <a:normAutofit/>
           </a:bodyPr>
           <a:lstStyle>
-            <a:lvl1pPr indent="-342900" lvl="0" marL="457200">
+            <a:lvl1pPr marL="457200" lvl="0" indent="-342900">
               <a:spcBef>
                 <a:spcPts val="0"/>
               </a:spcBef>
@@ -3343,7 +3460,7 @@
               <a:buChar char="●"/>
               <a:defRPr/>
             </a:lvl1pPr>
-            <a:lvl2pPr indent="-317500" lvl="1" marL="914400">
+            <a:lvl2pPr marL="914400" lvl="1" indent="-317500">
               <a:spcBef>
                 <a:spcPts val="0"/>
               </a:spcBef>
@@ -3354,7 +3471,7 @@
               <a:buChar char="○"/>
               <a:defRPr/>
             </a:lvl2pPr>
-            <a:lvl3pPr indent="-317500" lvl="2" marL="1371600">
+            <a:lvl3pPr marL="1371600" lvl="2" indent="-317500">
               <a:spcBef>
                 <a:spcPts val="0"/>
               </a:spcBef>
@@ -3365,7 +3482,7 @@
               <a:buChar char="■"/>
               <a:defRPr/>
             </a:lvl3pPr>
-            <a:lvl4pPr indent="-317500" lvl="3" marL="1828800">
+            <a:lvl4pPr marL="1828800" lvl="3" indent="-317500">
               <a:spcBef>
                 <a:spcPts val="0"/>
               </a:spcBef>
@@ -3376,7 +3493,7 @@
               <a:buChar char="●"/>
               <a:defRPr/>
             </a:lvl4pPr>
-            <a:lvl5pPr indent="-317500" lvl="4" marL="2286000">
+            <a:lvl5pPr marL="2286000" lvl="4" indent="-317500">
               <a:spcBef>
                 <a:spcPts val="0"/>
               </a:spcBef>
@@ -3387,7 +3504,7 @@
               <a:buChar char="○"/>
               <a:defRPr/>
             </a:lvl5pPr>
-            <a:lvl6pPr indent="-317500" lvl="5" marL="2743200">
+            <a:lvl6pPr marL="2743200" lvl="5" indent="-317500">
               <a:spcBef>
                 <a:spcPts val="0"/>
               </a:spcBef>
@@ -3398,7 +3515,7 @@
               <a:buChar char="■"/>
               <a:defRPr/>
             </a:lvl6pPr>
-            <a:lvl7pPr indent="-317500" lvl="6" marL="3200400">
+            <a:lvl7pPr marL="3200400" lvl="6" indent="-317500">
               <a:spcBef>
                 <a:spcPts val="0"/>
               </a:spcBef>
@@ -3409,7 +3526,7 @@
               <a:buChar char="●"/>
               <a:defRPr/>
             </a:lvl7pPr>
-            <a:lvl8pPr indent="-317500" lvl="7" marL="3657600">
+            <a:lvl8pPr marL="3657600" lvl="7" indent="-317500">
               <a:spcBef>
                 <a:spcPts val="0"/>
               </a:spcBef>
@@ -3420,7 +3537,7 @@
               <a:buChar char="○"/>
               <a:defRPr/>
             </a:lvl8pPr>
-            <a:lvl9pPr indent="-317500" lvl="8" marL="4114800">
+            <a:lvl9pPr marL="4114800" lvl="8" indent="-317500">
               <a:spcBef>
                 <a:spcPts val="0"/>
               </a:spcBef>
@@ -3432,15 +3549,19 @@
               <a:defRPr/>
             </a:lvl9pPr>
           </a:lstStyle>
-          <a:p/>
+          <a:p>
+            <a:endParaRPr/>
+          </a:p>
         </p:txBody>
       </p:sp>
       <p:sp>
         <p:nvSpPr>
           <p:cNvPr id="19" name="Google Shape;19;p4"/>
-          <p:cNvSpPr txBox="1"/>
+          <p:cNvSpPr txBox="1">
+            <a:spLocks noGrp="1"/>
+          </p:cNvSpPr>
           <p:nvPr>
-            <p:ph idx="12" type="sldNum"/>
+            <p:ph type="sldNum" idx="12"/>
           </p:nvPr>
         </p:nvSpPr>
         <p:spPr>
@@ -3453,7 +3574,7 @@
           </a:prstGeom>
         </p:spPr>
         <p:txBody>
-          <a:bodyPr anchorCtr="0" anchor="ctr" bIns="91425" lIns="91425" spcFirstLastPara="1" rIns="91425" wrap="square" tIns="91425">
+          <a:bodyPr spcFirstLastPara="1" wrap="square" lIns="91425" tIns="91425" rIns="91425" bIns="91425" anchor="ctr" anchorCtr="0">
             <a:normAutofit/>
           </a:bodyPr>
           <a:lstStyle>
@@ -3495,7 +3616,7 @@
             </a:lvl9pPr>
           </a:lstStyle>
           <a:p>
-            <a:pPr indent="0" lvl="0" marL="0" rtl="0" algn="r">
+            <a:pPr marL="0" lvl="0" indent="0" algn="r" rtl="0">
               <a:spcBef>
                 <a:spcPts val="0"/>
               </a:spcBef>
@@ -3521,11 +3642,11 @@
 </file>
 
 <file path=ppt/slideLayouts/slideLayout4.xml><?xml version="1.0" encoding="utf-8"?>
-<p:sldLayout xmlns:a="http://schemas.openxmlformats.org/drawingml/2006/main" xmlns:r="http://schemas.openxmlformats.org/officeDocument/2006/relationships" xmlns:mc="http://schemas.openxmlformats.org/markup-compatibility/2006" xmlns:mv="urn:schemas-microsoft-com:mac:vml" xmlns:p="http://schemas.openxmlformats.org/presentationml/2006/main" xmlns:c="http://schemas.openxmlformats.org/drawingml/2006/chart" xmlns:dgm="http://schemas.openxmlformats.org/drawingml/2006/diagram" xmlns:o="urn:schemas-microsoft-com:office:office" xmlns:v="urn:schemas-microsoft-com:vml" xmlns:pvml="urn:schemas-microsoft-com:office:powerpoint" xmlns:com="http://schemas.openxmlformats.org/drawingml/2006/compatibility" xmlns:p14="http://schemas.microsoft.com/office/powerpoint/2010/main" xmlns:p15="http://schemas.microsoft.com/office/powerpoint/2012/main" xmlns:ahyp="http://schemas.microsoft.com/office/drawing/2018/hyperlinkcolor" matchingName="Title and two columns" type="twoColTx">
+<p:sldLayout xmlns:a="http://schemas.openxmlformats.org/drawingml/2006/main" xmlns:r="http://schemas.openxmlformats.org/officeDocument/2006/relationships" xmlns:p="http://schemas.openxmlformats.org/presentationml/2006/main" matchingName="Title and two columns" type="twoColTx">
   <p:cSld name="TITLE_AND_TWO_COLUMNS">
     <p:spTree>
       <p:nvGrpSpPr>
-        <p:cNvPr id="20" name="Shape 20"/>
+        <p:cNvPr id="1" name="Shape 20"/>
         <p:cNvGrpSpPr/>
         <p:nvPr/>
       </p:nvGrpSpPr>
@@ -3540,7 +3661,9 @@
       <p:sp>
         <p:nvSpPr>
           <p:cNvPr id="21" name="Google Shape;21;p5"/>
-          <p:cNvSpPr txBox="1"/>
+          <p:cNvSpPr txBox="1">
+            <a:spLocks noGrp="1"/>
+          </p:cNvSpPr>
           <p:nvPr>
             <p:ph type="title"/>
           </p:nvPr>
@@ -3555,7 +3678,7 @@
           </a:prstGeom>
         </p:spPr>
         <p:txBody>
-          <a:bodyPr anchorCtr="0" anchor="t" bIns="91425" lIns="91425" spcFirstLastPara="1" rIns="91425" wrap="square" tIns="91425">
+          <a:bodyPr spcFirstLastPara="1" wrap="square" lIns="91425" tIns="91425" rIns="91425" bIns="91425" anchor="t" anchorCtr="0">
             <a:normAutofit/>
           </a:bodyPr>
           <a:lstStyle>
@@ -3659,15 +3782,19 @@
               <a:defRPr/>
             </a:lvl9pPr>
           </a:lstStyle>
-          <a:p/>
+          <a:p>
+            <a:endParaRPr/>
+          </a:p>
         </p:txBody>
       </p:sp>
       <p:sp>
         <p:nvSpPr>
           <p:cNvPr id="22" name="Google Shape;22;p5"/>
-          <p:cNvSpPr txBox="1"/>
+          <p:cNvSpPr txBox="1">
+            <a:spLocks noGrp="1"/>
+          </p:cNvSpPr>
           <p:nvPr>
-            <p:ph idx="1" type="body"/>
+            <p:ph type="body" idx="1"/>
           </p:nvPr>
         </p:nvSpPr>
         <p:spPr>
@@ -3680,11 +3807,11 @@
           </a:prstGeom>
         </p:spPr>
         <p:txBody>
-          <a:bodyPr anchorCtr="0" anchor="t" bIns="91425" lIns="91425" spcFirstLastPara="1" rIns="91425" wrap="square" tIns="91425">
+          <a:bodyPr spcFirstLastPara="1" wrap="square" lIns="91425" tIns="91425" rIns="91425" bIns="91425" anchor="t" anchorCtr="0">
             <a:normAutofit/>
           </a:bodyPr>
           <a:lstStyle>
-            <a:lvl1pPr indent="-317500" lvl="0" marL="457200">
+            <a:lvl1pPr marL="457200" lvl="0" indent="-317500">
               <a:spcBef>
                 <a:spcPts val="0"/>
               </a:spcBef>
@@ -3695,7 +3822,7 @@
               <a:buChar char="●"/>
               <a:defRPr sz="1400"/>
             </a:lvl1pPr>
-            <a:lvl2pPr indent="-304800" lvl="1" marL="914400">
+            <a:lvl2pPr marL="914400" lvl="1" indent="-304800">
               <a:spcBef>
                 <a:spcPts val="0"/>
               </a:spcBef>
@@ -3706,7 +3833,7 @@
               <a:buChar char="○"/>
               <a:defRPr sz="1200"/>
             </a:lvl2pPr>
-            <a:lvl3pPr indent="-304800" lvl="2" marL="1371600">
+            <a:lvl3pPr marL="1371600" lvl="2" indent="-304800">
               <a:spcBef>
                 <a:spcPts val="0"/>
               </a:spcBef>
@@ -3717,7 +3844,7 @@
               <a:buChar char="■"/>
               <a:defRPr sz="1200"/>
             </a:lvl3pPr>
-            <a:lvl4pPr indent="-304800" lvl="3" marL="1828800">
+            <a:lvl4pPr marL="1828800" lvl="3" indent="-304800">
               <a:spcBef>
                 <a:spcPts val="0"/>
               </a:spcBef>
@@ -3728,7 +3855,7 @@
               <a:buChar char="●"/>
               <a:defRPr sz="1200"/>
             </a:lvl4pPr>
-            <a:lvl5pPr indent="-304800" lvl="4" marL="2286000">
+            <a:lvl5pPr marL="2286000" lvl="4" indent="-304800">
               <a:spcBef>
                 <a:spcPts val="0"/>
               </a:spcBef>
@@ -3739,7 +3866,7 @@
               <a:buChar char="○"/>
               <a:defRPr sz="1200"/>
             </a:lvl5pPr>
-            <a:lvl6pPr indent="-304800" lvl="5" marL="2743200">
+            <a:lvl6pPr marL="2743200" lvl="5" indent="-304800">
               <a:spcBef>
                 <a:spcPts val="0"/>
               </a:spcBef>
@@ -3750,7 +3877,7 @@
               <a:buChar char="■"/>
               <a:defRPr sz="1200"/>
             </a:lvl6pPr>
-            <a:lvl7pPr indent="-304800" lvl="6" marL="3200400">
+            <a:lvl7pPr marL="3200400" lvl="6" indent="-304800">
               <a:spcBef>
                 <a:spcPts val="0"/>
               </a:spcBef>
@@ -3761,7 +3888,7 @@
               <a:buChar char="●"/>
               <a:defRPr sz="1200"/>
             </a:lvl7pPr>
-            <a:lvl8pPr indent="-304800" lvl="7" marL="3657600">
+            <a:lvl8pPr marL="3657600" lvl="7" indent="-304800">
               <a:spcBef>
                 <a:spcPts val="0"/>
               </a:spcBef>
@@ -3772,7 +3899,7 @@
               <a:buChar char="○"/>
               <a:defRPr sz="1200"/>
             </a:lvl8pPr>
-            <a:lvl9pPr indent="-304800" lvl="8" marL="4114800">
+            <a:lvl9pPr marL="4114800" lvl="8" indent="-304800">
               <a:spcBef>
                 <a:spcPts val="0"/>
               </a:spcBef>
@@ -3784,15 +3911,19 @@
               <a:defRPr sz="1200"/>
             </a:lvl9pPr>
           </a:lstStyle>
-          <a:p/>
+          <a:p>
+            <a:endParaRPr/>
+          </a:p>
         </p:txBody>
       </p:sp>
       <p:sp>
         <p:nvSpPr>
           <p:cNvPr id="23" name="Google Shape;23;p5"/>
-          <p:cNvSpPr txBox="1"/>
+          <p:cNvSpPr txBox="1">
+            <a:spLocks noGrp="1"/>
+          </p:cNvSpPr>
           <p:nvPr>
-            <p:ph idx="2" type="body"/>
+            <p:ph type="body" idx="2"/>
           </p:nvPr>
         </p:nvSpPr>
         <p:spPr>
@@ -3805,11 +3936,11 @@
           </a:prstGeom>
         </p:spPr>
         <p:txBody>
-          <a:bodyPr anchorCtr="0" anchor="t" bIns="91425" lIns="91425" spcFirstLastPara="1" rIns="91425" wrap="square" tIns="91425">
+          <a:bodyPr spcFirstLastPara="1" wrap="square" lIns="91425" tIns="91425" rIns="91425" bIns="91425" anchor="t" anchorCtr="0">
             <a:normAutofit/>
           </a:bodyPr>
           <a:lstStyle>
-            <a:lvl1pPr indent="-317500" lvl="0" marL="457200">
+            <a:lvl1pPr marL="457200" lvl="0" indent="-317500">
               <a:spcBef>
                 <a:spcPts val="0"/>
               </a:spcBef>
@@ -3820,7 +3951,7 @@
               <a:buChar char="●"/>
               <a:defRPr sz="1400"/>
             </a:lvl1pPr>
-            <a:lvl2pPr indent="-304800" lvl="1" marL="914400">
+            <a:lvl2pPr marL="914400" lvl="1" indent="-304800">
               <a:spcBef>
                 <a:spcPts val="0"/>
               </a:spcBef>
@@ -3831,7 +3962,7 @@
               <a:buChar char="○"/>
               <a:defRPr sz="1200"/>
             </a:lvl2pPr>
-            <a:lvl3pPr indent="-304800" lvl="2" marL="1371600">
+            <a:lvl3pPr marL="1371600" lvl="2" indent="-304800">
               <a:spcBef>
                 <a:spcPts val="0"/>
               </a:spcBef>
@@ -3842,7 +3973,7 @@
               <a:buChar char="■"/>
               <a:defRPr sz="1200"/>
             </a:lvl3pPr>
-            <a:lvl4pPr indent="-304800" lvl="3" marL="1828800">
+            <a:lvl4pPr marL="1828800" lvl="3" indent="-304800">
               <a:spcBef>
                 <a:spcPts val="0"/>
               </a:spcBef>
@@ -3853,7 +3984,7 @@
               <a:buChar char="●"/>
               <a:defRPr sz="1200"/>
             </a:lvl4pPr>
-            <a:lvl5pPr indent="-304800" lvl="4" marL="2286000">
+            <a:lvl5pPr marL="2286000" lvl="4" indent="-304800">
               <a:spcBef>
                 <a:spcPts val="0"/>
               </a:spcBef>
@@ -3864,7 +3995,7 @@
               <a:buChar char="○"/>
               <a:defRPr sz="1200"/>
             </a:lvl5pPr>
-            <a:lvl6pPr indent="-304800" lvl="5" marL="2743200">
+            <a:lvl6pPr marL="2743200" lvl="5" indent="-304800">
               <a:spcBef>
                 <a:spcPts val="0"/>
               </a:spcBef>
@@ -3875,7 +4006,7 @@
               <a:buChar char="■"/>
               <a:defRPr sz="1200"/>
             </a:lvl6pPr>
-            <a:lvl7pPr indent="-304800" lvl="6" marL="3200400">
+            <a:lvl7pPr marL="3200400" lvl="6" indent="-304800">
               <a:spcBef>
                 <a:spcPts val="0"/>
               </a:spcBef>
@@ -3886,7 +4017,7 @@
               <a:buChar char="●"/>
               <a:defRPr sz="1200"/>
             </a:lvl7pPr>
-            <a:lvl8pPr indent="-304800" lvl="7" marL="3657600">
+            <a:lvl8pPr marL="3657600" lvl="7" indent="-304800">
               <a:spcBef>
                 <a:spcPts val="0"/>
               </a:spcBef>
@@ -3897,7 +4028,7 @@
               <a:buChar char="○"/>
               <a:defRPr sz="1200"/>
             </a:lvl8pPr>
-            <a:lvl9pPr indent="-304800" lvl="8" marL="4114800">
+            <a:lvl9pPr marL="4114800" lvl="8" indent="-304800">
               <a:spcBef>
                 <a:spcPts val="0"/>
               </a:spcBef>
@@ -3909,15 +4040,19 @@
               <a:defRPr sz="1200"/>
             </a:lvl9pPr>
           </a:lstStyle>
-          <a:p/>
+          <a:p>
+            <a:endParaRPr/>
+          </a:p>
         </p:txBody>
       </p:sp>
       <p:sp>
         <p:nvSpPr>
           <p:cNvPr id="24" name="Google Shape;24;p5"/>
-          <p:cNvSpPr txBox="1"/>
+          <p:cNvSpPr txBox="1">
+            <a:spLocks noGrp="1"/>
+          </p:cNvSpPr>
           <p:nvPr>
-            <p:ph idx="12" type="sldNum"/>
+            <p:ph type="sldNum" idx="12"/>
           </p:nvPr>
         </p:nvSpPr>
         <p:spPr>
@@ -3930,7 +4065,7 @@
           </a:prstGeom>
         </p:spPr>
         <p:txBody>
-          <a:bodyPr anchorCtr="0" anchor="ctr" bIns="91425" lIns="91425" spcFirstLastPara="1" rIns="91425" wrap="square" tIns="91425">
+          <a:bodyPr spcFirstLastPara="1" wrap="square" lIns="91425" tIns="91425" rIns="91425" bIns="91425" anchor="ctr" anchorCtr="0">
             <a:normAutofit/>
           </a:bodyPr>
           <a:lstStyle>
@@ -3972,7 +4107,7 @@
             </a:lvl9pPr>
           </a:lstStyle>
           <a:p>
-            <a:pPr indent="0" lvl="0" marL="0" rtl="0" algn="r">
+            <a:pPr marL="0" lvl="0" indent="0" algn="r" rtl="0">
               <a:spcBef>
                 <a:spcPts val="0"/>
               </a:spcBef>
@@ -3998,11 +4133,11 @@
 </file>
 
 <file path=ppt/slideLayouts/slideLayout5.xml><?xml version="1.0" encoding="utf-8"?>
-<p:sldLayout xmlns:a="http://schemas.openxmlformats.org/drawingml/2006/main" xmlns:r="http://schemas.openxmlformats.org/officeDocument/2006/relationships" xmlns:mc="http://schemas.openxmlformats.org/markup-compatibility/2006" xmlns:mv="urn:schemas-microsoft-com:mac:vml" xmlns:p="http://schemas.openxmlformats.org/presentationml/2006/main" xmlns:c="http://schemas.openxmlformats.org/drawingml/2006/chart" xmlns:dgm="http://schemas.openxmlformats.org/drawingml/2006/diagram" xmlns:o="urn:schemas-microsoft-com:office:office" xmlns:v="urn:schemas-microsoft-com:vml" xmlns:pvml="urn:schemas-microsoft-com:office:powerpoint" xmlns:com="http://schemas.openxmlformats.org/drawingml/2006/compatibility" xmlns:p14="http://schemas.microsoft.com/office/powerpoint/2010/main" xmlns:p15="http://schemas.microsoft.com/office/powerpoint/2012/main" xmlns:ahyp="http://schemas.microsoft.com/office/drawing/2018/hyperlinkcolor" matchingName="Title only" type="titleOnly">
+<p:sldLayout xmlns:a="http://schemas.openxmlformats.org/drawingml/2006/main" xmlns:r="http://schemas.openxmlformats.org/officeDocument/2006/relationships" xmlns:p="http://schemas.openxmlformats.org/presentationml/2006/main" matchingName="Title only" type="titleOnly">
   <p:cSld name="TITLE_ONLY">
     <p:spTree>
       <p:nvGrpSpPr>
-        <p:cNvPr id="25" name="Shape 25"/>
+        <p:cNvPr id="1" name="Shape 25"/>
         <p:cNvGrpSpPr/>
         <p:nvPr/>
       </p:nvGrpSpPr>
@@ -4017,7 +4152,9 @@
       <p:sp>
         <p:nvSpPr>
           <p:cNvPr id="26" name="Google Shape;26;p6"/>
-          <p:cNvSpPr txBox="1"/>
+          <p:cNvSpPr txBox="1">
+            <a:spLocks noGrp="1"/>
+          </p:cNvSpPr>
           <p:nvPr>
             <p:ph type="title"/>
           </p:nvPr>
@@ -4032,7 +4169,7 @@
           </a:prstGeom>
         </p:spPr>
         <p:txBody>
-          <a:bodyPr anchorCtr="0" anchor="t" bIns="91425" lIns="91425" spcFirstLastPara="1" rIns="91425" wrap="square" tIns="91425">
+          <a:bodyPr spcFirstLastPara="1" wrap="square" lIns="91425" tIns="91425" rIns="91425" bIns="91425" anchor="t" anchorCtr="0">
             <a:normAutofit/>
           </a:bodyPr>
           <a:lstStyle>
@@ -4136,15 +4273,19 @@
               <a:defRPr/>
             </a:lvl9pPr>
           </a:lstStyle>
-          <a:p/>
+          <a:p>
+            <a:endParaRPr/>
+          </a:p>
         </p:txBody>
       </p:sp>
       <p:sp>
         <p:nvSpPr>
           <p:cNvPr id="27" name="Google Shape;27;p6"/>
-          <p:cNvSpPr txBox="1"/>
+          <p:cNvSpPr txBox="1">
+            <a:spLocks noGrp="1"/>
+          </p:cNvSpPr>
           <p:nvPr>
-            <p:ph idx="12" type="sldNum"/>
+            <p:ph type="sldNum" idx="12"/>
           </p:nvPr>
         </p:nvSpPr>
         <p:spPr>
@@ -4157,7 +4298,7 @@
           </a:prstGeom>
         </p:spPr>
         <p:txBody>
-          <a:bodyPr anchorCtr="0" anchor="ctr" bIns="91425" lIns="91425" spcFirstLastPara="1" rIns="91425" wrap="square" tIns="91425">
+          <a:bodyPr spcFirstLastPara="1" wrap="square" lIns="91425" tIns="91425" rIns="91425" bIns="91425" anchor="ctr" anchorCtr="0">
             <a:normAutofit/>
           </a:bodyPr>
           <a:lstStyle>
@@ -4199,7 +4340,7 @@
             </a:lvl9pPr>
           </a:lstStyle>
           <a:p>
-            <a:pPr indent="0" lvl="0" marL="0" rtl="0" algn="r">
+            <a:pPr marL="0" lvl="0" indent="0" algn="r" rtl="0">
               <a:spcBef>
                 <a:spcPts val="0"/>
               </a:spcBef>
@@ -4225,11 +4366,11 @@
 </file>
 
 <file path=ppt/slideLayouts/slideLayout6.xml><?xml version="1.0" encoding="utf-8"?>
-<p:sldLayout xmlns:a="http://schemas.openxmlformats.org/drawingml/2006/main" xmlns:r="http://schemas.openxmlformats.org/officeDocument/2006/relationships" xmlns:mc="http://schemas.openxmlformats.org/markup-compatibility/2006" xmlns:mv="urn:schemas-microsoft-com:mac:vml" xmlns:p="http://schemas.openxmlformats.org/presentationml/2006/main" xmlns:c="http://schemas.openxmlformats.org/drawingml/2006/chart" xmlns:dgm="http://schemas.openxmlformats.org/drawingml/2006/diagram" xmlns:o="urn:schemas-microsoft-com:office:office" xmlns:v="urn:schemas-microsoft-com:vml" xmlns:pvml="urn:schemas-microsoft-com:office:powerpoint" xmlns:com="http://schemas.openxmlformats.org/drawingml/2006/compatibility" xmlns:p14="http://schemas.microsoft.com/office/powerpoint/2010/main" xmlns:p15="http://schemas.microsoft.com/office/powerpoint/2012/main" xmlns:ahyp="http://schemas.microsoft.com/office/drawing/2018/hyperlinkcolor" matchingName="One column text">
+<p:sldLayout xmlns:a="http://schemas.openxmlformats.org/drawingml/2006/main" xmlns:r="http://schemas.openxmlformats.org/officeDocument/2006/relationships" xmlns:p="http://schemas.openxmlformats.org/presentationml/2006/main" matchingName="One column text">
   <p:cSld name="ONE_COLUMN_TEXT">
     <p:spTree>
       <p:nvGrpSpPr>
-        <p:cNvPr id="28" name="Shape 28"/>
+        <p:cNvPr id="1" name="Shape 28"/>
         <p:cNvGrpSpPr/>
         <p:nvPr/>
       </p:nvGrpSpPr>
@@ -4244,7 +4385,9 @@
       <p:sp>
         <p:nvSpPr>
           <p:cNvPr id="29" name="Google Shape;29;p7"/>
-          <p:cNvSpPr txBox="1"/>
+          <p:cNvSpPr txBox="1">
+            <a:spLocks noGrp="1"/>
+          </p:cNvSpPr>
           <p:nvPr>
             <p:ph type="title"/>
           </p:nvPr>
@@ -4259,7 +4402,7 @@
           </a:prstGeom>
         </p:spPr>
         <p:txBody>
-          <a:bodyPr anchorCtr="0" anchor="b" bIns="91425" lIns="91425" spcFirstLastPara="1" rIns="91425" wrap="square" tIns="91425">
+          <a:bodyPr spcFirstLastPara="1" wrap="square" lIns="91425" tIns="91425" rIns="91425" bIns="91425" anchor="b" anchorCtr="0">
             <a:normAutofit/>
           </a:bodyPr>
           <a:lstStyle>
@@ -4363,15 +4506,19 @@
               <a:defRPr sz="2400"/>
             </a:lvl9pPr>
           </a:lstStyle>
-          <a:p/>
+          <a:p>
+            <a:endParaRPr/>
+          </a:p>
         </p:txBody>
       </p:sp>
       <p:sp>
         <p:nvSpPr>
           <p:cNvPr id="30" name="Google Shape;30;p7"/>
-          <p:cNvSpPr txBox="1"/>
+          <p:cNvSpPr txBox="1">
+            <a:spLocks noGrp="1"/>
+          </p:cNvSpPr>
           <p:nvPr>
-            <p:ph idx="1" type="body"/>
+            <p:ph type="body" idx="1"/>
           </p:nvPr>
         </p:nvSpPr>
         <p:spPr>
@@ -4384,11 +4531,11 @@
           </a:prstGeom>
         </p:spPr>
         <p:txBody>
-          <a:bodyPr anchorCtr="0" anchor="t" bIns="91425" lIns="91425" spcFirstLastPara="1" rIns="91425" wrap="square" tIns="91425">
+          <a:bodyPr spcFirstLastPara="1" wrap="square" lIns="91425" tIns="91425" rIns="91425" bIns="91425" anchor="t" anchorCtr="0">
             <a:normAutofit/>
           </a:bodyPr>
           <a:lstStyle>
-            <a:lvl1pPr indent="-304800" lvl="0" marL="457200">
+            <a:lvl1pPr marL="457200" lvl="0" indent="-304800">
               <a:spcBef>
                 <a:spcPts val="0"/>
               </a:spcBef>
@@ -4399,7 +4546,7 @@
               <a:buChar char="●"/>
               <a:defRPr sz="1200"/>
             </a:lvl1pPr>
-            <a:lvl2pPr indent="-304800" lvl="1" marL="914400">
+            <a:lvl2pPr marL="914400" lvl="1" indent="-304800">
               <a:spcBef>
                 <a:spcPts val="0"/>
               </a:spcBef>
@@ -4410,7 +4557,7 @@
               <a:buChar char="○"/>
               <a:defRPr sz="1200"/>
             </a:lvl2pPr>
-            <a:lvl3pPr indent="-304800" lvl="2" marL="1371600">
+            <a:lvl3pPr marL="1371600" lvl="2" indent="-304800">
               <a:spcBef>
                 <a:spcPts val="0"/>
               </a:spcBef>
@@ -4421,7 +4568,7 @@
               <a:buChar char="■"/>
               <a:defRPr sz="1200"/>
             </a:lvl3pPr>
-            <a:lvl4pPr indent="-304800" lvl="3" marL="1828800">
+            <a:lvl4pPr marL="1828800" lvl="3" indent="-304800">
               <a:spcBef>
                 <a:spcPts val="0"/>
               </a:spcBef>
@@ -4432,7 +4579,7 @@
               <a:buChar char="●"/>
               <a:defRPr sz="1200"/>
             </a:lvl4pPr>
-            <a:lvl5pPr indent="-304800" lvl="4" marL="2286000">
+            <a:lvl5pPr marL="2286000" lvl="4" indent="-304800">
               <a:spcBef>
                 <a:spcPts val="0"/>
               </a:spcBef>
@@ -4443,7 +4590,7 @@
               <a:buChar char="○"/>
               <a:defRPr sz="1200"/>
             </a:lvl5pPr>
-            <a:lvl6pPr indent="-304800" lvl="5" marL="2743200">
+            <a:lvl6pPr marL="2743200" lvl="5" indent="-304800">
               <a:spcBef>
                 <a:spcPts val="0"/>
               </a:spcBef>
@@ -4454,7 +4601,7 @@
               <a:buChar char="■"/>
               <a:defRPr sz="1200"/>
             </a:lvl6pPr>
-            <a:lvl7pPr indent="-304800" lvl="6" marL="3200400">
+            <a:lvl7pPr marL="3200400" lvl="6" indent="-304800">
               <a:spcBef>
                 <a:spcPts val="0"/>
               </a:spcBef>
@@ -4465,7 +4612,7 @@
               <a:buChar char="●"/>
               <a:defRPr sz="1200"/>
             </a:lvl7pPr>
-            <a:lvl8pPr indent="-304800" lvl="7" marL="3657600">
+            <a:lvl8pPr marL="3657600" lvl="7" indent="-304800">
               <a:spcBef>
                 <a:spcPts val="0"/>
               </a:spcBef>
@@ -4476,7 +4623,7 @@
               <a:buChar char="○"/>
               <a:defRPr sz="1200"/>
             </a:lvl8pPr>
-            <a:lvl9pPr indent="-304800" lvl="8" marL="4114800">
+            <a:lvl9pPr marL="4114800" lvl="8" indent="-304800">
               <a:spcBef>
                 <a:spcPts val="0"/>
               </a:spcBef>
@@ -4488,15 +4635,19 @@
               <a:defRPr sz="1200"/>
             </a:lvl9pPr>
           </a:lstStyle>
-          <a:p/>
+          <a:p>
+            <a:endParaRPr/>
+          </a:p>
         </p:txBody>
       </p:sp>
       <p:sp>
         <p:nvSpPr>
           <p:cNvPr id="31" name="Google Shape;31;p7"/>
-          <p:cNvSpPr txBox="1"/>
+          <p:cNvSpPr txBox="1">
+            <a:spLocks noGrp="1"/>
+          </p:cNvSpPr>
           <p:nvPr>
-            <p:ph idx="12" type="sldNum"/>
+            <p:ph type="sldNum" idx="12"/>
           </p:nvPr>
         </p:nvSpPr>
         <p:spPr>
@@ -4509,7 +4660,7 @@
           </a:prstGeom>
         </p:spPr>
         <p:txBody>
-          <a:bodyPr anchorCtr="0" anchor="ctr" bIns="91425" lIns="91425" spcFirstLastPara="1" rIns="91425" wrap="square" tIns="91425">
+          <a:bodyPr spcFirstLastPara="1" wrap="square" lIns="91425" tIns="91425" rIns="91425" bIns="91425" anchor="ctr" anchorCtr="0">
             <a:normAutofit/>
           </a:bodyPr>
           <a:lstStyle>
@@ -4551,7 +4702,7 @@
             </a:lvl9pPr>
           </a:lstStyle>
           <a:p>
-            <a:pPr indent="0" lvl="0" marL="0" rtl="0" algn="r">
+            <a:pPr marL="0" lvl="0" indent="0" algn="r" rtl="0">
               <a:spcBef>
                 <a:spcPts val="0"/>
               </a:spcBef>
@@ -4577,11 +4728,11 @@
 </file>
 
 <file path=ppt/slideLayouts/slideLayout7.xml><?xml version="1.0" encoding="utf-8"?>
-<p:sldLayout xmlns:a="http://schemas.openxmlformats.org/drawingml/2006/main" xmlns:r="http://schemas.openxmlformats.org/officeDocument/2006/relationships" xmlns:mc="http://schemas.openxmlformats.org/markup-compatibility/2006" xmlns:mv="urn:schemas-microsoft-com:mac:vml" xmlns:p="http://schemas.openxmlformats.org/presentationml/2006/main" xmlns:c="http://schemas.openxmlformats.org/drawingml/2006/chart" xmlns:dgm="http://schemas.openxmlformats.org/drawingml/2006/diagram" xmlns:o="urn:schemas-microsoft-com:office:office" xmlns:v="urn:schemas-microsoft-com:vml" xmlns:pvml="urn:schemas-microsoft-com:office:powerpoint" xmlns:com="http://schemas.openxmlformats.org/drawingml/2006/compatibility" xmlns:p14="http://schemas.microsoft.com/office/powerpoint/2010/main" xmlns:p15="http://schemas.microsoft.com/office/powerpoint/2012/main" xmlns:ahyp="http://schemas.microsoft.com/office/drawing/2018/hyperlinkcolor" matchingName="Main point">
+<p:sldLayout xmlns:a="http://schemas.openxmlformats.org/drawingml/2006/main" xmlns:r="http://schemas.openxmlformats.org/officeDocument/2006/relationships" xmlns:p="http://schemas.openxmlformats.org/presentationml/2006/main" matchingName="Main point">
   <p:cSld name="MAIN_POINT">
     <p:spTree>
       <p:nvGrpSpPr>
-        <p:cNvPr id="32" name="Shape 32"/>
+        <p:cNvPr id="1" name="Shape 32"/>
         <p:cNvGrpSpPr/>
         <p:nvPr/>
       </p:nvGrpSpPr>
@@ -4596,7 +4747,9 @@
       <p:sp>
         <p:nvSpPr>
           <p:cNvPr id="33" name="Google Shape;33;p8"/>
-          <p:cNvSpPr txBox="1"/>
+          <p:cNvSpPr txBox="1">
+            <a:spLocks noGrp="1"/>
+          </p:cNvSpPr>
           <p:nvPr>
             <p:ph type="title"/>
           </p:nvPr>
@@ -4611,7 +4764,7 @@
           </a:prstGeom>
         </p:spPr>
         <p:txBody>
-          <a:bodyPr anchorCtr="0" anchor="ctr" bIns="91425" lIns="91425" spcFirstLastPara="1" rIns="91425" wrap="square" tIns="91425">
+          <a:bodyPr spcFirstLastPara="1" wrap="square" lIns="91425" tIns="91425" rIns="91425" bIns="91425" anchor="ctr" anchorCtr="0">
             <a:normAutofit/>
           </a:bodyPr>
           <a:lstStyle>
@@ -4715,15 +4868,19 @@
               <a:defRPr sz="4800"/>
             </a:lvl9pPr>
           </a:lstStyle>
-          <a:p/>
+          <a:p>
+            <a:endParaRPr/>
+          </a:p>
         </p:txBody>
       </p:sp>
       <p:sp>
         <p:nvSpPr>
           <p:cNvPr id="34" name="Google Shape;34;p8"/>
-          <p:cNvSpPr txBox="1"/>
+          <p:cNvSpPr txBox="1">
+            <a:spLocks noGrp="1"/>
+          </p:cNvSpPr>
           <p:nvPr>
-            <p:ph idx="12" type="sldNum"/>
+            <p:ph type="sldNum" idx="12"/>
           </p:nvPr>
         </p:nvSpPr>
         <p:spPr>
@@ -4736,7 +4893,7 @@
           </a:prstGeom>
         </p:spPr>
         <p:txBody>
-          <a:bodyPr anchorCtr="0" anchor="ctr" bIns="91425" lIns="91425" spcFirstLastPara="1" rIns="91425" wrap="square" tIns="91425">
+          <a:bodyPr spcFirstLastPara="1" wrap="square" lIns="91425" tIns="91425" rIns="91425" bIns="91425" anchor="ctr" anchorCtr="0">
             <a:normAutofit/>
           </a:bodyPr>
           <a:lstStyle>
@@ -4778,7 +4935,7 @@
             </a:lvl9pPr>
           </a:lstStyle>
           <a:p>
-            <a:pPr indent="0" lvl="0" marL="0" rtl="0" algn="r">
+            <a:pPr marL="0" lvl="0" indent="0" algn="r" rtl="0">
               <a:spcBef>
                 <a:spcPts val="0"/>
               </a:spcBef>
@@ -4804,11 +4961,11 @@
 </file>
 
 <file path=ppt/slideLayouts/slideLayout8.xml><?xml version="1.0" encoding="utf-8"?>
-<p:sldLayout xmlns:a="http://schemas.openxmlformats.org/drawingml/2006/main" xmlns:r="http://schemas.openxmlformats.org/officeDocument/2006/relationships" xmlns:mc="http://schemas.openxmlformats.org/markup-compatibility/2006" xmlns:mv="urn:schemas-microsoft-com:mac:vml" xmlns:p="http://schemas.openxmlformats.org/presentationml/2006/main" xmlns:c="http://schemas.openxmlformats.org/drawingml/2006/chart" xmlns:dgm="http://schemas.openxmlformats.org/drawingml/2006/diagram" xmlns:o="urn:schemas-microsoft-com:office:office" xmlns:v="urn:schemas-microsoft-com:vml" xmlns:pvml="urn:schemas-microsoft-com:office:powerpoint" xmlns:com="http://schemas.openxmlformats.org/drawingml/2006/compatibility" xmlns:p14="http://schemas.microsoft.com/office/powerpoint/2010/main" xmlns:p15="http://schemas.microsoft.com/office/powerpoint/2012/main" xmlns:ahyp="http://schemas.microsoft.com/office/drawing/2018/hyperlinkcolor" matchingName="Section title and description">
+<p:sldLayout xmlns:a="http://schemas.openxmlformats.org/drawingml/2006/main" xmlns:r="http://schemas.openxmlformats.org/officeDocument/2006/relationships" xmlns:p="http://schemas.openxmlformats.org/presentationml/2006/main" matchingName="Section title and description">
   <p:cSld name="SECTION_TITLE_AND_DESCRIPTION">
     <p:spTree>
       <p:nvGrpSpPr>
-        <p:cNvPr id="35" name="Shape 35"/>
+        <p:cNvPr id="1" name="Shape 35"/>
         <p:cNvGrpSpPr/>
         <p:nvPr/>
       </p:nvGrpSpPr>
@@ -4842,12 +4999,12 @@
           </a:ln>
         </p:spPr>
         <p:txBody>
-          <a:bodyPr anchorCtr="0" anchor="ctr" bIns="91425" lIns="91425" spcFirstLastPara="1" rIns="91425" wrap="square" tIns="91425">
+          <a:bodyPr spcFirstLastPara="1" wrap="square" lIns="91425" tIns="91425" rIns="91425" bIns="91425" anchor="ctr" anchorCtr="0">
             <a:noAutofit/>
           </a:bodyPr>
           <a:lstStyle/>
           <a:p>
-            <a:pPr indent="0" lvl="0" marL="0" rtl="0" algn="l">
+            <a:pPr marL="0" lvl="0" indent="0" algn="l" rtl="0">
               <a:spcBef>
                 <a:spcPts val="0"/>
               </a:spcBef>
@@ -4856,9 +5013,6 @@
               </a:spcAft>
               <a:buNone/>
             </a:pPr>
-            <a:r>
-              <a:t/>
-            </a:r>
             <a:endParaRPr/>
           </a:p>
         </p:txBody>
@@ -4866,7 +5020,9 @@
       <p:sp>
         <p:nvSpPr>
           <p:cNvPr id="37" name="Google Shape;37;p9"/>
-          <p:cNvSpPr txBox="1"/>
+          <p:cNvSpPr txBox="1">
+            <a:spLocks noGrp="1"/>
+          </p:cNvSpPr>
           <p:nvPr>
             <p:ph type="title"/>
           </p:nvPr>
@@ -4881,7 +5037,7 @@
           </a:prstGeom>
         </p:spPr>
         <p:txBody>
-          <a:bodyPr anchorCtr="0" anchor="b" bIns="91425" lIns="91425" spcFirstLastPara="1" rIns="91425" wrap="square" tIns="91425">
+          <a:bodyPr spcFirstLastPara="1" wrap="square" lIns="91425" tIns="91425" rIns="91425" bIns="91425" anchor="b" anchorCtr="0">
             <a:normAutofit/>
           </a:bodyPr>
           <a:lstStyle>
@@ -4985,15 +5141,19 @@
               <a:defRPr sz="4200"/>
             </a:lvl9pPr>
           </a:lstStyle>
-          <a:p/>
+          <a:p>
+            <a:endParaRPr/>
+          </a:p>
         </p:txBody>
       </p:sp>
       <p:sp>
         <p:nvSpPr>
           <p:cNvPr id="38" name="Google Shape;38;p9"/>
-          <p:cNvSpPr txBox="1"/>
+          <p:cNvSpPr txBox="1">
+            <a:spLocks noGrp="1"/>
+          </p:cNvSpPr>
           <p:nvPr>
-            <p:ph idx="1" type="subTitle"/>
+            <p:ph type="subTitle" idx="1"/>
           </p:nvPr>
         </p:nvSpPr>
         <p:spPr>
@@ -5006,7 +5166,7 @@
           </a:prstGeom>
         </p:spPr>
         <p:txBody>
-          <a:bodyPr anchorCtr="0" anchor="t" bIns="91425" lIns="91425" spcFirstLastPara="1" rIns="91425" wrap="square" tIns="91425">
+          <a:bodyPr spcFirstLastPara="1" wrap="square" lIns="91425" tIns="91425" rIns="91425" bIns="91425" anchor="t" anchorCtr="0">
             <a:normAutofit/>
           </a:bodyPr>
           <a:lstStyle>
@@ -5137,15 +5297,19 @@
               <a:defRPr sz="2100"/>
             </a:lvl9pPr>
           </a:lstStyle>
-          <a:p/>
+          <a:p>
+            <a:endParaRPr/>
+          </a:p>
         </p:txBody>
       </p:sp>
       <p:sp>
         <p:nvSpPr>
           <p:cNvPr id="39" name="Google Shape;39;p9"/>
-          <p:cNvSpPr txBox="1"/>
+          <p:cNvSpPr txBox="1">
+            <a:spLocks noGrp="1"/>
+          </p:cNvSpPr>
           <p:nvPr>
-            <p:ph idx="2" type="body"/>
+            <p:ph type="body" idx="2"/>
           </p:nvPr>
         </p:nvSpPr>
         <p:spPr>
@@ -5158,11 +5322,11 @@
           </a:prstGeom>
         </p:spPr>
         <p:txBody>
-          <a:bodyPr anchorCtr="0" anchor="ctr" bIns="91425" lIns="91425" spcFirstLastPara="1" rIns="91425" wrap="square" tIns="91425">
+          <a:bodyPr spcFirstLastPara="1" wrap="square" lIns="91425" tIns="91425" rIns="91425" bIns="91425" anchor="ctr" anchorCtr="0">
             <a:normAutofit/>
           </a:bodyPr>
           <a:lstStyle>
-            <a:lvl1pPr indent="-342900" lvl="0" marL="457200">
+            <a:lvl1pPr marL="457200" lvl="0" indent="-342900">
               <a:spcBef>
                 <a:spcPts val="0"/>
               </a:spcBef>
@@ -5173,7 +5337,7 @@
               <a:buChar char="●"/>
               <a:defRPr/>
             </a:lvl1pPr>
-            <a:lvl2pPr indent="-317500" lvl="1" marL="914400">
+            <a:lvl2pPr marL="914400" lvl="1" indent="-317500">
               <a:spcBef>
                 <a:spcPts val="0"/>
               </a:spcBef>
@@ -5184,7 +5348,7 @@
               <a:buChar char="○"/>
               <a:defRPr/>
             </a:lvl2pPr>
-            <a:lvl3pPr indent="-317500" lvl="2" marL="1371600">
+            <a:lvl3pPr marL="1371600" lvl="2" indent="-317500">
               <a:spcBef>
                 <a:spcPts val="0"/>
               </a:spcBef>
@@ -5195,7 +5359,7 @@
               <a:buChar char="■"/>
               <a:defRPr/>
             </a:lvl3pPr>
-            <a:lvl4pPr indent="-317500" lvl="3" marL="1828800">
+            <a:lvl4pPr marL="1828800" lvl="3" indent="-317500">
               <a:spcBef>
                 <a:spcPts val="0"/>
               </a:spcBef>
@@ -5206,7 +5370,7 @@
               <a:buChar char="●"/>
               <a:defRPr/>
             </a:lvl4pPr>
-            <a:lvl5pPr indent="-317500" lvl="4" marL="2286000">
+            <a:lvl5pPr marL="2286000" lvl="4" indent="-317500">
               <a:spcBef>
                 <a:spcPts val="0"/>
               </a:spcBef>
@@ -5217,7 +5381,7 @@
               <a:buChar char="○"/>
               <a:defRPr/>
             </a:lvl5pPr>
-            <a:lvl6pPr indent="-317500" lvl="5" marL="2743200">
+            <a:lvl6pPr marL="2743200" lvl="5" indent="-317500">
               <a:spcBef>
                 <a:spcPts val="0"/>
               </a:spcBef>
@@ -5228,7 +5392,7 @@
               <a:buChar char="■"/>
               <a:defRPr/>
             </a:lvl6pPr>
-            <a:lvl7pPr indent="-317500" lvl="6" marL="3200400">
+            <a:lvl7pPr marL="3200400" lvl="6" indent="-317500">
               <a:spcBef>
                 <a:spcPts val="0"/>
               </a:spcBef>
@@ -5239,7 +5403,7 @@
               <a:buChar char="●"/>
               <a:defRPr/>
             </a:lvl7pPr>
-            <a:lvl8pPr indent="-317500" lvl="7" marL="3657600">
+            <a:lvl8pPr marL="3657600" lvl="7" indent="-317500">
               <a:spcBef>
                 <a:spcPts val="0"/>
               </a:spcBef>
@@ -5250,7 +5414,7 @@
               <a:buChar char="○"/>
               <a:defRPr/>
             </a:lvl8pPr>
-            <a:lvl9pPr indent="-317500" lvl="8" marL="4114800">
+            <a:lvl9pPr marL="4114800" lvl="8" indent="-317500">
               <a:spcBef>
                 <a:spcPts val="0"/>
               </a:spcBef>
@@ -5262,15 +5426,19 @@
               <a:defRPr/>
             </a:lvl9pPr>
           </a:lstStyle>
-          <a:p/>
+          <a:p>
+            <a:endParaRPr/>
+          </a:p>
         </p:txBody>
       </p:sp>
       <p:sp>
         <p:nvSpPr>
           <p:cNvPr id="40" name="Google Shape;40;p9"/>
-          <p:cNvSpPr txBox="1"/>
+          <p:cNvSpPr txBox="1">
+            <a:spLocks noGrp="1"/>
+          </p:cNvSpPr>
           <p:nvPr>
-            <p:ph idx="12" type="sldNum"/>
+            <p:ph type="sldNum" idx="12"/>
           </p:nvPr>
         </p:nvSpPr>
         <p:spPr>
@@ -5283,7 +5451,7 @@
           </a:prstGeom>
         </p:spPr>
         <p:txBody>
-          <a:bodyPr anchorCtr="0" anchor="ctr" bIns="91425" lIns="91425" spcFirstLastPara="1" rIns="91425" wrap="square" tIns="91425">
+          <a:bodyPr spcFirstLastPara="1" wrap="square" lIns="91425" tIns="91425" rIns="91425" bIns="91425" anchor="ctr" anchorCtr="0">
             <a:normAutofit/>
           </a:bodyPr>
           <a:lstStyle>
@@ -5325,7 +5493,7 @@
             </a:lvl9pPr>
           </a:lstStyle>
           <a:p>
-            <a:pPr indent="0" lvl="0" marL="0" rtl="0" algn="r">
+            <a:pPr marL="0" lvl="0" indent="0" algn="r" rtl="0">
               <a:spcBef>
                 <a:spcPts val="0"/>
               </a:spcBef>
@@ -5351,11 +5519,11 @@
 </file>
 
 <file path=ppt/slideLayouts/slideLayout9.xml><?xml version="1.0" encoding="utf-8"?>
-<p:sldLayout xmlns:a="http://schemas.openxmlformats.org/drawingml/2006/main" xmlns:r="http://schemas.openxmlformats.org/officeDocument/2006/relationships" xmlns:mc="http://schemas.openxmlformats.org/markup-compatibility/2006" xmlns:mv="urn:schemas-microsoft-com:mac:vml" xmlns:p="http://schemas.openxmlformats.org/presentationml/2006/main" xmlns:c="http://schemas.openxmlformats.org/drawingml/2006/chart" xmlns:dgm="http://schemas.openxmlformats.org/drawingml/2006/diagram" xmlns:o="urn:schemas-microsoft-com:office:office" xmlns:v="urn:schemas-microsoft-com:vml" xmlns:pvml="urn:schemas-microsoft-com:office:powerpoint" xmlns:com="http://schemas.openxmlformats.org/drawingml/2006/compatibility" xmlns:p14="http://schemas.microsoft.com/office/powerpoint/2010/main" xmlns:p15="http://schemas.microsoft.com/office/powerpoint/2012/main" xmlns:ahyp="http://schemas.microsoft.com/office/drawing/2018/hyperlinkcolor" matchingName="Caption">
+<p:sldLayout xmlns:a="http://schemas.openxmlformats.org/drawingml/2006/main" xmlns:r="http://schemas.openxmlformats.org/officeDocument/2006/relationships" xmlns:p="http://schemas.openxmlformats.org/presentationml/2006/main" matchingName="Caption">
   <p:cSld name="CAPTION_ONLY">
     <p:spTree>
       <p:nvGrpSpPr>
-        <p:cNvPr id="41" name="Shape 41"/>
+        <p:cNvPr id="1" name="Shape 41"/>
         <p:cNvGrpSpPr/>
         <p:nvPr/>
       </p:nvGrpSpPr>
@@ -5370,9 +5538,11 @@
       <p:sp>
         <p:nvSpPr>
           <p:cNvPr id="42" name="Google Shape;42;p10"/>
-          <p:cNvSpPr txBox="1"/>
+          <p:cNvSpPr txBox="1">
+            <a:spLocks noGrp="1"/>
+          </p:cNvSpPr>
           <p:nvPr>
-            <p:ph idx="1" type="body"/>
+            <p:ph type="body" idx="1"/>
           </p:nvPr>
         </p:nvSpPr>
         <p:spPr>
@@ -5385,11 +5555,11 @@
           </a:prstGeom>
         </p:spPr>
         <p:txBody>
-          <a:bodyPr anchorCtr="0" anchor="ctr" bIns="91425" lIns="91425" spcFirstLastPara="1" rIns="91425" wrap="square" tIns="91425">
+          <a:bodyPr spcFirstLastPara="1" wrap="square" lIns="91425" tIns="91425" rIns="91425" bIns="91425" anchor="ctr" anchorCtr="0">
             <a:normAutofit/>
           </a:bodyPr>
           <a:lstStyle>
-            <a:lvl1pPr indent="-228600" lvl="0" marL="457200">
+            <a:lvl1pPr marL="457200" lvl="0" indent="-228600">
               <a:lnSpc>
                 <a:spcPct val="100000"/>
               </a:lnSpc>
@@ -5404,15 +5574,19 @@
               <a:defRPr/>
             </a:lvl1pPr>
           </a:lstStyle>
-          <a:p/>
+          <a:p>
+            <a:endParaRPr/>
+          </a:p>
         </p:txBody>
       </p:sp>
       <p:sp>
         <p:nvSpPr>
           <p:cNvPr id="43" name="Google Shape;43;p10"/>
-          <p:cNvSpPr txBox="1"/>
+          <p:cNvSpPr txBox="1">
+            <a:spLocks noGrp="1"/>
+          </p:cNvSpPr>
           <p:nvPr>
-            <p:ph idx="12" type="sldNum"/>
+            <p:ph type="sldNum" idx="12"/>
           </p:nvPr>
         </p:nvSpPr>
         <p:spPr>
@@ -5425,7 +5599,7 @@
           </a:prstGeom>
         </p:spPr>
         <p:txBody>
-          <a:bodyPr anchorCtr="0" anchor="ctr" bIns="91425" lIns="91425" spcFirstLastPara="1" rIns="91425" wrap="square" tIns="91425">
+          <a:bodyPr spcFirstLastPara="1" wrap="square" lIns="91425" tIns="91425" rIns="91425" bIns="91425" anchor="ctr" anchorCtr="0">
             <a:normAutofit/>
           </a:bodyPr>
           <a:lstStyle>
@@ -5467,7 +5641,7 @@
             </a:lvl9pPr>
           </a:lstStyle>
           <a:p>
-            <a:pPr indent="0" lvl="0" marL="0" rtl="0" algn="r">
+            <a:pPr marL="0" lvl="0" indent="0" algn="r" rtl="0">
               <a:spcBef>
                 <a:spcPts val="0"/>
               </a:spcBef>
@@ -5493,18 +5667,19 @@
 </file>
 
 <file path=ppt/slideMasters/slideMaster1.xml><?xml version="1.0" encoding="utf-8"?>
-<p:sldMaster xmlns:a="http://schemas.openxmlformats.org/drawingml/2006/main" xmlns:r="http://schemas.openxmlformats.org/officeDocument/2006/relationships" xmlns:mc="http://schemas.openxmlformats.org/markup-compatibility/2006" xmlns:mv="urn:schemas-microsoft-com:mac:vml" xmlns:p="http://schemas.openxmlformats.org/presentationml/2006/main" xmlns:c="http://schemas.openxmlformats.org/drawingml/2006/chart" xmlns:dgm="http://schemas.openxmlformats.org/drawingml/2006/diagram" xmlns:o="urn:schemas-microsoft-com:office:office" xmlns:v="urn:schemas-microsoft-com:vml" xmlns:pvml="urn:schemas-microsoft-com:office:powerpoint" xmlns:com="http://schemas.openxmlformats.org/drawingml/2006/compatibility" xmlns:p14="http://schemas.microsoft.com/office/powerpoint/2010/main" xmlns:p15="http://schemas.microsoft.com/office/powerpoint/2012/main" xmlns:ahyp="http://schemas.microsoft.com/office/drawing/2018/hyperlinkcolor">
+<p:sldMaster xmlns:a="http://schemas.openxmlformats.org/drawingml/2006/main" xmlns:r="http://schemas.openxmlformats.org/officeDocument/2006/relationships" xmlns:p="http://schemas.openxmlformats.org/presentationml/2006/main">
   <p:cSld name="simple-light-2">
     <p:bg>
       <p:bgPr>
         <a:solidFill>
           <a:schemeClr val="lt1"/>
         </a:solidFill>
+        <a:effectLst/>
       </p:bgPr>
     </p:bg>
     <p:spTree>
       <p:nvGrpSpPr>
-        <p:cNvPr id="5" name="Shape 5"/>
+        <p:cNvPr id="1" name="Shape 5"/>
         <p:cNvGrpSpPr/>
         <p:nvPr/>
       </p:nvGrpSpPr>
@@ -5519,7 +5694,9 @@
       <p:sp>
         <p:nvSpPr>
           <p:cNvPr id="6" name="Google Shape;6;p1"/>
-          <p:cNvSpPr txBox="1"/>
+          <p:cNvSpPr txBox="1">
+            <a:spLocks noGrp="1"/>
+          </p:cNvSpPr>
           <p:nvPr>
             <p:ph type="title"/>
           </p:nvPr>
@@ -5538,7 +5715,7 @@
           </a:ln>
         </p:spPr>
         <p:txBody>
-          <a:bodyPr anchorCtr="0" anchor="t" bIns="91425" lIns="91425" spcFirstLastPara="1" rIns="91425" wrap="square" tIns="91425">
+          <a:bodyPr spcFirstLastPara="1" wrap="square" lIns="91425" tIns="91425" rIns="91425" bIns="91425" anchor="t" anchorCtr="0">
             <a:normAutofit/>
           </a:bodyPr>
           <a:lstStyle>
@@ -5705,15 +5882,19 @@
               </a:defRPr>
             </a:lvl9pPr>
           </a:lstStyle>
-          <a:p/>
+          <a:p>
+            <a:endParaRPr/>
+          </a:p>
         </p:txBody>
       </p:sp>
       <p:sp>
         <p:nvSpPr>
           <p:cNvPr id="7" name="Google Shape;7;p1"/>
-          <p:cNvSpPr txBox="1"/>
+          <p:cNvSpPr txBox="1">
+            <a:spLocks noGrp="1"/>
+          </p:cNvSpPr>
           <p:nvPr>
-            <p:ph idx="1" type="body"/>
+            <p:ph type="body" idx="1"/>
           </p:nvPr>
         </p:nvSpPr>
         <p:spPr>
@@ -5730,11 +5911,11 @@
           </a:ln>
         </p:spPr>
         <p:txBody>
-          <a:bodyPr anchorCtr="0" anchor="t" bIns="91425" lIns="91425" spcFirstLastPara="1" rIns="91425" wrap="square" tIns="91425">
+          <a:bodyPr spcFirstLastPara="1" wrap="square" lIns="91425" tIns="91425" rIns="91425" bIns="91425" anchor="t" anchorCtr="0">
             <a:normAutofit/>
           </a:bodyPr>
           <a:lstStyle>
-            <a:lvl1pPr indent="-342900" lvl="0" marL="457200">
+            <a:lvl1pPr marL="457200" lvl="0" indent="-342900">
               <a:lnSpc>
                 <a:spcPct val="115000"/>
               </a:lnSpc>
@@ -5755,7 +5936,7 @@
                 </a:solidFill>
               </a:defRPr>
             </a:lvl1pPr>
-            <a:lvl2pPr indent="-317500" lvl="1" marL="914400">
+            <a:lvl2pPr marL="914400" lvl="1" indent="-317500">
               <a:lnSpc>
                 <a:spcPct val="115000"/>
               </a:lnSpc>
@@ -5776,7 +5957,7 @@
                 </a:solidFill>
               </a:defRPr>
             </a:lvl2pPr>
-            <a:lvl3pPr indent="-317500" lvl="2" marL="1371600">
+            <a:lvl3pPr marL="1371600" lvl="2" indent="-317500">
               <a:lnSpc>
                 <a:spcPct val="115000"/>
               </a:lnSpc>
@@ -5797,7 +5978,7 @@
                 </a:solidFill>
               </a:defRPr>
             </a:lvl3pPr>
-            <a:lvl4pPr indent="-317500" lvl="3" marL="1828800">
+            <a:lvl4pPr marL="1828800" lvl="3" indent="-317500">
               <a:lnSpc>
                 <a:spcPct val="115000"/>
               </a:lnSpc>
@@ -5818,7 +5999,7 @@
                 </a:solidFill>
               </a:defRPr>
             </a:lvl4pPr>
-            <a:lvl5pPr indent="-317500" lvl="4" marL="2286000">
+            <a:lvl5pPr marL="2286000" lvl="4" indent="-317500">
               <a:lnSpc>
                 <a:spcPct val="115000"/>
               </a:lnSpc>
@@ -5839,7 +6020,7 @@
                 </a:solidFill>
               </a:defRPr>
             </a:lvl5pPr>
-            <a:lvl6pPr indent="-317500" lvl="5" marL="2743200">
+            <a:lvl6pPr marL="2743200" lvl="5" indent="-317500">
               <a:lnSpc>
                 <a:spcPct val="115000"/>
               </a:lnSpc>
@@ -5860,7 +6041,7 @@
                 </a:solidFill>
               </a:defRPr>
             </a:lvl6pPr>
-            <a:lvl7pPr indent="-317500" lvl="6" marL="3200400">
+            <a:lvl7pPr marL="3200400" lvl="6" indent="-317500">
               <a:lnSpc>
                 <a:spcPct val="115000"/>
               </a:lnSpc>
@@ -5881,7 +6062,7 @@
                 </a:solidFill>
               </a:defRPr>
             </a:lvl7pPr>
-            <a:lvl8pPr indent="-317500" lvl="7" marL="3657600">
+            <a:lvl8pPr marL="3657600" lvl="7" indent="-317500">
               <a:lnSpc>
                 <a:spcPct val="115000"/>
               </a:lnSpc>
@@ -5902,7 +6083,7 @@
                 </a:solidFill>
               </a:defRPr>
             </a:lvl8pPr>
-            <a:lvl9pPr indent="-317500" lvl="8" marL="4114800">
+            <a:lvl9pPr marL="4114800" lvl="8" indent="-317500">
               <a:lnSpc>
                 <a:spcPct val="115000"/>
               </a:lnSpc>
@@ -5924,15 +6105,19 @@
               </a:defRPr>
             </a:lvl9pPr>
           </a:lstStyle>
-          <a:p/>
+          <a:p>
+            <a:endParaRPr/>
+          </a:p>
         </p:txBody>
       </p:sp>
       <p:sp>
         <p:nvSpPr>
           <p:cNvPr id="8" name="Google Shape;8;p1"/>
-          <p:cNvSpPr txBox="1"/>
+          <p:cNvSpPr txBox="1">
+            <a:spLocks noGrp="1"/>
+          </p:cNvSpPr>
           <p:nvPr>
-            <p:ph idx="12" type="sldNum"/>
+            <p:ph type="sldNum" idx="12"/>
           </p:nvPr>
         </p:nvSpPr>
         <p:spPr>
@@ -5949,7 +6134,7 @@
           </a:ln>
         </p:spPr>
         <p:txBody>
-          <a:bodyPr anchorCtr="0" anchor="ctr" bIns="91425" lIns="91425" spcFirstLastPara="1" rIns="91425" wrap="square" tIns="91425">
+          <a:bodyPr spcFirstLastPara="1" wrap="square" lIns="91425" tIns="91425" rIns="91425" bIns="91425" anchor="ctr" anchorCtr="0">
             <a:normAutofit/>
           </a:bodyPr>
           <a:lstStyle>
@@ -6027,7 +6212,7 @@
             </a:lvl9pPr>
           </a:lstStyle>
           <a:p>
-            <a:pPr indent="0" lvl="0" marL="0" rtl="0" algn="r">
+            <a:pPr marL="0" lvl="0" indent="0" algn="r" rtl="0">
               <a:spcBef>
                 <a:spcPts val="0"/>
               </a:spcBef>
@@ -6046,7 +6231,7 @@
       </p:sp>
     </p:spTree>
   </p:cSld>
-  <p:clrMap accent1="accent1" accent2="accent2" accent3="accent3" accent4="accent4" accent5="accent5" accent6="accent6" bg1="lt1" bg2="dk2" tx1="dk1" tx2="lt2" folHlink="folHlink" hlink="hlink"/>
+  <p:clrMap bg1="lt1" tx1="dk1" bg2="dk2" tx2="lt2" accent1="accent1" accent2="accent2" accent3="accent3" accent4="accent4" accent5="accent5" accent6="accent6" hlink="hlink" folHlink="folHlink"/>
   <p:sldLayoutIdLst>
     <p:sldLayoutId id="2147483648" r:id="rId1"/>
     <p:sldLayoutId id="2147483649" r:id="rId2"/>
@@ -6060,10 +6245,10 @@
     <p:sldLayoutId id="2147483657" r:id="rId10"/>
     <p:sldLayoutId id="2147483658" r:id="rId11"/>
   </p:sldLayoutIdLst>
-  <p:hf dt="0" ftr="0" hdr="0" sldNum="0"/>
+  <p:hf sldNum="0" hdr="0" ftr="0" dt="0"/>
   <p:txStyles>
     <p:titleStyle>
-      <a:defPPr lvl="0" marR="0" rtl="0" algn="l">
+      <a:defPPr marR="0" lvl="0" algn="l" rtl="0">
         <a:lnSpc>
           <a:spcPct val="100000"/>
         </a:lnSpc>
@@ -6074,7 +6259,7 @@
           <a:spcPts val="0"/>
         </a:spcAft>
       </a:defPPr>
-      <a:lvl1pPr lvl="0" marR="0" rtl="0" algn="l">
+      <a:lvl1pPr marR="0" lvl="0" algn="l" rtl="0">
         <a:lnSpc>
           <a:spcPct val="100000"/>
         </a:lnSpc>
@@ -6088,7 +6273,7 @@
           <a:srgbClr val="000000"/>
         </a:buClr>
         <a:buFont typeface="Arial"/>
-        <a:defRPr b="0" i="0" sz="1400" u="none" cap="none" strike="noStrike">
+        <a:defRPr sz="1400" b="0" i="0" u="none" strike="noStrike" cap="none">
           <a:solidFill>
             <a:srgbClr val="000000"/>
           </a:solidFill>
@@ -6098,7 +6283,7 @@
           <a:sym typeface="Arial"/>
         </a:defRPr>
       </a:lvl1pPr>
-      <a:lvl2pPr lvl="1" marR="0" rtl="0" algn="l">
+      <a:lvl2pPr marR="0" lvl="1" algn="l" rtl="0">
         <a:lnSpc>
           <a:spcPct val="100000"/>
         </a:lnSpc>
@@ -6112,7 +6297,7 @@
           <a:srgbClr val="000000"/>
         </a:buClr>
         <a:buFont typeface="Arial"/>
-        <a:defRPr b="0" i="0" sz="1400" u="none" cap="none" strike="noStrike">
+        <a:defRPr sz="1400" b="0" i="0" u="none" strike="noStrike" cap="none">
           <a:solidFill>
             <a:srgbClr val="000000"/>
           </a:solidFill>
@@ -6122,7 +6307,7 @@
           <a:sym typeface="Arial"/>
         </a:defRPr>
       </a:lvl2pPr>
-      <a:lvl3pPr lvl="2" marR="0" rtl="0" algn="l">
+      <a:lvl3pPr marR="0" lvl="2" algn="l" rtl="0">
         <a:lnSpc>
           <a:spcPct val="100000"/>
         </a:lnSpc>
@@ -6136,7 +6321,7 @@
           <a:srgbClr val="000000"/>
         </a:buClr>
         <a:buFont typeface="Arial"/>
-        <a:defRPr b="0" i="0" sz="1400" u="none" cap="none" strike="noStrike">
+        <a:defRPr sz="1400" b="0" i="0" u="none" strike="noStrike" cap="none">
           <a:solidFill>
             <a:srgbClr val="000000"/>
           </a:solidFill>
@@ -6146,7 +6331,7 @@
           <a:sym typeface="Arial"/>
         </a:defRPr>
       </a:lvl3pPr>
-      <a:lvl4pPr lvl="3" marR="0" rtl="0" algn="l">
+      <a:lvl4pPr marR="0" lvl="3" algn="l" rtl="0">
         <a:lnSpc>
           <a:spcPct val="100000"/>
         </a:lnSpc>
@@ -6160,7 +6345,7 @@
           <a:srgbClr val="000000"/>
         </a:buClr>
         <a:buFont typeface="Arial"/>
-        <a:defRPr b="0" i="0" sz="1400" u="none" cap="none" strike="noStrike">
+        <a:defRPr sz="1400" b="0" i="0" u="none" strike="noStrike" cap="none">
           <a:solidFill>
             <a:srgbClr val="000000"/>
           </a:solidFill>
@@ -6170,7 +6355,7 @@
           <a:sym typeface="Arial"/>
         </a:defRPr>
       </a:lvl4pPr>
-      <a:lvl5pPr lvl="4" marR="0" rtl="0" algn="l">
+      <a:lvl5pPr marR="0" lvl="4" algn="l" rtl="0">
         <a:lnSpc>
           <a:spcPct val="100000"/>
         </a:lnSpc>
@@ -6184,7 +6369,7 @@
           <a:srgbClr val="000000"/>
         </a:buClr>
         <a:buFont typeface="Arial"/>
-        <a:defRPr b="0" i="0" sz="1400" u="none" cap="none" strike="noStrike">
+        <a:defRPr sz="1400" b="0" i="0" u="none" strike="noStrike" cap="none">
           <a:solidFill>
             <a:srgbClr val="000000"/>
           </a:solidFill>
@@ -6194,7 +6379,7 @@
           <a:sym typeface="Arial"/>
         </a:defRPr>
       </a:lvl5pPr>
-      <a:lvl6pPr lvl="5" marR="0" rtl="0" algn="l">
+      <a:lvl6pPr marR="0" lvl="5" algn="l" rtl="0">
         <a:lnSpc>
           <a:spcPct val="100000"/>
         </a:lnSpc>
@@ -6208,7 +6393,7 @@
           <a:srgbClr val="000000"/>
         </a:buClr>
         <a:buFont typeface="Arial"/>
-        <a:defRPr b="0" i="0" sz="1400" u="none" cap="none" strike="noStrike">
+        <a:defRPr sz="1400" b="0" i="0" u="none" strike="noStrike" cap="none">
           <a:solidFill>
             <a:srgbClr val="000000"/>
           </a:solidFill>
@@ -6218,7 +6403,7 @@
           <a:sym typeface="Arial"/>
         </a:defRPr>
       </a:lvl6pPr>
-      <a:lvl7pPr lvl="6" marR="0" rtl="0" algn="l">
+      <a:lvl7pPr marR="0" lvl="6" algn="l" rtl="0">
         <a:lnSpc>
           <a:spcPct val="100000"/>
         </a:lnSpc>
@@ -6232,7 +6417,7 @@
           <a:srgbClr val="000000"/>
         </a:buClr>
         <a:buFont typeface="Arial"/>
-        <a:defRPr b="0" i="0" sz="1400" u="none" cap="none" strike="noStrike">
+        <a:defRPr sz="1400" b="0" i="0" u="none" strike="noStrike" cap="none">
           <a:solidFill>
             <a:srgbClr val="000000"/>
           </a:solidFill>
@@ -6242,7 +6427,7 @@
           <a:sym typeface="Arial"/>
         </a:defRPr>
       </a:lvl7pPr>
-      <a:lvl8pPr lvl="7" marR="0" rtl="0" algn="l">
+      <a:lvl8pPr marR="0" lvl="7" algn="l" rtl="0">
         <a:lnSpc>
           <a:spcPct val="100000"/>
         </a:lnSpc>
@@ -6256,7 +6441,7 @@
           <a:srgbClr val="000000"/>
         </a:buClr>
         <a:buFont typeface="Arial"/>
-        <a:defRPr b="0" i="0" sz="1400" u="none" cap="none" strike="noStrike">
+        <a:defRPr sz="1400" b="0" i="0" u="none" strike="noStrike" cap="none">
           <a:solidFill>
             <a:srgbClr val="000000"/>
           </a:solidFill>
@@ -6266,7 +6451,7 @@
           <a:sym typeface="Arial"/>
         </a:defRPr>
       </a:lvl8pPr>
-      <a:lvl9pPr lvl="8" marR="0" rtl="0" algn="l">
+      <a:lvl9pPr marR="0" lvl="8" algn="l" rtl="0">
         <a:lnSpc>
           <a:spcPct val="100000"/>
         </a:lnSpc>
@@ -6280,7 +6465,7 @@
           <a:srgbClr val="000000"/>
         </a:buClr>
         <a:buFont typeface="Arial"/>
-        <a:defRPr b="0" i="0" sz="1400" u="none" cap="none" strike="noStrike">
+        <a:defRPr sz="1400" b="0" i="0" u="none" strike="noStrike" cap="none">
           <a:solidFill>
             <a:srgbClr val="000000"/>
           </a:solidFill>
@@ -6292,7 +6477,7 @@
       </a:lvl9pPr>
     </p:titleStyle>
     <p:bodyStyle>
-      <a:defPPr lvl="0" marR="0" rtl="0" algn="l">
+      <a:defPPr marR="0" lvl="0" algn="l" rtl="0">
         <a:lnSpc>
           <a:spcPct val="100000"/>
         </a:lnSpc>
@@ -6303,7 +6488,7 @@
           <a:spcPts val="0"/>
         </a:spcAft>
       </a:defPPr>
-      <a:lvl1pPr lvl="0" marR="0" rtl="0" algn="l">
+      <a:lvl1pPr marR="0" lvl="0" algn="l" rtl="0">
         <a:lnSpc>
           <a:spcPct val="100000"/>
         </a:lnSpc>
@@ -6317,7 +6502,7 @@
           <a:srgbClr val="000000"/>
         </a:buClr>
         <a:buFont typeface="Arial"/>
-        <a:defRPr b="0" i="0" sz="1400" u="none" cap="none" strike="noStrike">
+        <a:defRPr sz="1400" b="0" i="0" u="none" strike="noStrike" cap="none">
           <a:solidFill>
             <a:srgbClr val="000000"/>
           </a:solidFill>
@@ -6327,7 +6512,7 @@
           <a:sym typeface="Arial"/>
         </a:defRPr>
       </a:lvl1pPr>
-      <a:lvl2pPr lvl="1" marR="0" rtl="0" algn="l">
+      <a:lvl2pPr marR="0" lvl="1" algn="l" rtl="0">
         <a:lnSpc>
           <a:spcPct val="100000"/>
         </a:lnSpc>
@@ -6341,7 +6526,7 @@
           <a:srgbClr val="000000"/>
         </a:buClr>
         <a:buFont typeface="Arial"/>
-        <a:defRPr b="0" i="0" sz="1400" u="none" cap="none" strike="noStrike">
+        <a:defRPr sz="1400" b="0" i="0" u="none" strike="noStrike" cap="none">
           <a:solidFill>
             <a:srgbClr val="000000"/>
           </a:solidFill>
@@ -6351,7 +6536,7 @@
           <a:sym typeface="Arial"/>
         </a:defRPr>
       </a:lvl2pPr>
-      <a:lvl3pPr lvl="2" marR="0" rtl="0" algn="l">
+      <a:lvl3pPr marR="0" lvl="2" algn="l" rtl="0">
         <a:lnSpc>
           <a:spcPct val="100000"/>
         </a:lnSpc>
@@ -6365,7 +6550,7 @@
           <a:srgbClr val="000000"/>
         </a:buClr>
         <a:buFont typeface="Arial"/>
-        <a:defRPr b="0" i="0" sz="1400" u="none" cap="none" strike="noStrike">
+        <a:defRPr sz="1400" b="0" i="0" u="none" strike="noStrike" cap="none">
           <a:solidFill>
             <a:srgbClr val="000000"/>
           </a:solidFill>
@@ -6375,7 +6560,7 @@
           <a:sym typeface="Arial"/>
         </a:defRPr>
       </a:lvl3pPr>
-      <a:lvl4pPr lvl="3" marR="0" rtl="0" algn="l">
+      <a:lvl4pPr marR="0" lvl="3" algn="l" rtl="0">
         <a:lnSpc>
           <a:spcPct val="100000"/>
         </a:lnSpc>
@@ -6389,7 +6574,7 @@
           <a:srgbClr val="000000"/>
         </a:buClr>
         <a:buFont typeface="Arial"/>
-        <a:defRPr b="0" i="0" sz="1400" u="none" cap="none" strike="noStrike">
+        <a:defRPr sz="1400" b="0" i="0" u="none" strike="noStrike" cap="none">
           <a:solidFill>
             <a:srgbClr val="000000"/>
           </a:solidFill>
@@ -6399,7 +6584,7 @@
           <a:sym typeface="Arial"/>
         </a:defRPr>
       </a:lvl4pPr>
-      <a:lvl5pPr lvl="4" marR="0" rtl="0" algn="l">
+      <a:lvl5pPr marR="0" lvl="4" algn="l" rtl="0">
         <a:lnSpc>
           <a:spcPct val="100000"/>
         </a:lnSpc>
@@ -6413,7 +6598,7 @@
           <a:srgbClr val="000000"/>
         </a:buClr>
         <a:buFont typeface="Arial"/>
-        <a:defRPr b="0" i="0" sz="1400" u="none" cap="none" strike="noStrike">
+        <a:defRPr sz="1400" b="0" i="0" u="none" strike="noStrike" cap="none">
           <a:solidFill>
             <a:srgbClr val="000000"/>
           </a:solidFill>
@@ -6423,7 +6608,7 @@
           <a:sym typeface="Arial"/>
         </a:defRPr>
       </a:lvl5pPr>
-      <a:lvl6pPr lvl="5" marR="0" rtl="0" algn="l">
+      <a:lvl6pPr marR="0" lvl="5" algn="l" rtl="0">
         <a:lnSpc>
           <a:spcPct val="100000"/>
         </a:lnSpc>
@@ -6437,7 +6622,7 @@
           <a:srgbClr val="000000"/>
         </a:buClr>
         <a:buFont typeface="Arial"/>
-        <a:defRPr b="0" i="0" sz="1400" u="none" cap="none" strike="noStrike">
+        <a:defRPr sz="1400" b="0" i="0" u="none" strike="noStrike" cap="none">
           <a:solidFill>
             <a:srgbClr val="000000"/>
           </a:solidFill>
@@ -6447,7 +6632,7 @@
           <a:sym typeface="Arial"/>
         </a:defRPr>
       </a:lvl6pPr>
-      <a:lvl7pPr lvl="6" marR="0" rtl="0" algn="l">
+      <a:lvl7pPr marR="0" lvl="6" algn="l" rtl="0">
         <a:lnSpc>
           <a:spcPct val="100000"/>
         </a:lnSpc>
@@ -6461,7 +6646,7 @@
           <a:srgbClr val="000000"/>
         </a:buClr>
         <a:buFont typeface="Arial"/>
-        <a:defRPr b="0" i="0" sz="1400" u="none" cap="none" strike="noStrike">
+        <a:defRPr sz="1400" b="0" i="0" u="none" strike="noStrike" cap="none">
           <a:solidFill>
             <a:srgbClr val="000000"/>
           </a:solidFill>
@@ -6471,7 +6656,7 @@
           <a:sym typeface="Arial"/>
         </a:defRPr>
       </a:lvl7pPr>
-      <a:lvl8pPr lvl="7" marR="0" rtl="0" algn="l">
+      <a:lvl8pPr marR="0" lvl="7" algn="l" rtl="0">
         <a:lnSpc>
           <a:spcPct val="100000"/>
         </a:lnSpc>
@@ -6485,7 +6670,7 @@
           <a:srgbClr val="000000"/>
         </a:buClr>
         <a:buFont typeface="Arial"/>
-        <a:defRPr b="0" i="0" sz="1400" u="none" cap="none" strike="noStrike">
+        <a:defRPr sz="1400" b="0" i="0" u="none" strike="noStrike" cap="none">
           <a:solidFill>
             <a:srgbClr val="000000"/>
           </a:solidFill>
@@ -6495,7 +6680,7 @@
           <a:sym typeface="Arial"/>
         </a:defRPr>
       </a:lvl8pPr>
-      <a:lvl9pPr lvl="8" marR="0" rtl="0" algn="l">
+      <a:lvl9pPr marR="0" lvl="8" algn="l" rtl="0">
         <a:lnSpc>
           <a:spcPct val="100000"/>
         </a:lnSpc>
@@ -6509,7 +6694,7 @@
           <a:srgbClr val="000000"/>
         </a:buClr>
         <a:buFont typeface="Arial"/>
-        <a:defRPr b="0" i="0" sz="1400" u="none" cap="none" strike="noStrike">
+        <a:defRPr sz="1400" b="0" i="0" u="none" strike="noStrike" cap="none">
           <a:solidFill>
             <a:srgbClr val="000000"/>
           </a:solidFill>
@@ -6521,7 +6706,7 @@
       </a:lvl9pPr>
     </p:bodyStyle>
     <p:otherStyle>
-      <a:defPPr lvl="0" marR="0" rtl="0" algn="l">
+      <a:defPPr marR="0" lvl="0" algn="l" rtl="0">
         <a:lnSpc>
           <a:spcPct val="100000"/>
         </a:lnSpc>
@@ -6532,7 +6717,7 @@
           <a:spcPts val="0"/>
         </a:spcAft>
       </a:defPPr>
-      <a:lvl1pPr lvl="0" marR="0" rtl="0" algn="l">
+      <a:lvl1pPr marR="0" lvl="0" algn="l" rtl="0">
         <a:lnSpc>
           <a:spcPct val="100000"/>
         </a:lnSpc>
@@ -6546,7 +6731,7 @@
           <a:srgbClr val="000000"/>
         </a:buClr>
         <a:buFont typeface="Arial"/>
-        <a:defRPr b="0" i="0" sz="1400" u="none" cap="none" strike="noStrike">
+        <a:defRPr sz="1400" b="0" i="0" u="none" strike="noStrike" cap="none">
           <a:solidFill>
             <a:srgbClr val="000000"/>
           </a:solidFill>
@@ -6556,7 +6741,7 @@
           <a:sym typeface="Arial"/>
         </a:defRPr>
       </a:lvl1pPr>
-      <a:lvl2pPr lvl="1" marR="0" rtl="0" algn="l">
+      <a:lvl2pPr marR="0" lvl="1" algn="l" rtl="0">
         <a:lnSpc>
           <a:spcPct val="100000"/>
         </a:lnSpc>
@@ -6570,7 +6755,7 @@
           <a:srgbClr val="000000"/>
         </a:buClr>
         <a:buFont typeface="Arial"/>
-        <a:defRPr b="0" i="0" sz="1400" u="none" cap="none" strike="noStrike">
+        <a:defRPr sz="1400" b="0" i="0" u="none" strike="noStrike" cap="none">
           <a:solidFill>
             <a:srgbClr val="000000"/>
           </a:solidFill>
@@ -6580,7 +6765,7 @@
           <a:sym typeface="Arial"/>
         </a:defRPr>
       </a:lvl2pPr>
-      <a:lvl3pPr lvl="2" marR="0" rtl="0" algn="l">
+      <a:lvl3pPr marR="0" lvl="2" algn="l" rtl="0">
         <a:lnSpc>
           <a:spcPct val="100000"/>
         </a:lnSpc>
@@ -6594,7 +6779,7 @@
           <a:srgbClr val="000000"/>
         </a:buClr>
         <a:buFont typeface="Arial"/>
-        <a:defRPr b="0" i="0" sz="1400" u="none" cap="none" strike="noStrike">
+        <a:defRPr sz="1400" b="0" i="0" u="none" strike="noStrike" cap="none">
           <a:solidFill>
             <a:srgbClr val="000000"/>
           </a:solidFill>
@@ -6604,7 +6789,7 @@
           <a:sym typeface="Arial"/>
         </a:defRPr>
       </a:lvl3pPr>
-      <a:lvl4pPr lvl="3" marR="0" rtl="0" algn="l">
+      <a:lvl4pPr marR="0" lvl="3" algn="l" rtl="0">
         <a:lnSpc>
           <a:spcPct val="100000"/>
         </a:lnSpc>
@@ -6618,7 +6803,7 @@
           <a:srgbClr val="000000"/>
         </a:buClr>
         <a:buFont typeface="Arial"/>
-        <a:defRPr b="0" i="0" sz="1400" u="none" cap="none" strike="noStrike">
+        <a:defRPr sz="1400" b="0" i="0" u="none" strike="noStrike" cap="none">
           <a:solidFill>
             <a:srgbClr val="000000"/>
           </a:solidFill>
@@ -6628,7 +6813,7 @@
           <a:sym typeface="Arial"/>
         </a:defRPr>
       </a:lvl4pPr>
-      <a:lvl5pPr lvl="4" marR="0" rtl="0" algn="l">
+      <a:lvl5pPr marR="0" lvl="4" algn="l" rtl="0">
         <a:lnSpc>
           <a:spcPct val="100000"/>
         </a:lnSpc>
@@ -6642,7 +6827,7 @@
           <a:srgbClr val="000000"/>
         </a:buClr>
         <a:buFont typeface="Arial"/>
-        <a:defRPr b="0" i="0" sz="1400" u="none" cap="none" strike="noStrike">
+        <a:defRPr sz="1400" b="0" i="0" u="none" strike="noStrike" cap="none">
           <a:solidFill>
             <a:srgbClr val="000000"/>
           </a:solidFill>
@@ -6652,7 +6837,7 @@
           <a:sym typeface="Arial"/>
         </a:defRPr>
       </a:lvl5pPr>
-      <a:lvl6pPr lvl="5" marR="0" rtl="0" algn="l">
+      <a:lvl6pPr marR="0" lvl="5" algn="l" rtl="0">
         <a:lnSpc>
           <a:spcPct val="100000"/>
         </a:lnSpc>
@@ -6666,7 +6851,7 @@
           <a:srgbClr val="000000"/>
         </a:buClr>
         <a:buFont typeface="Arial"/>
-        <a:defRPr b="0" i="0" sz="1400" u="none" cap="none" strike="noStrike">
+        <a:defRPr sz="1400" b="0" i="0" u="none" strike="noStrike" cap="none">
           <a:solidFill>
             <a:srgbClr val="000000"/>
           </a:solidFill>
@@ -6676,7 +6861,7 @@
           <a:sym typeface="Arial"/>
         </a:defRPr>
       </a:lvl6pPr>
-      <a:lvl7pPr lvl="6" marR="0" rtl="0" algn="l">
+      <a:lvl7pPr marR="0" lvl="6" algn="l" rtl="0">
         <a:lnSpc>
           <a:spcPct val="100000"/>
         </a:lnSpc>
@@ -6690,7 +6875,7 @@
           <a:srgbClr val="000000"/>
         </a:buClr>
         <a:buFont typeface="Arial"/>
-        <a:defRPr b="0" i="0" sz="1400" u="none" cap="none" strike="noStrike">
+        <a:defRPr sz="1400" b="0" i="0" u="none" strike="noStrike" cap="none">
           <a:solidFill>
             <a:srgbClr val="000000"/>
           </a:solidFill>
@@ -6700,7 +6885,7 @@
           <a:sym typeface="Arial"/>
         </a:defRPr>
       </a:lvl7pPr>
-      <a:lvl8pPr lvl="7" marR="0" rtl="0" algn="l">
+      <a:lvl8pPr marR="0" lvl="7" algn="l" rtl="0">
         <a:lnSpc>
           <a:spcPct val="100000"/>
         </a:lnSpc>
@@ -6714,7 +6899,7 @@
           <a:srgbClr val="000000"/>
         </a:buClr>
         <a:buFont typeface="Arial"/>
-        <a:defRPr b="0" i="0" sz="1400" u="none" cap="none" strike="noStrike">
+        <a:defRPr sz="1400" b="0" i="0" u="none" strike="noStrike" cap="none">
           <a:solidFill>
             <a:srgbClr val="000000"/>
           </a:solidFill>
@@ -6724,7 +6909,7 @@
           <a:sym typeface="Arial"/>
         </a:defRPr>
       </a:lvl8pPr>
-      <a:lvl9pPr lvl="8" marR="0" rtl="0" algn="l">
+      <a:lvl9pPr marR="0" lvl="8" algn="l" rtl="0">
         <a:lnSpc>
           <a:spcPct val="100000"/>
         </a:lnSpc>
@@ -6738,7 +6923,7 @@
           <a:srgbClr val="000000"/>
         </a:buClr>
         <a:buFont typeface="Arial"/>
-        <a:defRPr b="0" i="0" sz="1400" u="none" cap="none" strike="noStrike">
+        <a:defRPr sz="1400" b="0" i="0" u="none" strike="noStrike" cap="none">
           <a:solidFill>
             <a:srgbClr val="000000"/>
           </a:solidFill>
@@ -6754,11 +6939,11 @@
 </file>
 
 <file path=ppt/slides/slide1.xml><?xml version="1.0" encoding="utf-8"?>
-<p:sld xmlns:a="http://schemas.openxmlformats.org/drawingml/2006/main" xmlns:r="http://schemas.openxmlformats.org/officeDocument/2006/relationships" xmlns:mc="http://schemas.openxmlformats.org/markup-compatibility/2006" xmlns:mv="urn:schemas-microsoft-com:mac:vml" xmlns:p="http://schemas.openxmlformats.org/presentationml/2006/main" xmlns:c="http://schemas.openxmlformats.org/drawingml/2006/chart" xmlns:dgm="http://schemas.openxmlformats.org/drawingml/2006/diagram" xmlns:o="urn:schemas-microsoft-com:office:office" xmlns:v="urn:schemas-microsoft-com:vml" xmlns:pvml="urn:schemas-microsoft-com:office:powerpoint" xmlns:com="http://schemas.openxmlformats.org/drawingml/2006/compatibility" xmlns:p14="http://schemas.microsoft.com/office/powerpoint/2010/main" xmlns:p15="http://schemas.microsoft.com/office/powerpoint/2012/main" xmlns:ahyp="http://schemas.microsoft.com/office/drawing/2018/hyperlinkcolor">
+<p:sld xmlns:a="http://schemas.openxmlformats.org/drawingml/2006/main" xmlns:r="http://schemas.openxmlformats.org/officeDocument/2006/relationships" xmlns:p="http://schemas.openxmlformats.org/presentationml/2006/main">
   <p:cSld>
     <p:spTree>
       <p:nvGrpSpPr>
-        <p:cNvPr id="53" name="Shape 53"/>
+        <p:cNvPr id="1" name="Shape 53"/>
         <p:cNvGrpSpPr/>
         <p:nvPr/>
       </p:nvGrpSpPr>
@@ -6818,12 +7003,12 @@
           </a:ln>
         </p:spPr>
         <p:txBody>
-          <a:bodyPr anchorCtr="0" anchor="t" bIns="91425" lIns="91425" spcFirstLastPara="1" rIns="91425" wrap="square" tIns="91425">
+          <a:bodyPr spcFirstLastPara="1" wrap="square" lIns="91425" tIns="91425" rIns="91425" bIns="91425" anchor="t" anchorCtr="0">
             <a:normAutofit/>
           </a:bodyPr>
           <a:lstStyle/>
           <a:p>
-            <a:pPr indent="0" lvl="0" marL="0" rtl="0" algn="l">
+            <a:pPr marL="0" lvl="0" indent="0" algn="l" rtl="0">
               <a:lnSpc>
                 <a:spcPct val="80000"/>
               </a:lnSpc>
@@ -6836,7 +7021,7 @@
               <a:buNone/>
             </a:pPr>
             <a:r>
-              <a:rPr lang="en-GB" sz="1600">
+              <a:rPr lang="en-GB" sz="1600" dirty="0">
                 <a:solidFill>
                   <a:srgbClr val="202729"/>
                 </a:solidFill>
@@ -6845,9 +7030,21 @@
                 <a:cs typeface="Manrope SemiBold"/>
                 <a:sym typeface="Manrope SemiBold"/>
               </a:rPr>
-              <a:t>Team Name :</a:t>
+              <a:t>Team Name : </a:t>
             </a:r>
-            <a:endParaRPr sz="1600">
+            <a:r>
+              <a:rPr lang="en-IN" sz="1600">
+                <a:solidFill>
+                  <a:srgbClr val="202729"/>
+                </a:solidFill>
+                <a:latin typeface="Manrope SemiBold"/>
+                <a:ea typeface="Manrope SemiBold"/>
+                <a:cs typeface="Manrope SemiBold"/>
+                <a:sym typeface="Manrope SemiBold"/>
+              </a:rPr>
+              <a:t>Assemblers </a:t>
+            </a:r>
+            <a:endParaRPr sz="1600" dirty="0">
               <a:solidFill>
                 <a:srgbClr val="202729"/>
               </a:solidFill>
@@ -6879,12 +7076,12 @@
           </a:ln>
         </p:spPr>
         <p:txBody>
-          <a:bodyPr anchorCtr="0" anchor="t" bIns="91425" lIns="91425" spcFirstLastPara="1" rIns="91425" wrap="square" tIns="91425">
+          <a:bodyPr spcFirstLastPara="1" wrap="square" lIns="91425" tIns="91425" rIns="91425" bIns="91425" anchor="t" anchorCtr="0">
             <a:normAutofit/>
           </a:bodyPr>
           <a:lstStyle/>
           <a:p>
-            <a:pPr indent="0" lvl="0" marL="0" rtl="0" algn="l">
+            <a:pPr marL="0" lvl="0" indent="0" algn="l" rtl="0">
               <a:lnSpc>
                 <a:spcPct val="70000"/>
               </a:lnSpc>
@@ -6940,25 +7137,18 @@
           </a:ln>
         </p:spPr>
         <p:txBody>
-          <a:bodyPr anchorCtr="0" anchor="t" bIns="91425" lIns="91425" spcFirstLastPara="1" rIns="91425" wrap="square" tIns="91425">
+          <a:bodyPr spcFirstLastPara="1" wrap="square" lIns="91425" tIns="91425" rIns="91425" bIns="91425" anchor="t" anchorCtr="0">
             <a:normAutofit/>
           </a:bodyPr>
           <a:lstStyle/>
           <a:p>
-            <a:pPr indent="0" lvl="0" marL="0" rtl="0" algn="l">
+            <a:pPr lvl="0">
               <a:lnSpc>
                 <a:spcPct val="80000"/>
               </a:lnSpc>
-              <a:spcBef>
-                <a:spcPts val="0"/>
-              </a:spcBef>
-              <a:spcAft>
-                <a:spcPts val="0"/>
-              </a:spcAft>
-              <a:buNone/>
             </a:pPr>
             <a:r>
-              <a:rPr lang="en-GB" sz="1600">
+              <a:rPr lang="en-GB" sz="1600" dirty="0">
                 <a:solidFill>
                   <a:srgbClr val="202729"/>
                 </a:solidFill>
@@ -6967,9 +7157,9 @@
                 <a:cs typeface="Manrope SemiBold"/>
                 <a:sym typeface="Manrope SemiBold"/>
               </a:rPr>
-              <a:t>Team Leader Name :</a:t>
+              <a:t>Team Leader Name : Sandeep Udeg</a:t>
             </a:r>
-            <a:endParaRPr sz="1600">
+            <a:endParaRPr sz="1600" dirty="0">
               <a:solidFill>
                 <a:srgbClr val="202729"/>
               </a:solidFill>
@@ -6990,11 +7180,11 @@
 </file>
 
 <file path=ppt/slides/slide10.xml><?xml version="1.0" encoding="utf-8"?>
-<p:sld xmlns:a="http://schemas.openxmlformats.org/drawingml/2006/main" xmlns:r="http://schemas.openxmlformats.org/officeDocument/2006/relationships" xmlns:mc="http://schemas.openxmlformats.org/markup-compatibility/2006" xmlns:mv="urn:schemas-microsoft-com:mac:vml" xmlns:p="http://schemas.openxmlformats.org/presentationml/2006/main" xmlns:c="http://schemas.openxmlformats.org/drawingml/2006/chart" xmlns:dgm="http://schemas.openxmlformats.org/drawingml/2006/diagram" xmlns:o="urn:schemas-microsoft-com:office:office" xmlns:v="urn:schemas-microsoft-com:vml" xmlns:pvml="urn:schemas-microsoft-com:office:powerpoint" xmlns:com="http://schemas.openxmlformats.org/drawingml/2006/compatibility" xmlns:p14="http://schemas.microsoft.com/office/powerpoint/2010/main" xmlns:p15="http://schemas.microsoft.com/office/powerpoint/2012/main" xmlns:ahyp="http://schemas.microsoft.com/office/drawing/2018/hyperlinkcolor">
+<p:sld xmlns:a="http://schemas.openxmlformats.org/drawingml/2006/main" xmlns:r="http://schemas.openxmlformats.org/officeDocument/2006/relationships" xmlns:p="http://schemas.openxmlformats.org/presentationml/2006/main">
   <p:cSld>
     <p:spTree>
       <p:nvGrpSpPr>
-        <p:cNvPr id="109" name="Shape 109"/>
+        <p:cNvPr id="1" name="Shape 109"/>
         <p:cNvGrpSpPr/>
         <p:nvPr/>
       </p:nvGrpSpPr>
@@ -7016,7 +7206,7 @@
           <a:blip r:embed="rId3">
             <a:alphaModFix/>
           </a:blip>
-          <a:srcRect b="0" l="0" r="0" t="0"/>
+          <a:srcRect/>
           <a:stretch/>
         </p:blipFill>
         <p:spPr>
@@ -7053,12 +7243,12 @@
           </a:ln>
         </p:spPr>
         <p:txBody>
-          <a:bodyPr anchorCtr="0" anchor="t" bIns="91425" lIns="91425" spcFirstLastPara="1" rIns="91425" wrap="square" tIns="91425">
+          <a:bodyPr spcFirstLastPara="1" wrap="square" lIns="91425" tIns="91425" rIns="91425" bIns="91425" anchor="t" anchorCtr="0">
             <a:normAutofit/>
           </a:bodyPr>
           <a:lstStyle/>
           <a:p>
-            <a:pPr indent="0" lvl="0" marL="0" rtl="0" algn="l">
+            <a:pPr marL="0" lvl="0" indent="0" algn="l" rtl="0">
               <a:lnSpc>
                 <a:spcPct val="115000"/>
               </a:lnSpc>
@@ -7076,7 +7266,7 @@
               <a:buNone/>
             </a:pPr>
             <a:r>
-              <a:rPr b="1" lang="en-GB" sz="1700">
+              <a:rPr lang="en-GB" sz="1700" b="1">
                 <a:solidFill>
                   <a:srgbClr val="202729"/>
                 </a:solidFill>
@@ -7085,19 +7275,7 @@
                 <a:cs typeface="Manrope"/>
                 <a:sym typeface="Manrope"/>
               </a:rPr>
-              <a:t>Snapshots of the prototype</a:t>
-            </a:r>
-            <a:r>
-              <a:rPr b="1" lang="en-GB" sz="1700">
-                <a:solidFill>
-                  <a:srgbClr val="202729"/>
-                </a:solidFill>
-                <a:latin typeface="Manrope"/>
-                <a:ea typeface="Manrope"/>
-                <a:cs typeface="Manrope"/>
-                <a:sym typeface="Manrope"/>
-              </a:rPr>
-              <a:t>:</a:t>
+              <a:t>Snapshots of the prototype:</a:t>
             </a:r>
             <a:endParaRPr>
               <a:solidFill>
@@ -7120,11 +7298,11 @@
 </file>
 
 <file path=ppt/slides/slide11.xml><?xml version="1.0" encoding="utf-8"?>
-<p:sld xmlns:a="http://schemas.openxmlformats.org/drawingml/2006/main" xmlns:r="http://schemas.openxmlformats.org/officeDocument/2006/relationships" xmlns:mc="http://schemas.openxmlformats.org/markup-compatibility/2006" xmlns:mv="urn:schemas-microsoft-com:mac:vml" xmlns:p="http://schemas.openxmlformats.org/presentationml/2006/main" xmlns:c="http://schemas.openxmlformats.org/drawingml/2006/chart" xmlns:dgm="http://schemas.openxmlformats.org/drawingml/2006/diagram" xmlns:o="urn:schemas-microsoft-com:office:office" xmlns:v="urn:schemas-microsoft-com:vml" xmlns:pvml="urn:schemas-microsoft-com:office:powerpoint" xmlns:com="http://schemas.openxmlformats.org/drawingml/2006/compatibility" xmlns:p14="http://schemas.microsoft.com/office/powerpoint/2010/main" xmlns:p15="http://schemas.microsoft.com/office/powerpoint/2012/main" xmlns:ahyp="http://schemas.microsoft.com/office/drawing/2018/hyperlinkcolor">
+<p:sld xmlns:a="http://schemas.openxmlformats.org/drawingml/2006/main" xmlns:r="http://schemas.openxmlformats.org/officeDocument/2006/relationships" xmlns:p="http://schemas.openxmlformats.org/presentationml/2006/main">
   <p:cSld>
     <p:spTree>
       <p:nvGrpSpPr>
-        <p:cNvPr id="115" name="Shape 115"/>
+        <p:cNvPr id="1" name="Shape 115"/>
         <p:cNvGrpSpPr/>
         <p:nvPr/>
       </p:nvGrpSpPr>
@@ -7146,7 +7324,7 @@
           <a:blip r:embed="rId3">
             <a:alphaModFix/>
           </a:blip>
-          <a:srcRect b="0" l="0" r="0" t="0"/>
+          <a:srcRect/>
           <a:stretch/>
         </p:blipFill>
         <p:spPr>
@@ -7183,12 +7361,12 @@
           </a:ln>
         </p:spPr>
         <p:txBody>
-          <a:bodyPr anchorCtr="0" anchor="t" bIns="91425" lIns="91425" spcFirstLastPara="1" rIns="91425" wrap="square" tIns="91425">
+          <a:bodyPr spcFirstLastPara="1" wrap="square" lIns="91425" tIns="91425" rIns="91425" bIns="91425" anchor="t" anchorCtr="0">
             <a:normAutofit/>
           </a:bodyPr>
           <a:lstStyle/>
           <a:p>
-            <a:pPr indent="0" lvl="0" marL="0" rtl="0" algn="l">
+            <a:pPr marL="0" lvl="0" indent="0" algn="l" rtl="0">
               <a:lnSpc>
                 <a:spcPct val="115000"/>
               </a:lnSpc>
@@ -7206,7 +7384,7 @@
               <a:buNone/>
             </a:pPr>
             <a:r>
-              <a:rPr b="1" lang="en-GB" sz="1700">
+              <a:rPr lang="en-GB" sz="1700" b="1">
                 <a:solidFill>
                   <a:srgbClr val="202729"/>
                 </a:solidFill>
@@ -7215,19 +7393,7 @@
                 <a:cs typeface="Manrope"/>
                 <a:sym typeface="Manrope"/>
               </a:rPr>
-              <a:t>Prototype Performance report/Benchmarking</a:t>
-            </a:r>
-            <a:r>
-              <a:rPr b="1" lang="en-GB" sz="1700">
-                <a:solidFill>
-                  <a:srgbClr val="202729"/>
-                </a:solidFill>
-                <a:latin typeface="Manrope"/>
-                <a:ea typeface="Manrope"/>
-                <a:cs typeface="Manrope"/>
-                <a:sym typeface="Manrope"/>
-              </a:rPr>
-              <a:t>:</a:t>
+              <a:t>Prototype Performance report/Benchmarking:</a:t>
             </a:r>
             <a:endParaRPr>
               <a:solidFill>
@@ -7250,11 +7416,11 @@
 </file>
 
 <file path=ppt/slides/slide12.xml><?xml version="1.0" encoding="utf-8"?>
-<p:sld xmlns:a="http://schemas.openxmlformats.org/drawingml/2006/main" xmlns:r="http://schemas.openxmlformats.org/officeDocument/2006/relationships" xmlns:mc="http://schemas.openxmlformats.org/markup-compatibility/2006" xmlns:mv="urn:schemas-microsoft-com:mac:vml" xmlns:p="http://schemas.openxmlformats.org/presentationml/2006/main" xmlns:c="http://schemas.openxmlformats.org/drawingml/2006/chart" xmlns:dgm="http://schemas.openxmlformats.org/drawingml/2006/diagram" xmlns:o="urn:schemas-microsoft-com:office:office" xmlns:v="urn:schemas-microsoft-com:vml" xmlns:pvml="urn:schemas-microsoft-com:office:powerpoint" xmlns:com="http://schemas.openxmlformats.org/drawingml/2006/compatibility" xmlns:p14="http://schemas.microsoft.com/office/powerpoint/2010/main" xmlns:p15="http://schemas.microsoft.com/office/powerpoint/2012/main" xmlns:ahyp="http://schemas.microsoft.com/office/drawing/2018/hyperlinkcolor">
+<p:sld xmlns:a="http://schemas.openxmlformats.org/drawingml/2006/main" xmlns:r="http://schemas.openxmlformats.org/officeDocument/2006/relationships" xmlns:p="http://schemas.openxmlformats.org/presentationml/2006/main">
   <p:cSld>
     <p:spTree>
       <p:nvGrpSpPr>
-        <p:cNvPr id="121" name="Shape 121"/>
+        <p:cNvPr id="1" name="Shape 121"/>
         <p:cNvGrpSpPr/>
         <p:nvPr/>
       </p:nvGrpSpPr>
@@ -7276,7 +7442,7 @@
           <a:blip r:embed="rId3">
             <a:alphaModFix/>
           </a:blip>
-          <a:srcRect b="0" l="0" r="0" t="0"/>
+          <a:srcRect/>
           <a:stretch/>
         </p:blipFill>
         <p:spPr>
@@ -7313,12 +7479,12 @@
           </a:ln>
         </p:spPr>
         <p:txBody>
-          <a:bodyPr anchorCtr="0" anchor="t" bIns="91425" lIns="91425" spcFirstLastPara="1" rIns="91425" wrap="square" tIns="91425">
+          <a:bodyPr spcFirstLastPara="1" wrap="square" lIns="91425" tIns="91425" rIns="91425" bIns="91425" anchor="t" anchorCtr="0">
             <a:normAutofit/>
           </a:bodyPr>
           <a:lstStyle/>
           <a:p>
-            <a:pPr indent="0" lvl="0" marL="0" rtl="0" algn="l">
+            <a:pPr marL="0" lvl="0" indent="0" algn="l" rtl="0">
               <a:lnSpc>
                 <a:spcPct val="115000"/>
               </a:lnSpc>
@@ -7336,7 +7502,7 @@
               <a:buNone/>
             </a:pPr>
             <a:r>
-              <a:rPr b="1" lang="en-GB" sz="1700">
+              <a:rPr lang="en-GB" sz="1700" b="1">
                 <a:solidFill>
                   <a:srgbClr val="202729"/>
                 </a:solidFill>
@@ -7345,19 +7511,7 @@
                 <a:cs typeface="Manrope"/>
                 <a:sym typeface="Manrope"/>
               </a:rPr>
-              <a:t>Additional Details/Future Development (if any)</a:t>
-            </a:r>
-            <a:r>
-              <a:rPr b="1" lang="en-GB" sz="1700">
-                <a:solidFill>
-                  <a:srgbClr val="202729"/>
-                </a:solidFill>
-                <a:latin typeface="Manrope"/>
-                <a:ea typeface="Manrope"/>
-                <a:cs typeface="Manrope"/>
-                <a:sym typeface="Manrope"/>
-              </a:rPr>
-              <a:t>:</a:t>
+              <a:t>Additional Details/Future Development (if any):</a:t>
             </a:r>
             <a:endParaRPr>
               <a:solidFill>
@@ -7380,11 +7534,11 @@
 </file>
 
 <file path=ppt/slides/slide13.xml><?xml version="1.0" encoding="utf-8"?>
-<p:sld xmlns:a="http://schemas.openxmlformats.org/drawingml/2006/main" xmlns:r="http://schemas.openxmlformats.org/officeDocument/2006/relationships" xmlns:mc="http://schemas.openxmlformats.org/markup-compatibility/2006" xmlns:mv="urn:schemas-microsoft-com:mac:vml" xmlns:p="http://schemas.openxmlformats.org/presentationml/2006/main" xmlns:c="http://schemas.openxmlformats.org/drawingml/2006/chart" xmlns:dgm="http://schemas.openxmlformats.org/drawingml/2006/diagram" xmlns:o="urn:schemas-microsoft-com:office:office" xmlns:v="urn:schemas-microsoft-com:vml" xmlns:pvml="urn:schemas-microsoft-com:office:powerpoint" xmlns:com="http://schemas.openxmlformats.org/drawingml/2006/compatibility" xmlns:p14="http://schemas.microsoft.com/office/powerpoint/2010/main" xmlns:p15="http://schemas.microsoft.com/office/powerpoint/2012/main" xmlns:ahyp="http://schemas.microsoft.com/office/drawing/2018/hyperlinkcolor">
+<p:sld xmlns:a="http://schemas.openxmlformats.org/drawingml/2006/main" xmlns:r="http://schemas.openxmlformats.org/officeDocument/2006/relationships" xmlns:p="http://schemas.openxmlformats.org/presentationml/2006/main">
   <p:cSld>
     <p:spTree>
       <p:nvGrpSpPr>
-        <p:cNvPr id="127" name="Shape 127"/>
+        <p:cNvPr id="1" name="Shape 127"/>
         <p:cNvGrpSpPr/>
         <p:nvPr/>
       </p:nvGrpSpPr>
@@ -7406,7 +7560,7 @@
           <a:blip r:embed="rId3">
             <a:alphaModFix/>
           </a:blip>
-          <a:srcRect b="0" l="0" r="0" t="0"/>
+          <a:srcRect/>
           <a:stretch/>
         </p:blipFill>
         <p:spPr>
@@ -7443,12 +7597,12 @@
           </a:ln>
         </p:spPr>
         <p:txBody>
-          <a:bodyPr anchorCtr="0" anchor="t" bIns="91425" lIns="91425" spcFirstLastPara="1" rIns="91425" wrap="square" tIns="91425">
-            <a:normAutofit/>
+          <a:bodyPr spcFirstLastPara="1" wrap="square" lIns="91425" tIns="91425" rIns="91425" bIns="91425" anchor="t" anchorCtr="0">
+            <a:normAutofit fontScale="77500" lnSpcReduction="20000"/>
           </a:bodyPr>
           <a:lstStyle/>
           <a:p>
-            <a:pPr indent="0" lvl="0" marL="0" rtl="0" algn="l">
+            <a:pPr marL="0" lvl="0" indent="0" algn="l" rtl="0">
               <a:lnSpc>
                 <a:spcPct val="115000"/>
               </a:lnSpc>
@@ -7466,7 +7620,7 @@
               <a:buNone/>
             </a:pPr>
             <a:r>
-              <a:rPr b="1" lang="en-GB" sz="1700">
+              <a:rPr lang="en-GB" sz="1700" b="1">
                 <a:solidFill>
                   <a:srgbClr val="202729"/>
                 </a:solidFill>
@@ -7509,12 +7663,12 @@
           </a:ln>
         </p:spPr>
         <p:txBody>
-          <a:bodyPr anchorCtr="0" anchor="t" bIns="91425" lIns="91425" spcFirstLastPara="1" rIns="91425" wrap="square" tIns="91425">
+          <a:bodyPr spcFirstLastPara="1" wrap="square" lIns="91425" tIns="91425" rIns="91425" bIns="91425" anchor="t" anchorCtr="0">
             <a:normAutofit/>
           </a:bodyPr>
           <a:lstStyle/>
           <a:p>
-            <a:pPr indent="-317500" lvl="0" marL="457200" rtl="0" algn="l">
+            <a:pPr marL="457200" lvl="0" indent="-317500" algn="l" rtl="0">
               <a:lnSpc>
                 <a:spcPct val="115000"/>
               </a:lnSpc>
@@ -7554,7 +7708,7 @@
             </a:endParaRPr>
           </a:p>
           <a:p>
-            <a:pPr indent="-317500" lvl="0" marL="457200" rtl="0" algn="l">
+            <a:pPr marL="457200" lvl="0" indent="-317500" algn="l" rtl="0">
               <a:lnSpc>
                 <a:spcPct val="115000"/>
               </a:lnSpc>
@@ -7583,7 +7737,7 @@
               </a:rPr>
               <a:t>Demo Video Link (Max: 3 Minutes)</a:t>
             </a:r>
-            <a:endParaRPr b="1" sz="1700">
+            <a:endParaRPr sz="1700" b="1">
               <a:solidFill>
                 <a:srgbClr val="202729"/>
               </a:solidFill>
@@ -7604,11 +7758,11 @@
 </file>
 
 <file path=ppt/slides/slide14.xml><?xml version="1.0" encoding="utf-8"?>
-<p:sld xmlns:a="http://schemas.openxmlformats.org/drawingml/2006/main" xmlns:r="http://schemas.openxmlformats.org/officeDocument/2006/relationships" xmlns:mc="http://schemas.openxmlformats.org/markup-compatibility/2006" xmlns:mv="urn:schemas-microsoft-com:mac:vml" xmlns:p="http://schemas.openxmlformats.org/presentationml/2006/main" xmlns:c="http://schemas.openxmlformats.org/drawingml/2006/chart" xmlns:dgm="http://schemas.openxmlformats.org/drawingml/2006/diagram" xmlns:o="urn:schemas-microsoft-com:office:office" xmlns:v="urn:schemas-microsoft-com:vml" xmlns:pvml="urn:schemas-microsoft-com:office:powerpoint" xmlns:com="http://schemas.openxmlformats.org/drawingml/2006/compatibility" xmlns:p14="http://schemas.microsoft.com/office/powerpoint/2010/main" xmlns:p15="http://schemas.microsoft.com/office/powerpoint/2012/main" xmlns:ahyp="http://schemas.microsoft.com/office/drawing/2018/hyperlinkcolor">
+<p:sld xmlns:a="http://schemas.openxmlformats.org/drawingml/2006/main" xmlns:r="http://schemas.openxmlformats.org/officeDocument/2006/relationships" xmlns:p="http://schemas.openxmlformats.org/presentationml/2006/main">
   <p:cSld>
     <p:spTree>
       <p:nvGrpSpPr>
-        <p:cNvPr id="134" name="Shape 134"/>
+        <p:cNvPr id="1" name="Shape 134"/>
         <p:cNvGrpSpPr/>
         <p:nvPr/>
       </p:nvGrpSpPr>
@@ -7630,7 +7784,7 @@
           <a:blip r:embed="rId3">
             <a:alphaModFix/>
           </a:blip>
-          <a:srcRect b="0" l="0" r="0" t="0"/>
+          <a:srcRect/>
           <a:stretch/>
         </p:blipFill>
         <p:spPr>
@@ -7656,11 +7810,11 @@
 </file>
 
 <file path=ppt/slides/slide2.xml><?xml version="1.0" encoding="utf-8"?>
-<p:sld xmlns:a="http://schemas.openxmlformats.org/drawingml/2006/main" xmlns:r="http://schemas.openxmlformats.org/officeDocument/2006/relationships" xmlns:mc="http://schemas.openxmlformats.org/markup-compatibility/2006" xmlns:mv="urn:schemas-microsoft-com:mac:vml" xmlns:p="http://schemas.openxmlformats.org/presentationml/2006/main" xmlns:c="http://schemas.openxmlformats.org/drawingml/2006/chart" xmlns:dgm="http://schemas.openxmlformats.org/drawingml/2006/diagram" xmlns:o="urn:schemas-microsoft-com:office:office" xmlns:v="urn:schemas-microsoft-com:vml" xmlns:pvml="urn:schemas-microsoft-com:office:powerpoint" xmlns:com="http://schemas.openxmlformats.org/drawingml/2006/compatibility" xmlns:p14="http://schemas.microsoft.com/office/powerpoint/2010/main" xmlns:p15="http://schemas.microsoft.com/office/powerpoint/2012/main" xmlns:ahyp="http://schemas.microsoft.com/office/drawing/2018/hyperlinkcolor">
+<p:sld xmlns:a="http://schemas.openxmlformats.org/drawingml/2006/main" xmlns:r="http://schemas.openxmlformats.org/officeDocument/2006/relationships" xmlns:p="http://schemas.openxmlformats.org/presentationml/2006/main">
   <p:cSld>
     <p:spTree>
       <p:nvGrpSpPr>
-        <p:cNvPr id="61" name="Shape 61"/>
+        <p:cNvPr id="1" name="Shape 61"/>
         <p:cNvGrpSpPr/>
         <p:nvPr/>
       </p:nvGrpSpPr>
@@ -7682,7 +7836,7 @@
           <a:blip r:embed="rId3">
             <a:alphaModFix/>
           </a:blip>
-          <a:srcRect b="0" l="0" r="0" t="0"/>
+          <a:srcRect/>
           <a:stretch/>
         </p:blipFill>
         <p:spPr>
@@ -7719,12 +7873,12 @@
           </a:ln>
         </p:spPr>
         <p:txBody>
-          <a:bodyPr anchorCtr="0" anchor="t" bIns="91425" lIns="91425" spcFirstLastPara="1" rIns="91425" wrap="square" tIns="91425">
-            <a:normAutofit/>
+          <a:bodyPr spcFirstLastPara="1" wrap="square" lIns="91425" tIns="91425" rIns="91425" bIns="91425" anchor="t" anchorCtr="0">
+            <a:normAutofit fontScale="55000" lnSpcReduction="20000"/>
           </a:bodyPr>
           <a:lstStyle/>
           <a:p>
-            <a:pPr indent="0" lvl="0" marL="0" rtl="0" algn="l">
+            <a:pPr marL="0" lvl="0" indent="0" algn="l" rtl="0">
               <a:lnSpc>
                 <a:spcPct val="115000"/>
               </a:lnSpc>
@@ -7738,7 +7892,7 @@
               <a:buNone/>
             </a:pPr>
             <a:r>
-              <a:rPr b="1" lang="en-GB" sz="1700">
+              <a:rPr lang="en-GB" sz="1700" b="1">
                 <a:solidFill>
                   <a:srgbClr val="202729"/>
                 </a:solidFill>
@@ -7749,7 +7903,7 @@
               </a:rPr>
               <a:t>Brief about the Idea:</a:t>
             </a:r>
-            <a:endParaRPr b="1" sz="1700">
+            <a:endParaRPr sz="1700" b="1">
               <a:solidFill>
                 <a:srgbClr val="202729"/>
               </a:solidFill>
@@ -7770,11 +7924,11 @@
 </file>
 
 <file path=ppt/slides/slide3.xml><?xml version="1.0" encoding="utf-8"?>
-<p:sld xmlns:a="http://schemas.openxmlformats.org/drawingml/2006/main" xmlns:r="http://schemas.openxmlformats.org/officeDocument/2006/relationships" xmlns:mc="http://schemas.openxmlformats.org/markup-compatibility/2006" xmlns:mv="urn:schemas-microsoft-com:mac:vml" xmlns:p="http://schemas.openxmlformats.org/presentationml/2006/main" xmlns:c="http://schemas.openxmlformats.org/drawingml/2006/chart" xmlns:dgm="http://schemas.openxmlformats.org/drawingml/2006/diagram" xmlns:o="urn:schemas-microsoft-com:office:office" xmlns:v="urn:schemas-microsoft-com:vml" xmlns:pvml="urn:schemas-microsoft-com:office:powerpoint" xmlns:com="http://schemas.openxmlformats.org/drawingml/2006/compatibility" xmlns:p14="http://schemas.microsoft.com/office/powerpoint/2010/main" xmlns:p15="http://schemas.microsoft.com/office/powerpoint/2012/main" xmlns:ahyp="http://schemas.microsoft.com/office/drawing/2018/hyperlinkcolor">
+<p:sld xmlns:a="http://schemas.openxmlformats.org/drawingml/2006/main" xmlns:r="http://schemas.openxmlformats.org/officeDocument/2006/relationships" xmlns:p="http://schemas.openxmlformats.org/presentationml/2006/main">
   <p:cSld>
     <p:spTree>
       <p:nvGrpSpPr>
-        <p:cNvPr id="67" name="Shape 67"/>
+        <p:cNvPr id="1" name="Shape 67"/>
         <p:cNvGrpSpPr/>
         <p:nvPr/>
       </p:nvGrpSpPr>
@@ -7796,7 +7950,7 @@
           <a:blip r:embed="rId3">
             <a:alphaModFix/>
           </a:blip>
-          <a:srcRect b="0" l="0" r="0" t="0"/>
+          <a:srcRect/>
           <a:stretch/>
         </p:blipFill>
         <p:spPr>
@@ -7833,12 +7987,12 @@
           </a:ln>
         </p:spPr>
         <p:txBody>
-          <a:bodyPr anchorCtr="0" anchor="t" bIns="91425" lIns="91425" spcFirstLastPara="1" rIns="91425" wrap="square" tIns="91425">
+          <a:bodyPr spcFirstLastPara="1" wrap="square" lIns="91425" tIns="91425" rIns="91425" bIns="91425" anchor="t" anchorCtr="0">
             <a:normAutofit/>
           </a:bodyPr>
           <a:lstStyle/>
           <a:p>
-            <a:pPr indent="0" lvl="0" marL="0" rtl="0" algn="l">
+            <a:pPr marL="0" lvl="0" indent="0" algn="l" rtl="0">
               <a:lnSpc>
                 <a:spcPct val="115000"/>
               </a:lnSpc>
@@ -7852,7 +8006,7 @@
               <a:buNone/>
             </a:pPr>
             <a:r>
-              <a:rPr b="1" lang="en-GB" sz="1700">
+              <a:rPr lang="en-GB" sz="1700" b="1">
                 <a:solidFill>
                   <a:srgbClr val="202729"/>
                 </a:solidFill>
@@ -7863,7 +8017,7 @@
               </a:rPr>
               <a:t>Your solution should be able to explain the following:</a:t>
             </a:r>
-            <a:endParaRPr b="1" sz="1700">
+            <a:endParaRPr sz="1700" b="1">
               <a:solidFill>
                 <a:srgbClr val="202729"/>
               </a:solidFill>
@@ -7874,7 +8028,7 @@
             </a:endParaRPr>
           </a:p>
           <a:p>
-            <a:pPr indent="-330200" lvl="0" marL="457200" rtl="0" algn="l">
+            <a:pPr marL="457200" lvl="0" indent="-330200" algn="l" rtl="0">
               <a:lnSpc>
                 <a:spcPct val="115000"/>
               </a:lnSpc>
@@ -7914,7 +8068,7 @@
             </a:endParaRPr>
           </a:p>
           <a:p>
-            <a:pPr indent="-330200" lvl="0" marL="457200" rtl="0" algn="l">
+            <a:pPr marL="457200" lvl="0" indent="-330200" algn="l" rtl="0">
               <a:lnSpc>
                 <a:spcPct val="115000"/>
               </a:lnSpc>
@@ -7954,7 +8108,7 @@
             </a:endParaRPr>
           </a:p>
           <a:p>
-            <a:pPr indent="-330200" lvl="0" marL="457200" rtl="0" algn="l">
+            <a:pPr marL="457200" lvl="0" indent="-330200" algn="l" rtl="0">
               <a:lnSpc>
                 <a:spcPct val="115000"/>
               </a:lnSpc>
@@ -7994,7 +8148,7 @@
             </a:endParaRPr>
           </a:p>
           <a:p>
-            <a:pPr indent="0" lvl="0" marL="0" rtl="0" algn="l">
+            <a:pPr marL="0" lvl="0" indent="0" algn="l" rtl="0">
               <a:lnSpc>
                 <a:spcPct val="115000"/>
               </a:lnSpc>
@@ -8007,9 +8161,6 @@
               <a:buSzPts val="935"/>
               <a:buNone/>
             </a:pPr>
-            <a:r>
-              <a:t/>
-            </a:r>
             <a:endParaRPr sz="1600">
               <a:solidFill>
                 <a:srgbClr val="202729"/>
@@ -8031,11 +8182,11 @@
 </file>
 
 <file path=ppt/slides/slide4.xml><?xml version="1.0" encoding="utf-8"?>
-<p:sld xmlns:a="http://schemas.openxmlformats.org/drawingml/2006/main" xmlns:r="http://schemas.openxmlformats.org/officeDocument/2006/relationships" xmlns:mc="http://schemas.openxmlformats.org/markup-compatibility/2006" xmlns:mv="urn:schemas-microsoft-com:mac:vml" xmlns:p="http://schemas.openxmlformats.org/presentationml/2006/main" xmlns:c="http://schemas.openxmlformats.org/drawingml/2006/chart" xmlns:dgm="http://schemas.openxmlformats.org/drawingml/2006/diagram" xmlns:o="urn:schemas-microsoft-com:office:office" xmlns:v="urn:schemas-microsoft-com:vml" xmlns:pvml="urn:schemas-microsoft-com:office:powerpoint" xmlns:com="http://schemas.openxmlformats.org/drawingml/2006/compatibility" xmlns:p14="http://schemas.microsoft.com/office/powerpoint/2010/main" xmlns:p15="http://schemas.microsoft.com/office/powerpoint/2012/main" xmlns:ahyp="http://schemas.microsoft.com/office/drawing/2018/hyperlinkcolor">
+<p:sld xmlns:a="http://schemas.openxmlformats.org/drawingml/2006/main" xmlns:r="http://schemas.openxmlformats.org/officeDocument/2006/relationships" xmlns:p="http://schemas.openxmlformats.org/presentationml/2006/main">
   <p:cSld>
     <p:spTree>
       <p:nvGrpSpPr>
-        <p:cNvPr id="73" name="Shape 73"/>
+        <p:cNvPr id="1" name="Shape 73"/>
         <p:cNvGrpSpPr/>
         <p:nvPr/>
       </p:nvGrpSpPr>
@@ -8057,7 +8208,7 @@
           <a:blip r:embed="rId3">
             <a:alphaModFix/>
           </a:blip>
-          <a:srcRect b="0" l="0" r="0" t="0"/>
+          <a:srcRect/>
           <a:stretch/>
         </p:blipFill>
         <p:spPr>
@@ -8094,12 +8245,12 @@
           </a:ln>
         </p:spPr>
         <p:txBody>
-          <a:bodyPr anchorCtr="0" anchor="t" bIns="91425" lIns="91425" spcFirstLastPara="1" rIns="91425" wrap="square" tIns="91425">
+          <a:bodyPr spcFirstLastPara="1" wrap="square" lIns="91425" tIns="91425" rIns="91425" bIns="91425" anchor="t" anchorCtr="0">
             <a:normAutofit/>
           </a:bodyPr>
           <a:lstStyle/>
           <a:p>
-            <a:pPr indent="0" lvl="0" marL="0" rtl="0" algn="l">
+            <a:pPr marL="0" lvl="0" indent="0" algn="l" rtl="0">
               <a:lnSpc>
                 <a:spcPct val="115000"/>
               </a:lnSpc>
@@ -8113,7 +8264,7 @@
               <a:buNone/>
             </a:pPr>
             <a:r>
-              <a:rPr b="1" lang="en-GB" sz="1700">
+              <a:rPr lang="en-GB" sz="1700" b="1">
                 <a:solidFill>
                   <a:srgbClr val="202729"/>
                 </a:solidFill>
@@ -8124,7 +8275,7 @@
               </a:rPr>
               <a:t>List of features offered by the solution</a:t>
             </a:r>
-            <a:endParaRPr b="1" sz="1700">
+            <a:endParaRPr sz="1700" b="1">
               <a:solidFill>
                 <a:srgbClr val="202729"/>
               </a:solidFill>
@@ -8135,7 +8286,7 @@
             </a:endParaRPr>
           </a:p>
           <a:p>
-            <a:pPr indent="0" lvl="0" marL="0" rtl="0" algn="l">
+            <a:pPr marL="0" lvl="0" indent="0" algn="l" rtl="0">
               <a:lnSpc>
                 <a:spcPct val="115000"/>
               </a:lnSpc>
@@ -8181,11 +8332,11 @@
 </file>
 
 <file path=ppt/slides/slide5.xml><?xml version="1.0" encoding="utf-8"?>
-<p:sld xmlns:a="http://schemas.openxmlformats.org/drawingml/2006/main" xmlns:r="http://schemas.openxmlformats.org/officeDocument/2006/relationships" xmlns:mc="http://schemas.openxmlformats.org/markup-compatibility/2006" xmlns:mv="urn:schemas-microsoft-com:mac:vml" xmlns:p="http://schemas.openxmlformats.org/presentationml/2006/main" xmlns:c="http://schemas.openxmlformats.org/drawingml/2006/chart" xmlns:dgm="http://schemas.openxmlformats.org/drawingml/2006/diagram" xmlns:o="urn:schemas-microsoft-com:office:office" xmlns:v="urn:schemas-microsoft-com:vml" xmlns:pvml="urn:schemas-microsoft-com:office:powerpoint" xmlns:com="http://schemas.openxmlformats.org/drawingml/2006/compatibility" xmlns:p14="http://schemas.microsoft.com/office/powerpoint/2010/main" xmlns:p15="http://schemas.microsoft.com/office/powerpoint/2012/main" xmlns:ahyp="http://schemas.microsoft.com/office/drawing/2018/hyperlinkcolor">
+<p:sld xmlns:a="http://schemas.openxmlformats.org/drawingml/2006/main" xmlns:r="http://schemas.openxmlformats.org/officeDocument/2006/relationships" xmlns:p="http://schemas.openxmlformats.org/presentationml/2006/main">
   <p:cSld>
     <p:spTree>
       <p:nvGrpSpPr>
-        <p:cNvPr id="79" name="Shape 79"/>
+        <p:cNvPr id="1" name="Shape 79"/>
         <p:cNvGrpSpPr/>
         <p:nvPr/>
       </p:nvGrpSpPr>
@@ -8207,7 +8358,7 @@
           <a:blip r:embed="rId3">
             <a:alphaModFix/>
           </a:blip>
-          <a:srcRect b="0" l="0" r="0" t="0"/>
+          <a:srcRect/>
           <a:stretch/>
         </p:blipFill>
         <p:spPr>
@@ -8244,12 +8395,12 @@
           </a:ln>
         </p:spPr>
         <p:txBody>
-          <a:bodyPr anchorCtr="0" anchor="t" bIns="91425" lIns="91425" spcFirstLastPara="1" rIns="91425" wrap="square" tIns="91425">
+          <a:bodyPr spcFirstLastPara="1" wrap="square" lIns="91425" tIns="91425" rIns="91425" bIns="91425" anchor="t" anchorCtr="0">
             <a:normAutofit/>
           </a:bodyPr>
           <a:lstStyle/>
           <a:p>
-            <a:pPr indent="0" lvl="0" marL="0" rtl="0" algn="l">
+            <a:pPr marL="0" lvl="0" indent="0" algn="l" rtl="0">
               <a:lnSpc>
                 <a:spcPct val="115000"/>
               </a:lnSpc>
@@ -8263,7 +8414,7 @@
               <a:buNone/>
             </a:pPr>
             <a:r>
-              <a:rPr b="1" lang="en-GB" sz="1700">
+              <a:rPr lang="en-GB" sz="1700" b="1">
                 <a:solidFill>
                   <a:srgbClr val="202729"/>
                 </a:solidFill>
@@ -8274,7 +8425,7 @@
               </a:rPr>
               <a:t>Process flow diagram or Use-case diagram</a:t>
             </a:r>
-            <a:endParaRPr b="1" sz="1700">
+            <a:endParaRPr sz="1700" b="1">
               <a:solidFill>
                 <a:srgbClr val="202729"/>
               </a:solidFill>
@@ -8285,7 +8436,7 @@
             </a:endParaRPr>
           </a:p>
           <a:p>
-            <a:pPr indent="0" lvl="0" marL="0" rtl="0" algn="l">
+            <a:pPr marL="0" lvl="0" indent="0" algn="l" rtl="0">
               <a:lnSpc>
                 <a:spcPct val="115000"/>
               </a:lnSpc>
@@ -8331,11 +8482,11 @@
 </file>
 
 <file path=ppt/slides/slide6.xml><?xml version="1.0" encoding="utf-8"?>
-<p:sld xmlns:a="http://schemas.openxmlformats.org/drawingml/2006/main" xmlns:r="http://schemas.openxmlformats.org/officeDocument/2006/relationships" xmlns:mc="http://schemas.openxmlformats.org/markup-compatibility/2006" xmlns:mv="urn:schemas-microsoft-com:mac:vml" xmlns:p="http://schemas.openxmlformats.org/presentationml/2006/main" xmlns:c="http://schemas.openxmlformats.org/drawingml/2006/chart" xmlns:dgm="http://schemas.openxmlformats.org/drawingml/2006/diagram" xmlns:o="urn:schemas-microsoft-com:office:office" xmlns:v="urn:schemas-microsoft-com:vml" xmlns:pvml="urn:schemas-microsoft-com:office:powerpoint" xmlns:com="http://schemas.openxmlformats.org/drawingml/2006/compatibility" xmlns:p14="http://schemas.microsoft.com/office/powerpoint/2010/main" xmlns:p15="http://schemas.microsoft.com/office/powerpoint/2012/main" xmlns:ahyp="http://schemas.microsoft.com/office/drawing/2018/hyperlinkcolor">
+<p:sld xmlns:a="http://schemas.openxmlformats.org/drawingml/2006/main" xmlns:r="http://schemas.openxmlformats.org/officeDocument/2006/relationships" xmlns:p="http://schemas.openxmlformats.org/presentationml/2006/main">
   <p:cSld>
     <p:spTree>
       <p:nvGrpSpPr>
-        <p:cNvPr id="85" name="Shape 85"/>
+        <p:cNvPr id="1" name="Shape 85"/>
         <p:cNvGrpSpPr/>
         <p:nvPr/>
       </p:nvGrpSpPr>
@@ -8357,7 +8508,7 @@
           <a:blip r:embed="rId3">
             <a:alphaModFix/>
           </a:blip>
-          <a:srcRect b="0" l="0" r="0" t="0"/>
+          <a:srcRect/>
           <a:stretch/>
         </p:blipFill>
         <p:spPr>
@@ -8394,12 +8545,12 @@
           </a:ln>
         </p:spPr>
         <p:txBody>
-          <a:bodyPr anchorCtr="0" anchor="t" bIns="91425" lIns="91425" spcFirstLastPara="1" rIns="91425" wrap="square" tIns="91425">
+          <a:bodyPr spcFirstLastPara="1" wrap="square" lIns="91425" tIns="91425" rIns="91425" bIns="91425" anchor="t" anchorCtr="0">
             <a:normAutofit/>
           </a:bodyPr>
           <a:lstStyle/>
           <a:p>
-            <a:pPr indent="0" lvl="0" marL="0" rtl="0" algn="l">
+            <a:pPr marL="0" lvl="0" indent="0" algn="l" rtl="0">
               <a:lnSpc>
                 <a:spcPct val="115000"/>
               </a:lnSpc>
@@ -8413,7 +8564,7 @@
               <a:buNone/>
             </a:pPr>
             <a:r>
-              <a:rPr b="1" lang="en-GB" sz="1700">
+              <a:rPr lang="en-GB" sz="1700" b="1">
                 <a:solidFill>
                   <a:srgbClr val="202729"/>
                 </a:solidFill>
@@ -8445,11 +8596,11 @@
 </file>
 
 <file path=ppt/slides/slide7.xml><?xml version="1.0" encoding="utf-8"?>
-<p:sld xmlns:a="http://schemas.openxmlformats.org/drawingml/2006/main" xmlns:r="http://schemas.openxmlformats.org/officeDocument/2006/relationships" xmlns:mc="http://schemas.openxmlformats.org/markup-compatibility/2006" xmlns:mv="urn:schemas-microsoft-com:mac:vml" xmlns:p="http://schemas.openxmlformats.org/presentationml/2006/main" xmlns:c="http://schemas.openxmlformats.org/drawingml/2006/chart" xmlns:dgm="http://schemas.openxmlformats.org/drawingml/2006/diagram" xmlns:o="urn:schemas-microsoft-com:office:office" xmlns:v="urn:schemas-microsoft-com:vml" xmlns:pvml="urn:schemas-microsoft-com:office:powerpoint" xmlns:com="http://schemas.openxmlformats.org/drawingml/2006/compatibility" xmlns:p14="http://schemas.microsoft.com/office/powerpoint/2010/main" xmlns:p15="http://schemas.microsoft.com/office/powerpoint/2012/main" xmlns:ahyp="http://schemas.microsoft.com/office/drawing/2018/hyperlinkcolor">
+<p:sld xmlns:a="http://schemas.openxmlformats.org/drawingml/2006/main" xmlns:r="http://schemas.openxmlformats.org/officeDocument/2006/relationships" xmlns:p="http://schemas.openxmlformats.org/presentationml/2006/main">
   <p:cSld>
     <p:spTree>
       <p:nvGrpSpPr>
-        <p:cNvPr id="91" name="Shape 91"/>
+        <p:cNvPr id="1" name="Shape 91"/>
         <p:cNvGrpSpPr/>
         <p:nvPr/>
       </p:nvGrpSpPr>
@@ -8471,7 +8622,7 @@
           <a:blip r:embed="rId3">
             <a:alphaModFix/>
           </a:blip>
-          <a:srcRect b="0" l="0" r="0" t="0"/>
+          <a:srcRect/>
           <a:stretch/>
         </p:blipFill>
         <p:spPr>
@@ -8508,12 +8659,12 @@
           </a:ln>
         </p:spPr>
         <p:txBody>
-          <a:bodyPr anchorCtr="0" anchor="t" bIns="91425" lIns="91425" spcFirstLastPara="1" rIns="91425" wrap="square" tIns="91425">
+          <a:bodyPr spcFirstLastPara="1" wrap="square" lIns="91425" tIns="91425" rIns="91425" bIns="91425" anchor="t" anchorCtr="0">
             <a:normAutofit/>
           </a:bodyPr>
           <a:lstStyle/>
           <a:p>
-            <a:pPr indent="0" lvl="0" marL="0" rtl="0" algn="l">
+            <a:pPr marL="0" lvl="0" indent="0" algn="l" rtl="0">
               <a:lnSpc>
                 <a:spcPct val="115000"/>
               </a:lnSpc>
@@ -8527,7 +8678,7 @@
               <a:buNone/>
             </a:pPr>
             <a:r>
-              <a:rPr b="1" lang="en-GB" sz="1700">
+              <a:rPr lang="en-GB" sz="1700" b="1">
                 <a:solidFill>
                   <a:srgbClr val="202729"/>
                 </a:solidFill>
@@ -8559,11 +8710,11 @@
 </file>
 
 <file path=ppt/slides/slide8.xml><?xml version="1.0" encoding="utf-8"?>
-<p:sld xmlns:a="http://schemas.openxmlformats.org/drawingml/2006/main" xmlns:r="http://schemas.openxmlformats.org/officeDocument/2006/relationships" xmlns:mc="http://schemas.openxmlformats.org/markup-compatibility/2006" xmlns:mv="urn:schemas-microsoft-com:mac:vml" xmlns:p="http://schemas.openxmlformats.org/presentationml/2006/main" xmlns:c="http://schemas.openxmlformats.org/drawingml/2006/chart" xmlns:dgm="http://schemas.openxmlformats.org/drawingml/2006/diagram" xmlns:o="urn:schemas-microsoft-com:office:office" xmlns:v="urn:schemas-microsoft-com:vml" xmlns:pvml="urn:schemas-microsoft-com:office:powerpoint" xmlns:com="http://schemas.openxmlformats.org/drawingml/2006/compatibility" xmlns:p14="http://schemas.microsoft.com/office/powerpoint/2010/main" xmlns:p15="http://schemas.microsoft.com/office/powerpoint/2012/main" xmlns:ahyp="http://schemas.microsoft.com/office/drawing/2018/hyperlinkcolor">
+<p:sld xmlns:a="http://schemas.openxmlformats.org/drawingml/2006/main" xmlns:r="http://schemas.openxmlformats.org/officeDocument/2006/relationships" xmlns:p="http://schemas.openxmlformats.org/presentationml/2006/main">
   <p:cSld>
     <p:spTree>
       <p:nvGrpSpPr>
-        <p:cNvPr id="97" name="Shape 97"/>
+        <p:cNvPr id="1" name="Shape 97"/>
         <p:cNvGrpSpPr/>
         <p:nvPr/>
       </p:nvGrpSpPr>
@@ -8585,7 +8736,7 @@
           <a:blip r:embed="rId3">
             <a:alphaModFix/>
           </a:blip>
-          <a:srcRect b="0" l="0" r="0" t="0"/>
+          <a:srcRect/>
           <a:stretch/>
         </p:blipFill>
         <p:spPr>
@@ -8622,12 +8773,12 @@
           </a:ln>
         </p:spPr>
         <p:txBody>
-          <a:bodyPr anchorCtr="0" anchor="t" bIns="91425" lIns="91425" spcFirstLastPara="1" rIns="91425" wrap="square" tIns="91425">
+          <a:bodyPr spcFirstLastPara="1" wrap="square" lIns="91425" tIns="91425" rIns="91425" bIns="91425" anchor="t" anchorCtr="0">
             <a:normAutofit/>
           </a:bodyPr>
           <a:lstStyle/>
           <a:p>
-            <a:pPr indent="0" lvl="0" marL="0" rtl="0" algn="l">
+            <a:pPr marL="0" lvl="0" indent="0" algn="l" rtl="0">
               <a:lnSpc>
                 <a:spcPct val="115000"/>
               </a:lnSpc>
@@ -8641,7 +8792,7 @@
               <a:buNone/>
             </a:pPr>
             <a:r>
-              <a:rPr b="1" lang="en-GB" sz="1700">
+              <a:rPr lang="en-GB" sz="1700" b="1">
                 <a:solidFill>
                   <a:srgbClr val="202729"/>
                 </a:solidFill>
@@ -8673,11 +8824,11 @@
 </file>
 
 <file path=ppt/slides/slide9.xml><?xml version="1.0" encoding="utf-8"?>
-<p:sld xmlns:a="http://schemas.openxmlformats.org/drawingml/2006/main" xmlns:r="http://schemas.openxmlformats.org/officeDocument/2006/relationships" xmlns:mc="http://schemas.openxmlformats.org/markup-compatibility/2006" xmlns:mv="urn:schemas-microsoft-com:mac:vml" xmlns:p="http://schemas.openxmlformats.org/presentationml/2006/main" xmlns:c="http://schemas.openxmlformats.org/drawingml/2006/chart" xmlns:dgm="http://schemas.openxmlformats.org/drawingml/2006/diagram" xmlns:o="urn:schemas-microsoft-com:office:office" xmlns:v="urn:schemas-microsoft-com:vml" xmlns:pvml="urn:schemas-microsoft-com:office:powerpoint" xmlns:com="http://schemas.openxmlformats.org/drawingml/2006/compatibility" xmlns:p14="http://schemas.microsoft.com/office/powerpoint/2010/main" xmlns:p15="http://schemas.microsoft.com/office/powerpoint/2012/main" xmlns:ahyp="http://schemas.microsoft.com/office/drawing/2018/hyperlinkcolor">
+<p:sld xmlns:a="http://schemas.openxmlformats.org/drawingml/2006/main" xmlns:r="http://schemas.openxmlformats.org/officeDocument/2006/relationships" xmlns:p="http://schemas.openxmlformats.org/presentationml/2006/main">
   <p:cSld>
     <p:spTree>
       <p:nvGrpSpPr>
-        <p:cNvPr id="103" name="Shape 103"/>
+        <p:cNvPr id="1" name="Shape 103"/>
         <p:cNvGrpSpPr/>
         <p:nvPr/>
       </p:nvGrpSpPr>
@@ -8699,7 +8850,7 @@
           <a:blip r:embed="rId3">
             <a:alphaModFix/>
           </a:blip>
-          <a:srcRect b="0" l="0" r="0" t="0"/>
+          <a:srcRect/>
           <a:stretch/>
         </p:blipFill>
         <p:spPr>
@@ -8736,12 +8887,12 @@
           </a:ln>
         </p:spPr>
         <p:txBody>
-          <a:bodyPr anchorCtr="0" anchor="t" bIns="91425" lIns="91425" spcFirstLastPara="1" rIns="91425" wrap="square" tIns="91425">
+          <a:bodyPr spcFirstLastPara="1" wrap="square" lIns="91425" tIns="91425" rIns="91425" bIns="91425" anchor="t" anchorCtr="0">
             <a:normAutofit/>
           </a:bodyPr>
           <a:lstStyle/>
           <a:p>
-            <a:pPr indent="0" lvl="0" marL="0" rtl="0" algn="l">
+            <a:pPr marL="0" lvl="0" indent="0" algn="l" rtl="0">
               <a:lnSpc>
                 <a:spcPct val="115000"/>
               </a:lnSpc>
@@ -8755,7 +8906,7 @@
               <a:buNone/>
             </a:pPr>
             <a:r>
-              <a:rPr b="1" lang="en-GB" sz="1700">
+              <a:rPr lang="en-GB" sz="1700" b="1">
                 <a:solidFill>
                   <a:srgbClr val="202729"/>
                 </a:solidFill>
@@ -8787,7 +8938,7 @@
 </file>
 
 <file path=ppt/theme/theme1.xml><?xml version="1.0" encoding="utf-8"?>
-<a:theme xmlns:a="http://schemas.openxmlformats.org/drawingml/2006/main" xmlns:r="http://schemas.openxmlformats.org/officeDocument/2006/relationships" name="Simple Light">
+<a:theme xmlns:a="http://schemas.openxmlformats.org/drawingml/2006/main" name="Simple Light">
   <a:themeElements>
     <a:clrScheme name="Simple Light">
       <a:dk1>
@@ -9062,11 +9213,13 @@
       </a:bgFillStyleLst>
     </a:fmtScheme>
   </a:themeElements>
+  <a:objectDefaults/>
+  <a:extraClrSchemeLst/>
 </a:theme>
 </file>
 
 <file path=ppt/theme/theme2.xml><?xml version="1.0" encoding="utf-8"?>
-<a:theme xmlns:a="http://schemas.openxmlformats.org/drawingml/2006/main" xmlns:r="http://schemas.openxmlformats.org/officeDocument/2006/relationships">
+<a:theme xmlns:a="http://schemas.openxmlformats.org/drawingml/2006/main">
   <a:themeElements>
     <a:clrScheme name="Default">
       <a:dk1>
@@ -9341,5 +9494,7 @@
       </a:bgFillStyleLst>
     </a:fmtScheme>
   </a:themeElements>
+  <a:objectDefaults/>
+  <a:extraClrSchemeLst/>
 </a:theme>
 </file>
</xml_diff>